<commit_message>
Path planning jadi pre-defined map by index (usulan dosen): charter, docx, deck, naskah
Peta grid 4x4 berindeks 1-16 ditentukan di awal; aksi per indeks lewat blok
+ rute terpendek otomatis (BFS). Robot tidak menjelajah.

Co-Authored-By: Claude Opus 5.5 <noreply@anthropic.com>
Claude-Session: https://claude.ai/code/session_0155yf5wpAX58VAfqTZWuQQK
</commit_message>
<xml_diff>
--- a/docs/pitching-rab/LFM_Pitching_RAB_P01-5.pptx
+++ b/docs/pitching-rab/LFM_Pitching_RAB_P01-5.pptx
@@ -124,13 +124,13 @@
   <p:extLst>
     <p:ext uri="{521415D9-36F7-43E2-AB2F-B90AF26B5E84}">
       <p14:sectionLst xmlns:p14="http://schemas.microsoft.com/office/powerpoint/2010/main">
-        <p14:section name="Pembuka" id="{cee92f85-977e-7054-5f48-87c8b83e0010}">
+        <p14:section name="Pembuka" id="{49bb51d3-fb84-70f2-650a-9ce0917e2337}">
           <p14:sldIdLst>
             <p14:sldId id="256"/>
             <p14:sldId id="257"/>
           </p14:sldIdLst>
         </p14:section>
-        <p14:section name="Masalah dan solusi" id="{20dd998a-42cd-9e99-3b18-ddf2233e5280}">
+        <p14:section name="Masalah dan solusi" id="{4db6033c-5584-707e-3988-a9c6e5288e2c}">
           <p14:sldIdLst>
             <p14:sldId id="258"/>
             <p14:sldId id="259"/>
@@ -138,7 +138,7 @@
             <p14:sldId id="261"/>
           </p14:sldIdLst>
         </p14:section>
-        <p14:section name="Rancangan" id="{a48c67e6-4b50-0201-de87-a755ba8d1001}">
+        <p14:section name="Rancangan" id="{abc80518-d4d1-8665-4e3a-959be0eb3bde}">
           <p14:sldIdLst>
             <p14:sldId id="262"/>
             <p14:sldId id="263"/>
@@ -146,20 +146,20 @@
             <p14:sldId id="265"/>
           </p14:sldIdLst>
         </p14:section>
-        <p14:section name="Anggaran" id="{2bcb6cea-a19d-f6d1-3559-34944a47fc42}">
+        <p14:section name="Anggaran" id="{88d04877-1f35-9150-dcc1-75b714fd5407}">
           <p14:sldIdLst>
             <p14:sldId id="266"/>
             <p14:sldId id="267"/>
             <p14:sldId id="268"/>
           </p14:sldIdLst>
         </p14:section>
-        <p14:section name="Penutup" id="{1687b07e-5093-6d1f-33c8-a0835592e9fc}">
+        <p14:section name="Penutup" id="{2c363029-8fa9-72be-7de8-8840503c9675}">
           <p14:sldIdLst>
             <p14:sldId id="269"/>
             <p14:sldId id="270"/>
           </p14:sldIdLst>
         </p14:section>
-        <p14:section name="Lampiran" id="{2ee84095-35f7-e1db-1aa7-e10194935547}">
+        <p14:section name="Lampiran" id="{8cec365f-737e-262c-af85-5cebb8a58eab}">
           <p14:sldIdLst>
             <p14:sldId id="271"/>
             <p14:sldId id="272"/>
@@ -2426,7 +2426,7 @@
           <a:p>
             <a:r>
               <a:rPr lang="en-US" dirty="0"/>
-              <a:t>Solusi kami empat fitur utama: ikut garis dengan PID, path planning di grid, block coding berbasis web, dan fitur keamanan. Biayanya sekitar 45 persen harga kit pembanding.</a:t>
+              <a:t>Solusi kami empat fitur utama: ikut garis dengan PID, path planning dengan peta grid yang ditentukan di awal (per indeks persimpangan), block coding berbasis web, dan fitur keamanan. Biayanya sekitar 45 persen harga kit pembanding.</a:t>
             </a:r>
             <a:endParaRPr lang="en-US" dirty="0"/>
           </a:p>
@@ -2514,7 +2514,7 @@
           <a:p>
             <a:r>
               <a:rPr lang="en-US" dirty="0"/>
-              <a:t>Tabel reverse engineering: fungsi utama kit dipertahankan (12 sensor, OLED), komponen yang mahal atau kurang cocok untuk edukasi diganti, path planning ditambahkan, fitur lomba ditiadakan. Kinerja nyata kit akan diukur di lintasan yang sama.</a:t>
+              <a:t>Tabel reverse engineering: fungsi utama kit dipertahankan (12 sensor, OLED), komponen yang mahal atau kurang cocok untuk edukasi diganti. Path planning di kit disusun per indeks lewat mBlock; kami pakai cara yang sama ditambah rute terpendek otomatis dari peta indeks. Fitur lomba ditiadakan. Kinerja nyata kit akan diukur di lintasan yang sama.</a:t>
             </a:r>
             <a:endParaRPr lang="en-US" dirty="0"/>
           </a:p>
@@ -2778,7 +2778,7 @@
           <a:p>
             <a:r>
               <a:rPr lang="en-US" dirty="0"/>
-              <a:t>Kendali loop tertutup: posisi garis diumpankan ke PID. Encoder dipakai untuk jarak dan belok 90 derajat. Path planning: lintasan grid 4x4 dipetakan sebagai graf, lalu rute terpendek dihitung dengan BFS atau Dijkstra.</a:t>
+              <a:t>Kendali loop tertutup: posisi garis diumpankan ke PID. Encoder dipakai untuk jarak dan belok 90 derajat. Path planning memakai peta yang ditentukan di awal (pre-defined map by index, usulan Bu Fira): tiap persimpangan grid diberi nomor 1 sampai 16. Robot menghitung persimpangan yang dilewati dan menjalankan aksi untuk tiap indeks: belok kiri, belok kanan, lurus, atau berhenti. Aksinya bisa disusun siswa lewat blok seperti di Ichiduino, atau dihitung otomatis sebagai rute terpendek (BFS) dari peta yang sama. Robot tidak perlu menjelajah dulu, jadi lebih cepat dikerjakan dan diuji.</a:t>
             </a:r>
             <a:endParaRPr lang="en-US" dirty="0"/>
           </a:p>
@@ -15936,7 +15936,7 @@
                   <a:schemeClr val="bg1"/>
                 </a:solidFill>
               </a:rPr>
-              <a:t>Persimpangan grid disimpan sebagai graf, robot menjalankan rute terpendek</a:t>
+              <a:t>Peta grid ditentukan di awal (indeks); rute per indeks atau rute terpendek otomatis</a:t>
             </a:r>
             <a:endParaRPr lang="en-US" sz="1600" dirty="0"/>
           </a:p>
@@ -18223,7 +18223,7 @@
                             <a:schemeClr val="bg1"/>
                           </a:solidFill>
                         </a:rPr>
-                        <a:t>tidak disebut di brosur</a:t>
+                        <a:t>aksi per indeks lewat mBlock</a:t>
                       </a:r>
                       <a:endParaRPr lang="en-US" sz="1400" dirty="0"/>
                     </a:p>
@@ -18284,7 +18284,7 @@
                             <a:schemeClr val="bg1"/>
                           </a:solidFill>
                         </a:rPr>
-                        <a:t>grid 4 × 4, rute terpendek</a:t>
+                        <a:t>peta indeks + rute terpendek otomatis</a:t>
                       </a:r>
                       <a:endParaRPr lang="en-US" sz="1400" dirty="0"/>
                     </a:p>
@@ -18345,7 +18345,7 @@
                             <a:schemeClr val="accent2"/>
                           </a:solidFill>
                         </a:rPr>
-                        <a:t>ditambah</a:t>
+                        <a:t>dikembangkan</a:t>
                       </a:r>
                       <a:endParaRPr lang="en-US" sz="1400" dirty="0"/>
                     </a:p>
@@ -19065,7 +19065,7 @@
                   <a:schemeClr val="bg1"/>
                 </a:solidFill>
               </a:rPr>
-              <a:t>rute terpendek benar</a:t>
+              <a:t>rute pada peta indeks dijalankan benar</a:t>
             </a:r>
             <a:endParaRPr lang="en-US" sz="2800" dirty="0"/>
           </a:p>
@@ -19642,8 +19642,8 @@
         </p:nvSpPr>
         <p:spPr>
           <a:xfrm>
-            <a:off x="1124712" y="4526280"/>
-            <a:ext cx="6766560" cy="1051560"/>
+            <a:off x="1124712" y="4480560"/>
+            <a:ext cx="6766560" cy="1143000"/>
           </a:xfrm>
           <a:prstGeom prst="rect">
             <a:avLst/>
@@ -19657,7 +19657,7 @@
           <a:p>
             <a:pPr marL="203200" indent="-203200">
               <a:spcAft>
-                <a:spcPts val="400"/>
+                <a:spcPts val="300"/>
               </a:spcAft>
               <a:buSzPct val="100000"/>
               <a:buChar char="•"/>
@@ -19675,7 +19675,7 @@
           <a:p>
             <a:pPr marL="203200" indent="-203200">
               <a:spcAft>
-                <a:spcPts val="400"/>
+                <a:spcPts val="300"/>
               </a:spcAft>
               <a:buSzPct val="100000"/>
               <a:buChar char="•"/>
@@ -19693,7 +19693,7 @@
           <a:p>
             <a:pPr marL="203200" indent="-203200">
               <a:spcAft>
-                <a:spcPts val="400"/>
+                <a:spcPts val="300"/>
               </a:spcAft>
               <a:buSzPct val="100000"/>
               <a:buChar char="•"/>
@@ -19704,7 +19704,7 @@
                   <a:schemeClr val="bg1"/>
                 </a:solidFill>
               </a:rPr>
-              <a:t>Tiap persimpangan grid = simpul graf; rute terpendek dicari dengan BFS/Dijkstra.</a:t>
+              <a:t>Peta grid ditentukan di awal (pre-defined map by index): robot menghitung persimpangan dan menjalankan aksi tiap indeks, disusun lewat blok atau rute terpendek otomatis (BFS).</a:t>
             </a:r>
             <a:endParaRPr lang="en-US" sz="1400" dirty="0"/>
           </a:p>
@@ -20354,7 +20354,511 @@
       </p:sp>
       <p:sp>
         <p:nvSpPr>
-          <p:cNvPr id="36" name="Titik S lingkaran"/>
+          <p:cNvPr id="36" name="Indeks 13"/>
+          <p:cNvSpPr txBox="1"/>
+          <p:nvPr/>
+        </p:nvSpPr>
+        <p:spPr>
+          <a:xfrm>
+            <a:off x="8531352" y="1929384"/>
+            <a:ext cx="310896" cy="237744"/>
+          </a:xfrm>
+          <a:prstGeom prst="rect">
+            <a:avLst/>
+          </a:prstGeom>
+          <a:noFill/>
+          <a:ln/>
+        </p:spPr>
+        <p:txBody>
+          <a:bodyPr wrap="square" lIns="0" tIns="0" rIns="0" bIns="0" rtlCol="0" anchor="ctr"/>
+          <a:lstStyle/>
+          <a:p>
+            <a:pPr indent="0" marL="0">
+              <a:buNone/>
+            </a:pPr>
+            <a:r>
+              <a:rPr lang="en-US" sz="1100" dirty="0">
+                <a:solidFill>
+                  <a:schemeClr val="bg2"/>
+                </a:solidFill>
+              </a:rPr>
+              <a:t>13</a:t>
+            </a:r>
+            <a:endParaRPr lang="en-US" sz="1100" dirty="0"/>
+          </a:p>
+        </p:txBody>
+      </p:sp>
+      <p:sp>
+        <p:nvSpPr>
+          <p:cNvPr id="37" name="Indeks 9"/>
+          <p:cNvSpPr txBox="1"/>
+          <p:nvPr/>
+        </p:nvSpPr>
+        <p:spPr>
+          <a:xfrm>
+            <a:off x="8531352" y="2606040"/>
+            <a:ext cx="310896" cy="237744"/>
+          </a:xfrm>
+          <a:prstGeom prst="rect">
+            <a:avLst/>
+          </a:prstGeom>
+          <a:noFill/>
+          <a:ln/>
+        </p:spPr>
+        <p:txBody>
+          <a:bodyPr wrap="square" lIns="0" tIns="0" rIns="0" bIns="0" rtlCol="0" anchor="ctr"/>
+          <a:lstStyle/>
+          <a:p>
+            <a:pPr indent="0" marL="0">
+              <a:buNone/>
+            </a:pPr>
+            <a:r>
+              <a:rPr lang="en-US" sz="1100" dirty="0">
+                <a:solidFill>
+                  <a:schemeClr val="bg2"/>
+                </a:solidFill>
+              </a:rPr>
+              <a:t>9</a:t>
+            </a:r>
+            <a:endParaRPr lang="en-US" sz="1100" dirty="0"/>
+          </a:p>
+        </p:txBody>
+      </p:sp>
+      <p:sp>
+        <p:nvSpPr>
+          <p:cNvPr id="38" name="Indeks 5"/>
+          <p:cNvSpPr txBox="1"/>
+          <p:nvPr/>
+        </p:nvSpPr>
+        <p:spPr>
+          <a:xfrm>
+            <a:off x="8531352" y="3282696"/>
+            <a:ext cx="310896" cy="237744"/>
+          </a:xfrm>
+          <a:prstGeom prst="rect">
+            <a:avLst/>
+          </a:prstGeom>
+          <a:noFill/>
+          <a:ln/>
+        </p:spPr>
+        <p:txBody>
+          <a:bodyPr wrap="square" lIns="0" tIns="0" rIns="0" bIns="0" rtlCol="0" anchor="ctr"/>
+          <a:lstStyle/>
+          <a:p>
+            <a:pPr indent="0" marL="0">
+              <a:buNone/>
+            </a:pPr>
+            <a:r>
+              <a:rPr lang="en-US" sz="1100" dirty="0">
+                <a:solidFill>
+                  <a:schemeClr val="bg2"/>
+                </a:solidFill>
+              </a:rPr>
+              <a:t>5</a:t>
+            </a:r>
+            <a:endParaRPr lang="en-US" sz="1100" dirty="0"/>
+          </a:p>
+        </p:txBody>
+      </p:sp>
+      <p:sp>
+        <p:nvSpPr>
+          <p:cNvPr id="39" name="Indeks 14"/>
+          <p:cNvSpPr txBox="1"/>
+          <p:nvPr/>
+        </p:nvSpPr>
+        <p:spPr>
+          <a:xfrm>
+            <a:off x="9208008" y="1929384"/>
+            <a:ext cx="310896" cy="237744"/>
+          </a:xfrm>
+          <a:prstGeom prst="rect">
+            <a:avLst/>
+          </a:prstGeom>
+          <a:noFill/>
+          <a:ln/>
+        </p:spPr>
+        <p:txBody>
+          <a:bodyPr wrap="square" lIns="0" tIns="0" rIns="0" bIns="0" rtlCol="0" anchor="ctr"/>
+          <a:lstStyle/>
+          <a:p>
+            <a:pPr indent="0" marL="0">
+              <a:buNone/>
+            </a:pPr>
+            <a:r>
+              <a:rPr lang="en-US" sz="1100" dirty="0">
+                <a:solidFill>
+                  <a:schemeClr val="bg2"/>
+                </a:solidFill>
+              </a:rPr>
+              <a:t>14</a:t>
+            </a:r>
+            <a:endParaRPr lang="en-US" sz="1100" dirty="0"/>
+          </a:p>
+        </p:txBody>
+      </p:sp>
+      <p:sp>
+        <p:nvSpPr>
+          <p:cNvPr id="40" name="Indeks 10"/>
+          <p:cNvSpPr txBox="1"/>
+          <p:nvPr/>
+        </p:nvSpPr>
+        <p:spPr>
+          <a:xfrm>
+            <a:off x="9208008" y="2606040"/>
+            <a:ext cx="310896" cy="237744"/>
+          </a:xfrm>
+          <a:prstGeom prst="rect">
+            <a:avLst/>
+          </a:prstGeom>
+          <a:noFill/>
+          <a:ln/>
+        </p:spPr>
+        <p:txBody>
+          <a:bodyPr wrap="square" lIns="0" tIns="0" rIns="0" bIns="0" rtlCol="0" anchor="ctr"/>
+          <a:lstStyle/>
+          <a:p>
+            <a:pPr indent="0" marL="0">
+              <a:buNone/>
+            </a:pPr>
+            <a:r>
+              <a:rPr lang="en-US" sz="1100" dirty="0">
+                <a:solidFill>
+                  <a:schemeClr val="bg2"/>
+                </a:solidFill>
+              </a:rPr>
+              <a:t>10</a:t>
+            </a:r>
+            <a:endParaRPr lang="en-US" sz="1100" dirty="0"/>
+          </a:p>
+        </p:txBody>
+      </p:sp>
+      <p:sp>
+        <p:nvSpPr>
+          <p:cNvPr id="41" name="Indeks 6"/>
+          <p:cNvSpPr txBox="1"/>
+          <p:nvPr/>
+        </p:nvSpPr>
+        <p:spPr>
+          <a:xfrm>
+            <a:off x="9208008" y="3282696"/>
+            <a:ext cx="310896" cy="237744"/>
+          </a:xfrm>
+          <a:prstGeom prst="rect">
+            <a:avLst/>
+          </a:prstGeom>
+          <a:noFill/>
+          <a:ln/>
+        </p:spPr>
+        <p:txBody>
+          <a:bodyPr wrap="square" lIns="0" tIns="0" rIns="0" bIns="0" rtlCol="0" anchor="ctr"/>
+          <a:lstStyle/>
+          <a:p>
+            <a:pPr indent="0" marL="0">
+              <a:buNone/>
+            </a:pPr>
+            <a:r>
+              <a:rPr lang="en-US" sz="1100" dirty="0">
+                <a:solidFill>
+                  <a:schemeClr val="bg2"/>
+                </a:solidFill>
+              </a:rPr>
+              <a:t>6</a:t>
+            </a:r>
+            <a:endParaRPr lang="en-US" sz="1100" dirty="0"/>
+          </a:p>
+        </p:txBody>
+      </p:sp>
+      <p:sp>
+        <p:nvSpPr>
+          <p:cNvPr id="42" name="Indeks 2"/>
+          <p:cNvSpPr txBox="1"/>
+          <p:nvPr/>
+        </p:nvSpPr>
+        <p:spPr>
+          <a:xfrm>
+            <a:off x="9208008" y="3959352"/>
+            <a:ext cx="310896" cy="237744"/>
+          </a:xfrm>
+          <a:prstGeom prst="rect">
+            <a:avLst/>
+          </a:prstGeom>
+          <a:noFill/>
+          <a:ln/>
+        </p:spPr>
+        <p:txBody>
+          <a:bodyPr wrap="square" lIns="0" tIns="0" rIns="0" bIns="0" rtlCol="0" anchor="ctr"/>
+          <a:lstStyle/>
+          <a:p>
+            <a:pPr indent="0" marL="0">
+              <a:buNone/>
+            </a:pPr>
+            <a:r>
+              <a:rPr lang="en-US" sz="1100" dirty="0">
+                <a:solidFill>
+                  <a:schemeClr val="bg2"/>
+                </a:solidFill>
+              </a:rPr>
+              <a:t>2</a:t>
+            </a:r>
+            <a:endParaRPr lang="en-US" sz="1100" dirty="0"/>
+          </a:p>
+        </p:txBody>
+      </p:sp>
+      <p:sp>
+        <p:nvSpPr>
+          <p:cNvPr id="43" name="Indeks 15"/>
+          <p:cNvSpPr txBox="1"/>
+          <p:nvPr/>
+        </p:nvSpPr>
+        <p:spPr>
+          <a:xfrm>
+            <a:off x="9884664" y="1929384"/>
+            <a:ext cx="310896" cy="237744"/>
+          </a:xfrm>
+          <a:prstGeom prst="rect">
+            <a:avLst/>
+          </a:prstGeom>
+          <a:noFill/>
+          <a:ln/>
+        </p:spPr>
+        <p:txBody>
+          <a:bodyPr wrap="square" lIns="0" tIns="0" rIns="0" bIns="0" rtlCol="0" anchor="ctr"/>
+          <a:lstStyle/>
+          <a:p>
+            <a:pPr indent="0" marL="0">
+              <a:buNone/>
+            </a:pPr>
+            <a:r>
+              <a:rPr lang="en-US" sz="1100" dirty="0">
+                <a:solidFill>
+                  <a:schemeClr val="bg2"/>
+                </a:solidFill>
+              </a:rPr>
+              <a:t>15</a:t>
+            </a:r>
+            <a:endParaRPr lang="en-US" sz="1100" dirty="0"/>
+          </a:p>
+        </p:txBody>
+      </p:sp>
+      <p:sp>
+        <p:nvSpPr>
+          <p:cNvPr id="44" name="Indeks 11"/>
+          <p:cNvSpPr txBox="1"/>
+          <p:nvPr/>
+        </p:nvSpPr>
+        <p:spPr>
+          <a:xfrm>
+            <a:off x="9884664" y="2606040"/>
+            <a:ext cx="310896" cy="237744"/>
+          </a:xfrm>
+          <a:prstGeom prst="rect">
+            <a:avLst/>
+          </a:prstGeom>
+          <a:noFill/>
+          <a:ln/>
+        </p:spPr>
+        <p:txBody>
+          <a:bodyPr wrap="square" lIns="0" tIns="0" rIns="0" bIns="0" rtlCol="0" anchor="ctr"/>
+          <a:lstStyle/>
+          <a:p>
+            <a:pPr indent="0" marL="0">
+              <a:buNone/>
+            </a:pPr>
+            <a:r>
+              <a:rPr lang="en-US" sz="1100" dirty="0">
+                <a:solidFill>
+                  <a:schemeClr val="bg2"/>
+                </a:solidFill>
+              </a:rPr>
+              <a:t>11</a:t>
+            </a:r>
+            <a:endParaRPr lang="en-US" sz="1100" dirty="0"/>
+          </a:p>
+        </p:txBody>
+      </p:sp>
+      <p:sp>
+        <p:nvSpPr>
+          <p:cNvPr id="45" name="Indeks 7"/>
+          <p:cNvSpPr txBox="1"/>
+          <p:nvPr/>
+        </p:nvSpPr>
+        <p:spPr>
+          <a:xfrm>
+            <a:off x="9884664" y="3282696"/>
+            <a:ext cx="310896" cy="237744"/>
+          </a:xfrm>
+          <a:prstGeom prst="rect">
+            <a:avLst/>
+          </a:prstGeom>
+          <a:noFill/>
+          <a:ln/>
+        </p:spPr>
+        <p:txBody>
+          <a:bodyPr wrap="square" lIns="0" tIns="0" rIns="0" bIns="0" rtlCol="0" anchor="ctr"/>
+          <a:lstStyle/>
+          <a:p>
+            <a:pPr indent="0" marL="0">
+              <a:buNone/>
+            </a:pPr>
+            <a:r>
+              <a:rPr lang="en-US" sz="1100" dirty="0">
+                <a:solidFill>
+                  <a:schemeClr val="bg2"/>
+                </a:solidFill>
+              </a:rPr>
+              <a:t>7</a:t>
+            </a:r>
+            <a:endParaRPr lang="en-US" sz="1100" dirty="0"/>
+          </a:p>
+        </p:txBody>
+      </p:sp>
+      <p:sp>
+        <p:nvSpPr>
+          <p:cNvPr id="46" name="Indeks 3"/>
+          <p:cNvSpPr txBox="1"/>
+          <p:nvPr/>
+        </p:nvSpPr>
+        <p:spPr>
+          <a:xfrm>
+            <a:off x="9884664" y="3959352"/>
+            <a:ext cx="310896" cy="237744"/>
+          </a:xfrm>
+          <a:prstGeom prst="rect">
+            <a:avLst/>
+          </a:prstGeom>
+          <a:noFill/>
+          <a:ln/>
+        </p:spPr>
+        <p:txBody>
+          <a:bodyPr wrap="square" lIns="0" tIns="0" rIns="0" bIns="0" rtlCol="0" anchor="ctr"/>
+          <a:lstStyle/>
+          <a:p>
+            <a:pPr indent="0" marL="0">
+              <a:buNone/>
+            </a:pPr>
+            <a:r>
+              <a:rPr lang="en-US" sz="1100" dirty="0">
+                <a:solidFill>
+                  <a:schemeClr val="bg2"/>
+                </a:solidFill>
+              </a:rPr>
+              <a:t>3</a:t>
+            </a:r>
+            <a:endParaRPr lang="en-US" sz="1100" dirty="0"/>
+          </a:p>
+        </p:txBody>
+      </p:sp>
+      <p:sp>
+        <p:nvSpPr>
+          <p:cNvPr id="47" name="Indeks 12"/>
+          <p:cNvSpPr txBox="1"/>
+          <p:nvPr/>
+        </p:nvSpPr>
+        <p:spPr>
+          <a:xfrm>
+            <a:off x="10561320" y="2606040"/>
+            <a:ext cx="310896" cy="237744"/>
+          </a:xfrm>
+          <a:prstGeom prst="rect">
+            <a:avLst/>
+          </a:prstGeom>
+          <a:noFill/>
+          <a:ln/>
+        </p:spPr>
+        <p:txBody>
+          <a:bodyPr wrap="square" lIns="0" tIns="0" rIns="0" bIns="0" rtlCol="0" anchor="ctr"/>
+          <a:lstStyle/>
+          <a:p>
+            <a:pPr indent="0" marL="0">
+              <a:buNone/>
+            </a:pPr>
+            <a:r>
+              <a:rPr lang="en-US" sz="1100" dirty="0">
+                <a:solidFill>
+                  <a:schemeClr val="bg2"/>
+                </a:solidFill>
+              </a:rPr>
+              <a:t>12</a:t>
+            </a:r>
+            <a:endParaRPr lang="en-US" sz="1100" dirty="0"/>
+          </a:p>
+        </p:txBody>
+      </p:sp>
+      <p:sp>
+        <p:nvSpPr>
+          <p:cNvPr id="48" name="Indeks 8"/>
+          <p:cNvSpPr txBox="1"/>
+          <p:nvPr/>
+        </p:nvSpPr>
+        <p:spPr>
+          <a:xfrm>
+            <a:off x="10561320" y="3282696"/>
+            <a:ext cx="310896" cy="237744"/>
+          </a:xfrm>
+          <a:prstGeom prst="rect">
+            <a:avLst/>
+          </a:prstGeom>
+          <a:noFill/>
+          <a:ln/>
+        </p:spPr>
+        <p:txBody>
+          <a:bodyPr wrap="square" lIns="0" tIns="0" rIns="0" bIns="0" rtlCol="0" anchor="ctr"/>
+          <a:lstStyle/>
+          <a:p>
+            <a:pPr indent="0" marL="0">
+              <a:buNone/>
+            </a:pPr>
+            <a:r>
+              <a:rPr lang="en-US" sz="1100" dirty="0">
+                <a:solidFill>
+                  <a:schemeClr val="bg2"/>
+                </a:solidFill>
+              </a:rPr>
+              <a:t>8</a:t>
+            </a:r>
+            <a:endParaRPr lang="en-US" sz="1100" dirty="0"/>
+          </a:p>
+        </p:txBody>
+      </p:sp>
+      <p:sp>
+        <p:nvSpPr>
+          <p:cNvPr id="49" name="Indeks 4"/>
+          <p:cNvSpPr txBox="1"/>
+          <p:nvPr/>
+        </p:nvSpPr>
+        <p:spPr>
+          <a:xfrm>
+            <a:off x="10561320" y="3959352"/>
+            <a:ext cx="310896" cy="237744"/>
+          </a:xfrm>
+          <a:prstGeom prst="rect">
+            <a:avLst/>
+          </a:prstGeom>
+          <a:noFill/>
+          <a:ln/>
+        </p:spPr>
+        <p:txBody>
+          <a:bodyPr wrap="square" lIns="0" tIns="0" rIns="0" bIns="0" rtlCol="0" anchor="ctr"/>
+          <a:lstStyle/>
+          <a:p>
+            <a:pPr indent="0" marL="0">
+              <a:buNone/>
+            </a:pPr>
+            <a:r>
+              <a:rPr lang="en-US" sz="1100" dirty="0">
+                <a:solidFill>
+                  <a:schemeClr val="bg2"/>
+                </a:solidFill>
+              </a:rPr>
+              <a:t>4</a:t>
+            </a:r>
+            <a:endParaRPr lang="en-US" sz="1100" dirty="0"/>
+          </a:p>
+        </p:txBody>
+      </p:sp>
+      <p:sp>
+        <p:nvSpPr>
+          <p:cNvPr id="50" name="Titik S lingkaran"/>
           <p:cNvSpPr/>
           <p:nvPr/>
         </p:nvSpPr>
@@ -20374,7 +20878,7 @@
       </p:sp>
       <p:sp>
         <p:nvSpPr>
-          <p:cNvPr id="37" name="Titik S"/>
+          <p:cNvPr id="51" name="Titik S"/>
           <p:cNvSpPr txBox="1"/>
           <p:nvPr/>
         </p:nvSpPr>
@@ -20410,7 +20914,7 @@
       </p:sp>
       <p:sp>
         <p:nvSpPr>
-          <p:cNvPr id="38" name="Titik T lingkaran"/>
+          <p:cNvPr id="52" name="Titik T lingkaran"/>
           <p:cNvSpPr/>
           <p:nvPr/>
         </p:nvSpPr>
@@ -20430,7 +20934,7 @@
       </p:sp>
       <p:sp>
         <p:nvSpPr>
-          <p:cNvPr id="39" name="Titik T"/>
+          <p:cNvPr id="53" name="Titik T"/>
           <p:cNvSpPr txBox="1"/>
           <p:nvPr/>
         </p:nvSpPr>
@@ -20466,14 +20970,14 @@
       </p:sp>
       <p:sp>
         <p:nvSpPr>
-          <p:cNvPr id="40" name="Grid keterangan"/>
+          <p:cNvPr id="54" name="Grid keterangan"/>
           <p:cNvSpPr txBox="1"/>
           <p:nvPr/>
         </p:nvSpPr>
         <p:spPr>
           <a:xfrm>
-            <a:off x="8183880" y="4526280"/>
-            <a:ext cx="2651760" cy="594360"/>
+            <a:off x="8183880" y="4553712"/>
+            <a:ext cx="2834640" cy="548640"/>
           </a:xfrm>
           <a:prstGeom prst="rect">
             <a:avLst/>
@@ -20494,7 +20998,7 @@
                   <a:schemeClr val="bg2"/>
                 </a:solidFill>
               </a:rPr>
-              <a:t>Grid 4 × 4 persimpangan, jarak 30 cm</a:t>
+              <a:t>Peta 4 × 4, indeks 1–16 (30 cm)</a:t>
             </a:r>
             <a:endParaRPr lang="en-US" sz="1400" dirty="0"/>
           </a:p>
@@ -20508,7 +21012,7 @@
                   <a:schemeClr val="bg2"/>
                 </a:solidFill>
               </a:rPr>
-              <a:t>S = awal, T = tujuan</a:t>
+              <a:t>Contoh rute S = 1 → T = 16</a:t>
             </a:r>
             <a:endParaRPr lang="en-US" sz="1400" dirty="0"/>
           </a:p>

</xml_diff>

<commit_message>
Path planning: indeks = langkah rute (pola sensor → aksi → ikuti garis), sesuai blok Ichiduino
Co-Authored-By: Claude Opus 5.5 <noreply@anthropic.com>
Claude-Session: https://claude.ai/code/session_0155yf5wpAX58VAfqTZWuQQK
</commit_message>
<xml_diff>
--- a/docs/pitching-rab/LFM_Pitching_RAB_P01-5.pptx
+++ b/docs/pitching-rab/LFM_Pitching_RAB_P01-5.pptx
@@ -124,13 +124,13 @@
   <p:extLst>
     <p:ext uri="{521415D9-36F7-43E2-AB2F-B90AF26B5E84}">
       <p14:sectionLst xmlns:p14="http://schemas.microsoft.com/office/powerpoint/2010/main">
-        <p14:section name="Pembuka" id="{49bb51d3-fb84-70f2-650a-9ce0917e2337}">
+        <p14:section name="Pembuka" id="{fcd4a80e-28eb-ce7a-2f32-bddc5c008fe6}">
           <p14:sldIdLst>
             <p14:sldId id="256"/>
             <p14:sldId id="257"/>
           </p14:sldIdLst>
         </p14:section>
-        <p14:section name="Masalah dan solusi" id="{4db6033c-5584-707e-3988-a9c6e5288e2c}">
+        <p14:section name="Masalah dan solusi" id="{f2956ee4-ca64-e99b-0465-80f891742f8e}">
           <p14:sldIdLst>
             <p14:sldId id="258"/>
             <p14:sldId id="259"/>
@@ -138,7 +138,7 @@
             <p14:sldId id="261"/>
           </p14:sldIdLst>
         </p14:section>
-        <p14:section name="Rancangan" id="{abc80518-d4d1-8665-4e3a-959be0eb3bde}">
+        <p14:section name="Rancangan" id="{03657843-cdf9-bf05-177b-5d0f7dd95b4e}">
           <p14:sldIdLst>
             <p14:sldId id="262"/>
             <p14:sldId id="263"/>
@@ -146,20 +146,20 @@
             <p14:sldId id="265"/>
           </p14:sldIdLst>
         </p14:section>
-        <p14:section name="Anggaran" id="{88d04877-1f35-9150-dcc1-75b714fd5407}">
+        <p14:section name="Anggaran" id="{f6bfdb64-ff9e-c613-8a9e-0c3005a3c778}">
           <p14:sldIdLst>
             <p14:sldId id="266"/>
             <p14:sldId id="267"/>
             <p14:sldId id="268"/>
           </p14:sldIdLst>
         </p14:section>
-        <p14:section name="Penutup" id="{2c363029-8fa9-72be-7de8-8840503c9675}">
+        <p14:section name="Penutup" id="{80e22ff7-7b2a-4def-f063-5696bd1b71bc}">
           <p14:sldIdLst>
             <p14:sldId id="269"/>
             <p14:sldId id="270"/>
           </p14:sldIdLst>
         </p14:section>
-        <p14:section name="Lampiran" id="{8cec365f-737e-262c-af85-5cebb8a58eab}">
+        <p14:section name="Lampiran" id="{8778c8e6-8743-dad0-ac8f-46ef874a6be0}">
           <p14:sldIdLst>
             <p14:sldId id="271"/>
             <p14:sldId id="272"/>
@@ -2426,7 +2426,7 @@
           <a:p>
             <a:r>
               <a:rPr lang="en-US" dirty="0"/>
-              <a:t>Solusi kami empat fitur utama: ikut garis dengan PID, path planning dengan peta grid yang ditentukan di awal (per indeks persimpangan), block coding berbasis web, dan fitur keamanan. Biayanya sekitar 45 persen harga kit pembanding.</a:t>
+              <a:t>Solusi kami empat fitur utama: ikut garis dengan PID, path planning dengan peta by index seperti Ichiduino (rute ditulis sebagai urutan langkah: pola sensor lalu aksi), block coding berbasis web, dan fitur keamanan. Biayanya sekitar 45 persen harga kit pembanding.</a:t>
             </a:r>
             <a:endParaRPr lang="en-US" dirty="0"/>
           </a:p>
@@ -2514,7 +2514,7 @@
           <a:p>
             <a:r>
               <a:rPr lang="en-US" dirty="0"/>
-              <a:t>Tabel reverse engineering: fungsi utama kit dipertahankan (12 sensor, OLED), komponen yang mahal atau kurang cocok untuk edukasi diganti. Path planning di kit disusun per indeks lewat mBlock; kami pakai cara yang sama ditambah rute terpendek otomatis dari peta indeks. Fitur lomba ditiadakan. Kinerja nyata kit akan diukur di lintasan yang sama.</a:t>
+              <a:t>Tabel reverse engineering: fungsi utama kit dipertahankan (12 sensor, OLED), komponen yang mahal atau kurang cocok untuk edukasi diganti. Path planning di kit disusun per indeks lewat mBlock dengan aksi berbasis waktu (ms). Kami pakai cara yang sama, tapi aksi belok dan maju diukur encoder sehingga tidak tergantung tegangan baterai, dan di lintasan grid urutan indeksnya bisa dibuat otomatis dari rute terpendek. Fitur lomba ditiadakan. Kinerja nyata kit akan diukur di lintasan yang sama.</a:t>
             </a:r>
             <a:endParaRPr lang="en-US" dirty="0"/>
           </a:p>
@@ -2778,7 +2778,7 @@
           <a:p>
             <a:r>
               <a:rPr lang="en-US" dirty="0"/>
-              <a:t>Kendali loop tertutup: posisi garis diumpankan ke PID. Encoder dipakai untuk jarak dan belok 90 derajat. Path planning memakai peta yang ditentukan di awal (pre-defined map by index, usulan Bu Fira): tiap persimpangan grid diberi nomor 1 sampai 16. Robot menghitung persimpangan yang dilewati dan menjalankan aksi untuk tiap indeks: belok kiri, belok kanan, lurus, atau berhenti. Aksinya bisa disusun siswa lewat blok seperti di Ichiduino, atau dihitung otomatis sebagai rute terpendek (BFS) dari peta yang sama. Robot tidak perlu menjelajah dulu, jadi lebih cepat dikerjakan dan diuji.</a:t>
+              <a:t>Kendali loop tertutup: posisi garis diumpankan ke PID; encoder dipakai untuk jarak dan belok 90 derajat. Path planning memakai peta yang ditentukan di awal (pre-defined map by index, usulan Bu Fira), seperti blok path planning Ichiduino di mBlock: rute ditulis sebagai urutan indeks. Tiap indeks berisi pola sensor pemicu (misalnya persimpangan kiri), aksi (maju, belok kiri, belok kanan), lalu ikuti garis lagi sampai indeks berikutnya. Contoh di grid: dari S, indeks 1 belok kiri, 2 kanan, 3 kiri, 4 kanan, 5 kiri, 6 berhenti di T. Bedanya dengan kit: aksi kami diukur encoder, bukan waktu, dan di lintasan grid urutan indeks bisa dibuat otomatis dari rute terpendek (BFS). Robot tidak perlu menjelajah dulu.</a:t>
             </a:r>
             <a:endParaRPr lang="en-US" dirty="0"/>
           </a:p>
@@ -15936,7 +15936,7 @@
                   <a:schemeClr val="bg1"/>
                 </a:solidFill>
               </a:rPr>
-              <a:t>Peta grid ditentukan di awal (indeks); rute per indeks atau rute terpendek otomatis</a:t>
+              <a:t>Rute = urutan indeks (pola sensor → aksi); di grid dibuat otomatis dari rute terpendek</a:t>
             </a:r>
             <a:endParaRPr lang="en-US" sz="1600" dirty="0"/>
           </a:p>
@@ -16174,10 +16174,10 @@
             <a:tbl>
               <a:tblPr/>
               <a:tblGrid>
-                <a:gridCol w="1737360"/>
-                <a:gridCol w="2834640"/>
+                <a:gridCol w="1691640"/>
+                <a:gridCol w="2926080"/>
                 <a:gridCol w="3447288"/>
-                <a:gridCol w="1920240"/>
+                <a:gridCol w="1874520"/>
               </a:tblGrid>
               <a:tr h="329184">
                 <a:tc>
@@ -18223,7 +18223,7 @@
                             <a:schemeClr val="bg1"/>
                           </a:solidFill>
                         </a:rPr>
-                        <a:t>aksi per indeks lewat mBlock</a:t>
+                        <a:t>per indeks, berbasis waktu</a:t>
                       </a:r>
                       <a:endParaRPr lang="en-US" sz="1400" dirty="0"/>
                     </a:p>
@@ -18284,7 +18284,7 @@
                             <a:schemeClr val="bg1"/>
                           </a:solidFill>
                         </a:rPr>
-                        <a:t>peta indeks + rute terpendek otomatis</a:t>
+                        <a:t>indeks + encoder + rute otomatis</a:t>
                       </a:r>
                       <a:endParaRPr lang="en-US" sz="1400" dirty="0"/>
                     </a:p>
@@ -19704,7 +19704,7 @@
                   <a:schemeClr val="bg1"/>
                 </a:solidFill>
               </a:rPr>
-              <a:t>Peta grid ditentukan di awal (pre-defined map by index): robot menghitung persimpangan dan menjalankan aksi tiap indeks, disusun lewat blok atau rute terpendek otomatis (BFS).</a:t>
+              <a:t>Peta by index (gaya Ichiduino): rute = urutan indeks; tiap indeks: pola sensor → aksi (maju/kiri/kanan) → ikuti garis. Di grid, urutannya bisa dibuat otomatis dari rute terpendek (BFS).</a:t>
             </a:r>
             <a:endParaRPr lang="en-US" sz="1400" dirty="0"/>
           </a:p>
@@ -19718,8 +19718,8 @@
         </p:nvSpPr>
         <p:spPr>
           <a:xfrm>
-            <a:off x="8458200" y="2240280"/>
-            <a:ext cx="2029968" cy="0"/>
+            <a:off x="8458200" y="2194560"/>
+            <a:ext cx="1975104" cy="0"/>
           </a:xfrm>
           <a:prstGeom prst="line">
             <a:avLst/>
@@ -19741,8 +19741,8 @@
         </p:nvSpPr>
         <p:spPr>
           <a:xfrm>
-            <a:off x="8458200" y="2240280"/>
-            <a:ext cx="0" cy="2029968"/>
+            <a:off x="8458200" y="2194560"/>
+            <a:ext cx="0" cy="1975104"/>
           </a:xfrm>
           <a:prstGeom prst="line">
             <a:avLst/>
@@ -19764,8 +19764,8 @@
         </p:nvSpPr>
         <p:spPr>
           <a:xfrm>
-            <a:off x="8458200" y="2916936"/>
-            <a:ext cx="2029968" cy="0"/>
+            <a:off x="8458200" y="2852928"/>
+            <a:ext cx="1975104" cy="0"/>
           </a:xfrm>
           <a:prstGeom prst="line">
             <a:avLst/>
@@ -19787,8 +19787,8 @@
         </p:nvSpPr>
         <p:spPr>
           <a:xfrm>
-            <a:off x="9134856" y="2240280"/>
-            <a:ext cx="0" cy="2029968"/>
+            <a:off x="9116568" y="2194560"/>
+            <a:ext cx="0" cy="1975104"/>
           </a:xfrm>
           <a:prstGeom prst="line">
             <a:avLst/>
@@ -19810,8 +19810,8 @@
         </p:nvSpPr>
         <p:spPr>
           <a:xfrm>
-            <a:off x="8458200" y="3593592"/>
-            <a:ext cx="2029968" cy="0"/>
+            <a:off x="8458200" y="3511296"/>
+            <a:ext cx="1975104" cy="0"/>
           </a:xfrm>
           <a:prstGeom prst="line">
             <a:avLst/>
@@ -19833,8 +19833,8 @@
         </p:nvSpPr>
         <p:spPr>
           <a:xfrm>
-            <a:off x="9811512" y="2240280"/>
-            <a:ext cx="0" cy="2029968"/>
+            <a:off x="9774936" y="2194560"/>
+            <a:ext cx="0" cy="1975104"/>
           </a:xfrm>
           <a:prstGeom prst="line">
             <a:avLst/>
@@ -19856,8 +19856,8 @@
         </p:nvSpPr>
         <p:spPr>
           <a:xfrm>
-            <a:off x="8458200" y="4270248"/>
-            <a:ext cx="2029968" cy="0"/>
+            <a:off x="8458200" y="4169664"/>
+            <a:ext cx="1975104" cy="0"/>
           </a:xfrm>
           <a:prstGeom prst="line">
             <a:avLst/>
@@ -19879,8 +19879,8 @@
         </p:nvSpPr>
         <p:spPr>
           <a:xfrm>
-            <a:off x="10488168" y="2240280"/>
-            <a:ext cx="0" cy="2029968"/>
+            <a:off x="10433304" y="2194560"/>
+            <a:ext cx="0" cy="1975104"/>
           </a:xfrm>
           <a:prstGeom prst="line">
             <a:avLst/>
@@ -19902,8 +19902,8 @@
         </p:nvSpPr>
         <p:spPr>
           <a:xfrm>
-            <a:off x="8458200" y="4270248"/>
-            <a:ext cx="676656" cy="0"/>
+            <a:off x="8458200" y="4169664"/>
+            <a:ext cx="658368" cy="0"/>
           </a:xfrm>
           <a:prstGeom prst="line">
             <a:avLst/>
@@ -19925,8 +19925,8 @@
         </p:nvSpPr>
         <p:spPr>
           <a:xfrm>
-            <a:off x="9134856" y="3593592"/>
-            <a:ext cx="0" cy="676656"/>
+            <a:off x="9116568" y="3511296"/>
+            <a:ext cx="0" cy="658368"/>
           </a:xfrm>
           <a:prstGeom prst="line">
             <a:avLst/>
@@ -19948,8 +19948,8 @@
         </p:nvSpPr>
         <p:spPr>
           <a:xfrm>
-            <a:off x="9134856" y="3593592"/>
-            <a:ext cx="676656" cy="0"/>
+            <a:off x="9116568" y="3511296"/>
+            <a:ext cx="658368" cy="0"/>
           </a:xfrm>
           <a:prstGeom prst="line">
             <a:avLst/>
@@ -19971,8 +19971,8 @@
         </p:nvSpPr>
         <p:spPr>
           <a:xfrm>
-            <a:off x="9811512" y="2916936"/>
-            <a:ext cx="0" cy="676656"/>
+            <a:off x="9774936" y="2852928"/>
+            <a:ext cx="0" cy="658368"/>
           </a:xfrm>
           <a:prstGeom prst="line">
             <a:avLst/>
@@ -19994,8 +19994,8 @@
         </p:nvSpPr>
         <p:spPr>
           <a:xfrm>
-            <a:off x="9811512" y="2916936"/>
-            <a:ext cx="676656" cy="0"/>
+            <a:off x="9774936" y="2852928"/>
+            <a:ext cx="658368" cy="0"/>
           </a:xfrm>
           <a:prstGeom prst="line">
             <a:avLst/>
@@ -20017,8 +20017,8 @@
         </p:nvSpPr>
         <p:spPr>
           <a:xfrm>
-            <a:off x="10488168" y="2240280"/>
-            <a:ext cx="0" cy="676656"/>
+            <a:off x="10433304" y="2194560"/>
+            <a:ext cx="0" cy="658368"/>
           </a:xfrm>
           <a:prstGeom prst="line">
             <a:avLst/>
@@ -20040,7 +20040,7 @@
         </p:nvSpPr>
         <p:spPr>
           <a:xfrm>
-            <a:off x="8385048" y="2167128"/>
+            <a:off x="8385048" y="2121408"/>
             <a:ext cx="146304" cy="146304"/>
           </a:xfrm>
           <a:prstGeom prst="ellipse">
@@ -20060,7 +20060,7 @@
         </p:nvSpPr>
         <p:spPr>
           <a:xfrm>
-            <a:off x="8385048" y="2843784"/>
+            <a:off x="8385048" y="2779776"/>
             <a:ext cx="146304" cy="146304"/>
           </a:xfrm>
           <a:prstGeom prst="ellipse">
@@ -20080,7 +20080,7 @@
         </p:nvSpPr>
         <p:spPr>
           <a:xfrm>
-            <a:off x="8385048" y="3520440"/>
+            <a:off x="8385048" y="3438144"/>
             <a:ext cx="146304" cy="146304"/>
           </a:xfrm>
           <a:prstGeom prst="ellipse">
@@ -20100,7 +20100,7 @@
         </p:nvSpPr>
         <p:spPr>
           <a:xfrm>
-            <a:off x="8385048" y="4197096"/>
+            <a:off x="8385048" y="4096512"/>
             <a:ext cx="146304" cy="146304"/>
           </a:xfrm>
           <a:prstGeom prst="ellipse">
@@ -20120,7 +20120,7 @@
         </p:nvSpPr>
         <p:spPr>
           <a:xfrm>
-            <a:off x="9061704" y="2167128"/>
+            <a:off x="9043416" y="2121408"/>
             <a:ext cx="146304" cy="146304"/>
           </a:xfrm>
           <a:prstGeom prst="ellipse">
@@ -20140,7 +20140,7 @@
         </p:nvSpPr>
         <p:spPr>
           <a:xfrm>
-            <a:off x="9061704" y="2843784"/>
+            <a:off x="9043416" y="2779776"/>
             <a:ext cx="146304" cy="146304"/>
           </a:xfrm>
           <a:prstGeom prst="ellipse">
@@ -20160,7 +20160,7 @@
         </p:nvSpPr>
         <p:spPr>
           <a:xfrm>
-            <a:off x="9061704" y="3520440"/>
+            <a:off x="9043416" y="3438144"/>
             <a:ext cx="146304" cy="146304"/>
           </a:xfrm>
           <a:prstGeom prst="ellipse">
@@ -20180,7 +20180,7 @@
         </p:nvSpPr>
         <p:spPr>
           <a:xfrm>
-            <a:off x="9061704" y="4197096"/>
+            <a:off x="9043416" y="4096512"/>
             <a:ext cx="146304" cy="146304"/>
           </a:xfrm>
           <a:prstGeom prst="ellipse">
@@ -20200,7 +20200,7 @@
         </p:nvSpPr>
         <p:spPr>
           <a:xfrm>
-            <a:off x="9738360" y="2167128"/>
+            <a:off x="9701784" y="2121408"/>
             <a:ext cx="146304" cy="146304"/>
           </a:xfrm>
           <a:prstGeom prst="ellipse">
@@ -20220,7 +20220,7 @@
         </p:nvSpPr>
         <p:spPr>
           <a:xfrm>
-            <a:off x="9738360" y="2843784"/>
+            <a:off x="9701784" y="2779776"/>
             <a:ext cx="146304" cy="146304"/>
           </a:xfrm>
           <a:prstGeom prst="ellipse">
@@ -20240,7 +20240,7 @@
         </p:nvSpPr>
         <p:spPr>
           <a:xfrm>
-            <a:off x="9738360" y="3520440"/>
+            <a:off x="9701784" y="3438144"/>
             <a:ext cx="146304" cy="146304"/>
           </a:xfrm>
           <a:prstGeom prst="ellipse">
@@ -20260,7 +20260,7 @@
         </p:nvSpPr>
         <p:spPr>
           <a:xfrm>
-            <a:off x="9738360" y="4197096"/>
+            <a:off x="9701784" y="4096512"/>
             <a:ext cx="146304" cy="146304"/>
           </a:xfrm>
           <a:prstGeom prst="ellipse">
@@ -20280,7 +20280,7 @@
         </p:nvSpPr>
         <p:spPr>
           <a:xfrm>
-            <a:off x="10415016" y="2167128"/>
+            <a:off x="10360152" y="2121408"/>
             <a:ext cx="146304" cy="146304"/>
           </a:xfrm>
           <a:prstGeom prst="ellipse">
@@ -20300,7 +20300,7 @@
         </p:nvSpPr>
         <p:spPr>
           <a:xfrm>
-            <a:off x="10415016" y="2843784"/>
+            <a:off x="10360152" y="2779776"/>
             <a:ext cx="146304" cy="146304"/>
           </a:xfrm>
           <a:prstGeom prst="ellipse">
@@ -20320,7 +20320,7 @@
         </p:nvSpPr>
         <p:spPr>
           <a:xfrm>
-            <a:off x="10415016" y="3520440"/>
+            <a:off x="10360152" y="3438144"/>
             <a:ext cx="146304" cy="146304"/>
           </a:xfrm>
           <a:prstGeom prst="ellipse">
@@ -20340,7 +20340,7 @@
         </p:nvSpPr>
         <p:spPr>
           <a:xfrm>
-            <a:off x="10415016" y="4197096"/>
+            <a:off x="10360152" y="4096512"/>
             <a:ext cx="146304" cy="146304"/>
           </a:xfrm>
           <a:prstGeom prst="ellipse">
@@ -20354,14 +20354,14 @@
       </p:sp>
       <p:sp>
         <p:nvSpPr>
-          <p:cNvPr id="36" name="Indeks 13"/>
+          <p:cNvPr id="36" name="Indeks 1"/>
           <p:cNvSpPr txBox="1"/>
           <p:nvPr/>
         </p:nvSpPr>
         <p:spPr>
           <a:xfrm>
-            <a:off x="8531352" y="1929384"/>
-            <a:ext cx="310896" cy="237744"/>
+            <a:off x="9198864" y="3867912"/>
+            <a:ext cx="274320" cy="237744"/>
           </a:xfrm>
           <a:prstGeom prst="rect">
             <a:avLst/>
@@ -20377,27 +20377,27 @@
               <a:buNone/>
             </a:pPr>
             <a:r>
-              <a:rPr lang="en-US" sz="1100" dirty="0">
+              <a:rPr lang="en-US" sz="1200" b="1" dirty="0">
                 <a:solidFill>
-                  <a:schemeClr val="bg2"/>
+                  <a:schemeClr val="accent2"/>
                 </a:solidFill>
               </a:rPr>
-              <a:t>13</a:t>
+              <a:t>1</a:t>
             </a:r>
-            <a:endParaRPr lang="en-US" sz="1100" dirty="0"/>
+            <a:endParaRPr lang="en-US" sz="1200" dirty="0"/>
           </a:p>
         </p:txBody>
       </p:sp>
       <p:sp>
         <p:nvSpPr>
-          <p:cNvPr id="37" name="Indeks 9"/>
+          <p:cNvPr id="37" name="Indeks 2"/>
           <p:cNvSpPr txBox="1"/>
           <p:nvPr/>
         </p:nvSpPr>
         <p:spPr>
           <a:xfrm>
-            <a:off x="8531352" y="2606040"/>
-            <a:ext cx="310896" cy="237744"/>
+            <a:off x="9198864" y="3209544"/>
+            <a:ext cx="274320" cy="237744"/>
           </a:xfrm>
           <a:prstGeom prst="rect">
             <a:avLst/>
@@ -20413,27 +20413,27 @@
               <a:buNone/>
             </a:pPr>
             <a:r>
-              <a:rPr lang="en-US" sz="1100" dirty="0">
+              <a:rPr lang="en-US" sz="1200" b="1" dirty="0">
                 <a:solidFill>
-                  <a:schemeClr val="bg2"/>
+                  <a:schemeClr val="accent2"/>
                 </a:solidFill>
               </a:rPr>
-              <a:t>9</a:t>
+              <a:t>2</a:t>
             </a:r>
-            <a:endParaRPr lang="en-US" sz="1100" dirty="0"/>
+            <a:endParaRPr lang="en-US" sz="1200" dirty="0"/>
           </a:p>
         </p:txBody>
       </p:sp>
       <p:sp>
         <p:nvSpPr>
-          <p:cNvPr id="38" name="Indeks 5"/>
+          <p:cNvPr id="38" name="Indeks 3"/>
           <p:cNvSpPr txBox="1"/>
           <p:nvPr/>
         </p:nvSpPr>
         <p:spPr>
           <a:xfrm>
-            <a:off x="8531352" y="3282696"/>
-            <a:ext cx="310896" cy="237744"/>
+            <a:off x="9857232" y="3209544"/>
+            <a:ext cx="274320" cy="237744"/>
           </a:xfrm>
           <a:prstGeom prst="rect">
             <a:avLst/>
@@ -20449,27 +20449,27 @@
               <a:buNone/>
             </a:pPr>
             <a:r>
-              <a:rPr lang="en-US" sz="1100" dirty="0">
+              <a:rPr lang="en-US" sz="1200" b="1" dirty="0">
                 <a:solidFill>
-                  <a:schemeClr val="bg2"/>
+                  <a:schemeClr val="accent2"/>
                 </a:solidFill>
               </a:rPr>
-              <a:t>5</a:t>
+              <a:t>3</a:t>
             </a:r>
-            <a:endParaRPr lang="en-US" sz="1100" dirty="0"/>
+            <a:endParaRPr lang="en-US" sz="1200" dirty="0"/>
           </a:p>
         </p:txBody>
       </p:sp>
       <p:sp>
         <p:nvSpPr>
-          <p:cNvPr id="39" name="Indeks 14"/>
+          <p:cNvPr id="39" name="Indeks 4"/>
           <p:cNvSpPr txBox="1"/>
           <p:nvPr/>
         </p:nvSpPr>
         <p:spPr>
           <a:xfrm>
-            <a:off x="9208008" y="1929384"/>
-            <a:ext cx="310896" cy="237744"/>
+            <a:off x="9857232" y="2551176"/>
+            <a:ext cx="274320" cy="237744"/>
           </a:xfrm>
           <a:prstGeom prst="rect">
             <a:avLst/>
@@ -20485,27 +20485,27 @@
               <a:buNone/>
             </a:pPr>
             <a:r>
-              <a:rPr lang="en-US" sz="1100" dirty="0">
+              <a:rPr lang="en-US" sz="1200" b="1" dirty="0">
                 <a:solidFill>
-                  <a:schemeClr val="bg2"/>
+                  <a:schemeClr val="accent2"/>
                 </a:solidFill>
               </a:rPr>
-              <a:t>14</a:t>
+              <a:t>4</a:t>
             </a:r>
-            <a:endParaRPr lang="en-US" sz="1100" dirty="0"/>
+            <a:endParaRPr lang="en-US" sz="1200" dirty="0"/>
           </a:p>
         </p:txBody>
       </p:sp>
       <p:sp>
         <p:nvSpPr>
-          <p:cNvPr id="40" name="Indeks 10"/>
+          <p:cNvPr id="40" name="Indeks 5"/>
           <p:cNvSpPr txBox="1"/>
           <p:nvPr/>
         </p:nvSpPr>
         <p:spPr>
           <a:xfrm>
-            <a:off x="9208008" y="2606040"/>
-            <a:ext cx="310896" cy="237744"/>
+            <a:off x="10515600" y="2551176"/>
+            <a:ext cx="274320" cy="237744"/>
           </a:xfrm>
           <a:prstGeom prst="rect">
             <a:avLst/>
@@ -20521,350 +20521,26 @@
               <a:buNone/>
             </a:pPr>
             <a:r>
-              <a:rPr lang="en-US" sz="1100" dirty="0">
+              <a:rPr lang="en-US" sz="1200" b="1" dirty="0">
                 <a:solidFill>
-                  <a:schemeClr val="bg2"/>
+                  <a:schemeClr val="accent2"/>
                 </a:solidFill>
               </a:rPr>
-              <a:t>10</a:t>
+              <a:t>5</a:t>
             </a:r>
-            <a:endParaRPr lang="en-US" sz="1100" dirty="0"/>
+            <a:endParaRPr lang="en-US" sz="1200" dirty="0"/>
           </a:p>
         </p:txBody>
       </p:sp>
       <p:sp>
         <p:nvSpPr>
-          <p:cNvPr id="41" name="Indeks 6"/>
-          <p:cNvSpPr txBox="1"/>
+          <p:cNvPr id="41" name="Titik S lingkaran"/>
+          <p:cNvSpPr/>
           <p:nvPr/>
         </p:nvSpPr>
         <p:spPr>
           <a:xfrm>
-            <a:off x="9208008" y="3282696"/>
-            <a:ext cx="310896" cy="237744"/>
-          </a:xfrm>
-          <a:prstGeom prst="rect">
-            <a:avLst/>
-          </a:prstGeom>
-          <a:noFill/>
-          <a:ln/>
-        </p:spPr>
-        <p:txBody>
-          <a:bodyPr wrap="square" lIns="0" tIns="0" rIns="0" bIns="0" rtlCol="0" anchor="ctr"/>
-          <a:lstStyle/>
-          <a:p>
-            <a:pPr indent="0" marL="0">
-              <a:buNone/>
-            </a:pPr>
-            <a:r>
-              <a:rPr lang="en-US" sz="1100" dirty="0">
-                <a:solidFill>
-                  <a:schemeClr val="bg2"/>
-                </a:solidFill>
-              </a:rPr>
-              <a:t>6</a:t>
-            </a:r>
-            <a:endParaRPr lang="en-US" sz="1100" dirty="0"/>
-          </a:p>
-        </p:txBody>
-      </p:sp>
-      <p:sp>
-        <p:nvSpPr>
-          <p:cNvPr id="42" name="Indeks 2"/>
-          <p:cNvSpPr txBox="1"/>
-          <p:nvPr/>
-        </p:nvSpPr>
-        <p:spPr>
-          <a:xfrm>
-            <a:off x="9208008" y="3959352"/>
-            <a:ext cx="310896" cy="237744"/>
-          </a:xfrm>
-          <a:prstGeom prst="rect">
-            <a:avLst/>
-          </a:prstGeom>
-          <a:noFill/>
-          <a:ln/>
-        </p:spPr>
-        <p:txBody>
-          <a:bodyPr wrap="square" lIns="0" tIns="0" rIns="0" bIns="0" rtlCol="0" anchor="ctr"/>
-          <a:lstStyle/>
-          <a:p>
-            <a:pPr indent="0" marL="0">
-              <a:buNone/>
-            </a:pPr>
-            <a:r>
-              <a:rPr lang="en-US" sz="1100" dirty="0">
-                <a:solidFill>
-                  <a:schemeClr val="bg2"/>
-                </a:solidFill>
-              </a:rPr>
-              <a:t>2</a:t>
-            </a:r>
-            <a:endParaRPr lang="en-US" sz="1100" dirty="0"/>
-          </a:p>
-        </p:txBody>
-      </p:sp>
-      <p:sp>
-        <p:nvSpPr>
-          <p:cNvPr id="43" name="Indeks 15"/>
-          <p:cNvSpPr txBox="1"/>
-          <p:nvPr/>
-        </p:nvSpPr>
-        <p:spPr>
-          <a:xfrm>
-            <a:off x="9884664" y="1929384"/>
-            <a:ext cx="310896" cy="237744"/>
-          </a:xfrm>
-          <a:prstGeom prst="rect">
-            <a:avLst/>
-          </a:prstGeom>
-          <a:noFill/>
-          <a:ln/>
-        </p:spPr>
-        <p:txBody>
-          <a:bodyPr wrap="square" lIns="0" tIns="0" rIns="0" bIns="0" rtlCol="0" anchor="ctr"/>
-          <a:lstStyle/>
-          <a:p>
-            <a:pPr indent="0" marL="0">
-              <a:buNone/>
-            </a:pPr>
-            <a:r>
-              <a:rPr lang="en-US" sz="1100" dirty="0">
-                <a:solidFill>
-                  <a:schemeClr val="bg2"/>
-                </a:solidFill>
-              </a:rPr>
-              <a:t>15</a:t>
-            </a:r>
-            <a:endParaRPr lang="en-US" sz="1100" dirty="0"/>
-          </a:p>
-        </p:txBody>
-      </p:sp>
-      <p:sp>
-        <p:nvSpPr>
-          <p:cNvPr id="44" name="Indeks 11"/>
-          <p:cNvSpPr txBox="1"/>
-          <p:nvPr/>
-        </p:nvSpPr>
-        <p:spPr>
-          <a:xfrm>
-            <a:off x="9884664" y="2606040"/>
-            <a:ext cx="310896" cy="237744"/>
-          </a:xfrm>
-          <a:prstGeom prst="rect">
-            <a:avLst/>
-          </a:prstGeom>
-          <a:noFill/>
-          <a:ln/>
-        </p:spPr>
-        <p:txBody>
-          <a:bodyPr wrap="square" lIns="0" tIns="0" rIns="0" bIns="0" rtlCol="0" anchor="ctr"/>
-          <a:lstStyle/>
-          <a:p>
-            <a:pPr indent="0" marL="0">
-              <a:buNone/>
-            </a:pPr>
-            <a:r>
-              <a:rPr lang="en-US" sz="1100" dirty="0">
-                <a:solidFill>
-                  <a:schemeClr val="bg2"/>
-                </a:solidFill>
-              </a:rPr>
-              <a:t>11</a:t>
-            </a:r>
-            <a:endParaRPr lang="en-US" sz="1100" dirty="0"/>
-          </a:p>
-        </p:txBody>
-      </p:sp>
-      <p:sp>
-        <p:nvSpPr>
-          <p:cNvPr id="45" name="Indeks 7"/>
-          <p:cNvSpPr txBox="1"/>
-          <p:nvPr/>
-        </p:nvSpPr>
-        <p:spPr>
-          <a:xfrm>
-            <a:off x="9884664" y="3282696"/>
-            <a:ext cx="310896" cy="237744"/>
-          </a:xfrm>
-          <a:prstGeom prst="rect">
-            <a:avLst/>
-          </a:prstGeom>
-          <a:noFill/>
-          <a:ln/>
-        </p:spPr>
-        <p:txBody>
-          <a:bodyPr wrap="square" lIns="0" tIns="0" rIns="0" bIns="0" rtlCol="0" anchor="ctr"/>
-          <a:lstStyle/>
-          <a:p>
-            <a:pPr indent="0" marL="0">
-              <a:buNone/>
-            </a:pPr>
-            <a:r>
-              <a:rPr lang="en-US" sz="1100" dirty="0">
-                <a:solidFill>
-                  <a:schemeClr val="bg2"/>
-                </a:solidFill>
-              </a:rPr>
-              <a:t>7</a:t>
-            </a:r>
-            <a:endParaRPr lang="en-US" sz="1100" dirty="0"/>
-          </a:p>
-        </p:txBody>
-      </p:sp>
-      <p:sp>
-        <p:nvSpPr>
-          <p:cNvPr id="46" name="Indeks 3"/>
-          <p:cNvSpPr txBox="1"/>
-          <p:nvPr/>
-        </p:nvSpPr>
-        <p:spPr>
-          <a:xfrm>
-            <a:off x="9884664" y="3959352"/>
-            <a:ext cx="310896" cy="237744"/>
-          </a:xfrm>
-          <a:prstGeom prst="rect">
-            <a:avLst/>
-          </a:prstGeom>
-          <a:noFill/>
-          <a:ln/>
-        </p:spPr>
-        <p:txBody>
-          <a:bodyPr wrap="square" lIns="0" tIns="0" rIns="0" bIns="0" rtlCol="0" anchor="ctr"/>
-          <a:lstStyle/>
-          <a:p>
-            <a:pPr indent="0" marL="0">
-              <a:buNone/>
-            </a:pPr>
-            <a:r>
-              <a:rPr lang="en-US" sz="1100" dirty="0">
-                <a:solidFill>
-                  <a:schemeClr val="bg2"/>
-                </a:solidFill>
-              </a:rPr>
-              <a:t>3</a:t>
-            </a:r>
-            <a:endParaRPr lang="en-US" sz="1100" dirty="0"/>
-          </a:p>
-        </p:txBody>
-      </p:sp>
-      <p:sp>
-        <p:nvSpPr>
-          <p:cNvPr id="47" name="Indeks 12"/>
-          <p:cNvSpPr txBox="1"/>
-          <p:nvPr/>
-        </p:nvSpPr>
-        <p:spPr>
-          <a:xfrm>
-            <a:off x="10561320" y="2606040"/>
-            <a:ext cx="310896" cy="237744"/>
-          </a:xfrm>
-          <a:prstGeom prst="rect">
-            <a:avLst/>
-          </a:prstGeom>
-          <a:noFill/>
-          <a:ln/>
-        </p:spPr>
-        <p:txBody>
-          <a:bodyPr wrap="square" lIns="0" tIns="0" rIns="0" bIns="0" rtlCol="0" anchor="ctr"/>
-          <a:lstStyle/>
-          <a:p>
-            <a:pPr indent="0" marL="0">
-              <a:buNone/>
-            </a:pPr>
-            <a:r>
-              <a:rPr lang="en-US" sz="1100" dirty="0">
-                <a:solidFill>
-                  <a:schemeClr val="bg2"/>
-                </a:solidFill>
-              </a:rPr>
-              <a:t>12</a:t>
-            </a:r>
-            <a:endParaRPr lang="en-US" sz="1100" dirty="0"/>
-          </a:p>
-        </p:txBody>
-      </p:sp>
-      <p:sp>
-        <p:nvSpPr>
-          <p:cNvPr id="48" name="Indeks 8"/>
-          <p:cNvSpPr txBox="1"/>
-          <p:nvPr/>
-        </p:nvSpPr>
-        <p:spPr>
-          <a:xfrm>
-            <a:off x="10561320" y="3282696"/>
-            <a:ext cx="310896" cy="237744"/>
-          </a:xfrm>
-          <a:prstGeom prst="rect">
-            <a:avLst/>
-          </a:prstGeom>
-          <a:noFill/>
-          <a:ln/>
-        </p:spPr>
-        <p:txBody>
-          <a:bodyPr wrap="square" lIns="0" tIns="0" rIns="0" bIns="0" rtlCol="0" anchor="ctr"/>
-          <a:lstStyle/>
-          <a:p>
-            <a:pPr indent="0" marL="0">
-              <a:buNone/>
-            </a:pPr>
-            <a:r>
-              <a:rPr lang="en-US" sz="1100" dirty="0">
-                <a:solidFill>
-                  <a:schemeClr val="bg2"/>
-                </a:solidFill>
-              </a:rPr>
-              <a:t>8</a:t>
-            </a:r>
-            <a:endParaRPr lang="en-US" sz="1100" dirty="0"/>
-          </a:p>
-        </p:txBody>
-      </p:sp>
-      <p:sp>
-        <p:nvSpPr>
-          <p:cNvPr id="49" name="Indeks 4"/>
-          <p:cNvSpPr txBox="1"/>
-          <p:nvPr/>
-        </p:nvSpPr>
-        <p:spPr>
-          <a:xfrm>
-            <a:off x="10561320" y="3959352"/>
-            <a:ext cx="310896" cy="237744"/>
-          </a:xfrm>
-          <a:prstGeom prst="rect">
-            <a:avLst/>
-          </a:prstGeom>
-          <a:noFill/>
-          <a:ln/>
-        </p:spPr>
-        <p:txBody>
-          <a:bodyPr wrap="square" lIns="0" tIns="0" rIns="0" bIns="0" rtlCol="0" anchor="ctr"/>
-          <a:lstStyle/>
-          <a:p>
-            <a:pPr indent="0" marL="0">
-              <a:buNone/>
-            </a:pPr>
-            <a:r>
-              <a:rPr lang="en-US" sz="1100" dirty="0">
-                <a:solidFill>
-                  <a:schemeClr val="bg2"/>
-                </a:solidFill>
-              </a:rPr>
-              <a:t>4</a:t>
-            </a:r>
-            <a:endParaRPr lang="en-US" sz="1100" dirty="0"/>
-          </a:p>
-        </p:txBody>
-      </p:sp>
-      <p:sp>
-        <p:nvSpPr>
-          <p:cNvPr id="50" name="Titik S lingkaran"/>
-          <p:cNvSpPr/>
-          <p:nvPr/>
-        </p:nvSpPr>
-        <p:spPr>
-          <a:xfrm>
-            <a:off x="8275320" y="4087368"/>
+            <a:off x="8275320" y="3986784"/>
             <a:ext cx="365760" cy="365760"/>
           </a:xfrm>
           <a:prstGeom prst="ellipse">
@@ -20878,13 +20554,13 @@
       </p:sp>
       <p:sp>
         <p:nvSpPr>
-          <p:cNvPr id="51" name="Titik S"/>
+          <p:cNvPr id="42" name="Titik S"/>
           <p:cNvSpPr txBox="1"/>
           <p:nvPr/>
         </p:nvSpPr>
         <p:spPr>
           <a:xfrm>
-            <a:off x="8275320" y="4087368"/>
+            <a:off x="8275320" y="3986784"/>
             <a:ext cx="365760" cy="365760"/>
           </a:xfrm>
           <a:prstGeom prst="rect">
@@ -20914,13 +20590,13 @@
       </p:sp>
       <p:sp>
         <p:nvSpPr>
-          <p:cNvPr id="52" name="Titik T lingkaran"/>
+          <p:cNvPr id="43" name="Titik T lingkaran"/>
           <p:cNvSpPr/>
           <p:nvPr/>
         </p:nvSpPr>
         <p:spPr>
           <a:xfrm>
-            <a:off x="10305288" y="2057400"/>
+            <a:off x="10250424" y="2011680"/>
             <a:ext cx="365760" cy="365760"/>
           </a:xfrm>
           <a:prstGeom prst="ellipse">
@@ -20934,13 +20610,13 @@
       </p:sp>
       <p:sp>
         <p:nvSpPr>
-          <p:cNvPr id="53" name="Titik T"/>
+          <p:cNvPr id="44" name="Titik T"/>
           <p:cNvSpPr txBox="1"/>
           <p:nvPr/>
         </p:nvSpPr>
         <p:spPr>
           <a:xfrm>
-            <a:off x="10305288" y="2057400"/>
+            <a:off x="10250424" y="2011680"/>
             <a:ext cx="365760" cy="365760"/>
           </a:xfrm>
           <a:prstGeom prst="rect">
@@ -20970,14 +20646,14 @@
       </p:sp>
       <p:sp>
         <p:nvSpPr>
-          <p:cNvPr id="54" name="Grid keterangan"/>
+          <p:cNvPr id="45" name="Grid keterangan"/>
           <p:cNvSpPr txBox="1"/>
           <p:nvPr/>
         </p:nvSpPr>
         <p:spPr>
           <a:xfrm>
-            <a:off x="8183880" y="4553712"/>
-            <a:ext cx="2834640" cy="548640"/>
+            <a:off x="8183880" y="4462272"/>
+            <a:ext cx="2834640" cy="658368"/>
           </a:xfrm>
           <a:prstGeom prst="rect">
             <a:avLst/>
@@ -20993,28 +20669,42 @@
               <a:buNone/>
             </a:pPr>
             <a:r>
-              <a:rPr lang="en-US" sz="1400" dirty="0">
+              <a:rPr lang="en-US" sz="1300" dirty="0">
                 <a:solidFill>
                   <a:schemeClr val="bg2"/>
                 </a:solidFill>
               </a:rPr>
-              <a:t>Peta 4 × 4, indeks 1–16 (30 cm)</a:t>
+              <a:t>Indeks = urutan langkah rute S → T</a:t>
             </a:r>
-            <a:endParaRPr lang="en-US" sz="1400" dirty="0"/>
+            <a:endParaRPr lang="en-US" sz="1300" dirty="0"/>
           </a:p>
           <a:p>
             <a:pPr indent="0" marL="0">
               <a:buNone/>
             </a:pPr>
             <a:r>
-              <a:rPr lang="en-US" sz="1400" dirty="0">
+              <a:rPr lang="en-US" sz="1300" dirty="0">
                 <a:solidFill>
                   <a:schemeClr val="bg2"/>
                 </a:solidFill>
               </a:rPr>
-              <a:t>Contoh rute S = 1 → T = 16</a:t>
+              <a:t>1 kiri · 2 kanan · 3 kiri</a:t>
             </a:r>
-            <a:endParaRPr lang="en-US" sz="1400" dirty="0"/>
+            <a:endParaRPr lang="en-US" sz="1300" dirty="0"/>
+          </a:p>
+          <a:p>
+            <a:pPr indent="0" marL="0">
+              <a:buNone/>
+            </a:pPr>
+            <a:r>
+              <a:rPr lang="en-US" sz="1300" dirty="0">
+                <a:solidFill>
+                  <a:schemeClr val="bg2"/>
+                </a:solidFill>
+              </a:rPr>
+              <a:t>4 kanan · 5 kiri · 6 berhenti</a:t>
+            </a:r>
+            <a:endParaRPr lang="en-US" sz="1300" dirty="0"/>
           </a:p>
         </p:txBody>
       </p:sp>

</xml_diff>

<commit_message>
Batas RAB jadi Rp1.000.000: charter + docx, deck (slide 3, 6, 13), naskah, README, CLAUDE.md
RAB Rp902.000 tetap, sekarang sisa Rp98.000.

Co-Authored-By: Claude Opus 5.5 <noreply@anthropic.com>
Claude-Session: https://claude.ai/code/session_0155yf5wpAX58VAfqTZWuQQK
</commit_message>
<xml_diff>
--- a/docs/pitching-rab/LFM_Pitching_RAB_P01-5.pptx
+++ b/docs/pitching-rab/LFM_Pitching_RAB_P01-5.pptx
@@ -124,13 +124,13 @@
   <p:extLst>
     <p:ext uri="{521415D9-36F7-43E2-AB2F-B90AF26B5E84}">
       <p14:sectionLst xmlns:p14="http://schemas.microsoft.com/office/powerpoint/2010/main">
-        <p14:section name="Pembuka" id="{fcd4a80e-28eb-ce7a-2f32-bddc5c008fe6}">
+        <p14:section name="Pembuka" id="{116ebe3b-8695-e8d3-05da-22863dc10224}">
           <p14:sldIdLst>
             <p14:sldId id="256"/>
             <p14:sldId id="257"/>
           </p14:sldIdLst>
         </p14:section>
-        <p14:section name="Masalah dan solusi" id="{f2956ee4-ca64-e99b-0465-80f891742f8e}">
+        <p14:section name="Masalah dan solusi" id="{1c891747-87d8-e4f9-5623-cc1dc0dc6698}">
           <p14:sldIdLst>
             <p14:sldId id="258"/>
             <p14:sldId id="259"/>
@@ -138,7 +138,7 @@
             <p14:sldId id="261"/>
           </p14:sldIdLst>
         </p14:section>
-        <p14:section name="Rancangan" id="{03657843-cdf9-bf05-177b-5d0f7dd95b4e}">
+        <p14:section name="Rancangan" id="{3ba8faaa-ed2b-c81c-ca85-de43b9220a35}">
           <p14:sldIdLst>
             <p14:sldId id="262"/>
             <p14:sldId id="263"/>
@@ -146,20 +146,20 @@
             <p14:sldId id="265"/>
           </p14:sldIdLst>
         </p14:section>
-        <p14:section name="Anggaran" id="{f6bfdb64-ff9e-c613-8a9e-0c3005a3c778}">
+        <p14:section name="Anggaran" id="{d5742e59-a431-169a-3c6e-446257760c74}">
           <p14:sldIdLst>
             <p14:sldId id="266"/>
             <p14:sldId id="267"/>
             <p14:sldId id="268"/>
           </p14:sldIdLst>
         </p14:section>
-        <p14:section name="Penutup" id="{80e22ff7-7b2a-4def-f063-5696bd1b71bc}">
+        <p14:section name="Penutup" id="{198a2e4c-8221-133a-90eb-c5e81f1149bb}">
           <p14:sldIdLst>
             <p14:sldId id="269"/>
             <p14:sldId id="270"/>
           </p14:sldIdLst>
         </p14:section>
-        <p14:section name="Lampiran" id="{8778c8e6-8743-dad0-ac8f-46ef874a6be0}">
+        <p14:section name="Lampiran" id="{6c11e9d6-b035-a5e2-4f18-30546b988c57}">
           <p14:sldIdLst>
             <p14:sldId id="271"/>
             <p14:sldId id="272"/>
@@ -675,7 +675,7 @@
               <c:strCache>
                 <c:ptCount val="1"/>
                 <c:pt idx="0">
-                  <c:v>Batas Rp900 rb</c:v>
+                  <c:v>Batas Rp1.000 rb</c:v>
                 </c:pt>
               </c:strCache>
             </c:strRef>
@@ -779,31 +779,31 @@
                 <c:formatCode>General</c:formatCode>
                 <c:ptCount val="9"/>
                 <c:pt idx="0">
-                  <c:v>900</c:v>
+                  <c:v>1000</c:v>
                 </c:pt>
                 <c:pt idx="1">
-                  <c:v>900</c:v>
+                  <c:v>1000</c:v>
                 </c:pt>
                 <c:pt idx="2">
-                  <c:v>900</c:v>
+                  <c:v>1000</c:v>
                 </c:pt>
                 <c:pt idx="3">
-                  <c:v>900</c:v>
+                  <c:v>1000</c:v>
                 </c:pt>
                 <c:pt idx="4">
-                  <c:v>900</c:v>
+                  <c:v>1000</c:v>
                 </c:pt>
                 <c:pt idx="5">
-                  <c:v>900</c:v>
+                  <c:v>1000</c:v>
                 </c:pt>
                 <c:pt idx="6">
-                  <c:v>900</c:v>
+                  <c:v>1000</c:v>
                 </c:pt>
                 <c:pt idx="7">
-                  <c:v>900</c:v>
+                  <c:v>1000</c:v>
                 </c:pt>
                 <c:pt idx="8">
-                  <c:v>900</c:v>
+                  <c:v>1000</c:v>
                 </c:pt>
               </c:numCache>
             </c:numRef>
@@ -884,7 +884,7 @@
         <c:axId val="2094734552"/>
         <c:scaling>
           <c:orientation val="minMax"/>
-          <c:max val="920"/>
+          <c:max val="1050"/>
           <c:min val="800"/>
         </c:scaling>
         <c:delete val="0"/>
@@ -929,7 +929,7 @@
         <c:crossAx val="2094734554"/>
         <c:crosses val="autoZero"/>
         <c:crossBetween val="between"/>
-        <c:majorUnit val="40"/>
+        <c:majorUnit val="50"/>
       </c:valAx>
       <c:spPr>
         <a:noFill/>
@@ -1722,7 +1722,7 @@
           <a:p>
             <a:r>
               <a:rPr lang="en-US" dirty="0"/>
-              <a:t>RAB sudah sembilan kali direvisi dan dijaga dekat batas. Sekarang 902 ribu, lebih 2 ribu (0,2 persen) karena harga QRE1113GR lokal ternyata tiga kali perkiraan. Kalau diminta pas 900 ribu: push button di RAB 4 buah, rancangan memakai 2 (tombol A dan B); mengurangi 2 buah menutup selisih 2 ribu.</a:t>
+              <a:t>RAB sudah sembilan kali direvisi. Kenaikan terbesar dari harga QRE1113GR lokal yang ternyata tiga kali perkiraan, sedangkan penghematan datang dari penghapusan MCP23017 dan LED indikator, skid nilon, serta alat yang dipinjam dari lab. Dengan batas anggaran Rp1.000.000, RAB 902 ribu masih menyisakan 98 ribu (9,8 persen) untuk kenaikan harga atau item yang belum masuk RAB seperti body 3D print.</a:t>
             </a:r>
             <a:endParaRPr lang="en-US" dirty="0"/>
           </a:p>
@@ -2338,7 +2338,7 @@
           <a:p>
             <a:r>
               <a:rPr lang="en-US" dirty="0"/>
-              <a:t>Masalah: kit edukasi mahal, sekitar dua juta rupiah, dan dirancang untuk lomba. Dari dosen kami mendapat batas: reverse engineering, anggaran maksimal 900 ribu, minimal bisa ikut garis dan path planning.</a:t>
+              <a:t>Masalah: kit edukasi mahal, sekitar dua juta rupiah, dan dirancang untuk lomba. Dari dosen kami mendapat batas: reverse engineering, anggaran maksimal satu juta rupiah (naik dari 900 ribu), minimal bisa ikut garis dan path planning.</a:t>
             </a:r>
             <a:endParaRPr lang="en-US" dirty="0"/>
           </a:p>
@@ -5314,7 +5314,7 @@
       </p:sp>
       <p:graphicFrame>
         <p:nvGraphicFramePr>
-          <p:cNvPr id="3" name="Grafik riwayat RAB" descr="Grafik garis total RAB per revisi dari 845 sampai 902 ribu rupiah, dengan garis batas 900 ribu"/>
+          <p:cNvPr id="3" name="Grafik riwayat RAB" descr="Grafik garis total RAB per revisi dari 845 sampai 902 ribu rupiah, dengan garis batas 1 juta rupiah"/>
           <p:cNvGraphicFramePr/>
           <p:nvPr/>
         </p:nvGraphicFramePr>
@@ -5353,14 +5353,14 @@
               <a:buNone/>
             </a:pPr>
             <a:r>
-              <a:rPr lang="en-US" sz="4000" b="1" dirty="0">
+              <a:rPr lang="en-US" sz="3600" b="1" dirty="0">
                 <a:solidFill>
                   <a:schemeClr val="accent2"/>
                 </a:solidFill>
               </a:rPr>
-              <a:t>+Rp2.000</a:t>
+              <a:t>Sisa Rp98.000</a:t>
             </a:r>
-            <a:endParaRPr lang="en-US" sz="4000" dirty="0"/>
+            <a:endParaRPr lang="en-US" sz="3600" dirty="0"/>
           </a:p>
           <a:p>
             <a:pPr indent="0" marL="0">
@@ -5372,9 +5372,9 @@
                   <a:schemeClr val="bg1"/>
                 </a:solidFill>
               </a:rPr>
-              <a:t>(0,2%) di atas batas Rp900.000</a:t>
+              <a:t>(9,8%) di bawah batas Rp1.000.000</a:t>
             </a:r>
-            <a:endParaRPr lang="en-US" sz="4000" dirty="0"/>
+            <a:endParaRPr lang="en-US" sz="3600" dirty="0"/>
           </a:p>
         </p:txBody>
       </p:sp>
@@ -5386,8 +5386,8 @@
         </p:nvSpPr>
         <p:spPr>
           <a:xfrm>
-            <a:off x="7726680" y="3429000"/>
-            <a:ext cx="3383280" cy="2194560"/>
+            <a:off x="7726680" y="3200400"/>
+            <a:ext cx="3383280" cy="2103120"/>
           </a:xfrm>
           <a:prstGeom prst="rect">
             <a:avLst/>
@@ -5412,7 +5412,7 @@
                   <a:schemeClr val="bg1"/>
                 </a:solidFill>
               </a:rPr>
-              <a:t>Penyebab: QRE1113GR lokal Rp15.000/pcs, 3× perkiraan awal (+Rp105.000).</a:t>
+              <a:t>Kenaikan terbesar: QRE1113GR lokal Rp15.000/pcs, 3× perkiraan awal (+Rp105.000).</a:t>
             </a:r>
             <a:endParaRPr lang="en-US" sz="1400" dirty="0"/>
           </a:p>
@@ -5430,7 +5430,7 @@
                   <a:schemeClr val="bg1"/>
                 </a:solidFill>
               </a:rPr>
-              <a:t>Sudah dihemat: MCP23017 + LED indikator dihapus, skid nilon pengganti ball caster, breadboard dan timah pinjam lab (−Rp85.000).</a:t>
+              <a:t>Sudah dihemat: MCP23017 + LED indikator dihapus, skid nilon, alat pinjam lab (−Rp85.000).</a:t>
             </a:r>
             <a:endParaRPr lang="en-US" sz="1400" dirty="0"/>
           </a:p>
@@ -5448,7 +5448,7 @@
                   <a:schemeClr val="bg1"/>
                 </a:solidFill>
               </a:rPr>
-              <a:t>12 sensor dipertahankan supaya setara kit pembanding.</a:t>
+              <a:t>Sisa bisa menutup kenaikan harga atau body 3D print (belum di RAB).</a:t>
             </a:r>
             <a:endParaRPr lang="en-US" sz="1400" dirty="0"/>
           </a:p>
@@ -15587,7 +15587,7 @@
                   <a:schemeClr val="bg1"/>
                 </a:solidFill>
               </a:rPr>
-              <a:t>Arahan dosen (05/10/2026): reverse engineering produk contoh, lalu buat ulang dengan budget maksimal Rp900.000.</a:t>
+              <a:t>Arahan dosen: reverse engineering produk contoh, lalu buat ulang dengan budget maksimal Rp1.000.000.</a:t>
             </a:r>
             <a:endParaRPr lang="en-US" sz="1400" dirty="0"/>
           </a:p>
@@ -19320,7 +19320,7 @@
                   <a:schemeClr val="bg2"/>
                 </a:solidFill>
               </a:rPr>
-              <a:t>Tiap sasaran punya cara uji dan alat ukur bersatuan (3–10 ulangan); sasaran ke-9: total biaya ≤ Rp900.000.</a:t>
+              <a:t>Tiap sasaran punya cara uji dan alat ukur bersatuan (3–10 ulangan); sasaran ke-9: total biaya ≤ Rp1.000.000.</a:t>
             </a:r>
             <a:endParaRPr lang="en-US" sz="1400" dirty="0"/>
           </a:p>

</xml_diff>

<commit_message>
RAB jadi Rp887.000: mux CD74HC4067M SOP-24 Rp20.000 dari WKH Electronic (charter + docx, deck, naskah)
Toko lokal lain hanya punya versi SSOP yang tidak lolos aturan cetak; versi SOP-24 cocok dengan footprint
SOIC-24W, jadi PCB sensor tidak berubah. Subtotal lampiran A deck dibetulkan.

Co-Authored-By: Claude Opus 5.5 <noreply@anthropic.com>
Claude-Session: https://claude.ai/code/session_0155yf5wpAX58VAfqTZWuQQK
</commit_message>
<xml_diff>
--- a/docs/pitching-rab/LFM_Pitching_RAB_P01-5.pptx
+++ b/docs/pitching-rab/LFM_Pitching_RAB_P01-5.pptx
@@ -124,13 +124,13 @@
   <p:extLst>
     <p:ext uri="{521415D9-36F7-43E2-AB2F-B90AF26B5E84}">
       <p14:sectionLst xmlns:p14="http://schemas.microsoft.com/office/powerpoint/2010/main">
-        <p14:section name="Pembuka" id="{116ebe3b-8695-e8d3-05da-22863dc10224}">
+        <p14:section name="Pembuka" id="{11e51e26-de48-c815-b1ed-3da7d32f00d5}">
           <p14:sldIdLst>
             <p14:sldId id="256"/>
             <p14:sldId id="257"/>
           </p14:sldIdLst>
         </p14:section>
-        <p14:section name="Masalah dan solusi" id="{1c891747-87d8-e4f9-5623-cc1dc0dc6698}">
+        <p14:section name="Masalah dan solusi" id="{60064b55-b994-35ad-3841-636ca2a31fad}">
           <p14:sldIdLst>
             <p14:sldId id="258"/>
             <p14:sldId id="259"/>
@@ -138,7 +138,7 @@
             <p14:sldId id="261"/>
           </p14:sldIdLst>
         </p14:section>
-        <p14:section name="Rancangan" id="{3ba8faaa-ed2b-c81c-ca85-de43b9220a35}">
+        <p14:section name="Rancangan" id="{a6e05fd5-aee9-d111-44b9-cf9da7a47860}">
           <p14:sldIdLst>
             <p14:sldId id="262"/>
             <p14:sldId id="263"/>
@@ -146,20 +146,20 @@
             <p14:sldId id="265"/>
           </p14:sldIdLst>
         </p14:section>
-        <p14:section name="Anggaran" id="{d5742e59-a431-169a-3c6e-446257760c74}">
+        <p14:section name="Anggaran" id="{722b5b8f-739b-8224-206b-9caed72e1309}">
           <p14:sldIdLst>
             <p14:sldId id="266"/>
             <p14:sldId id="267"/>
             <p14:sldId id="268"/>
           </p14:sldIdLst>
         </p14:section>
-        <p14:section name="Penutup" id="{198a2e4c-8221-133a-90eb-c5e81f1149bb}">
+        <p14:section name="Penutup" id="{d93f419f-14e8-66f3-bf04-d11a517d35a2}">
           <p14:sldIdLst>
             <p14:sldId id="269"/>
             <p14:sldId id="270"/>
           </p14:sldIdLst>
         </p14:section>
-        <p14:section name="Lampiran" id="{6c11e9d6-b035-a5e2-4f18-30546b988c57}">
+        <p14:section name="Lampiran" id="{7f3aa96d-3a95-51b2-7174-c5ea11273bc5}">
           <p14:sldIdLst>
             <p14:sldId id="271"/>
             <p14:sldId id="272"/>
@@ -299,7 +299,7 @@
                   <c:v>240</c:v>
                 </c:pt>
                 <c:pt idx="1">
-                  <c:v>218</c:v>
+                  <c:v>203</c:v>
                 </c:pt>
                 <c:pt idx="2">
                   <c:v>170</c:v>
@@ -561,9 +561,9 @@
           </c:marker>
           <c:cat>
             <c:multiLvlStrRef>
-              <c:f>Sheet1!$A$2:$A$10</c:f>
+              <c:f>Sheet1!$A$2:$A$11</c:f>
               <c:multiLvlStrCache>
-                <c:ptCount val="9"/>
+                <c:ptCount val="10"/>
                 <c:lvl>
                   <c:pt idx="0">
                     <c:v>Rev 3.2</c:v>
@@ -592,16 +592,19 @@
                   <c:pt idx="8">
                     <c:v>22/10</c:v>
                   </c:pt>
+                  <c:pt idx="9">
+                    <c:v>26/10</c:v>
+                  </c:pt>
                 </c:lvl>
               </c:multiLvlStrCache>
             </c:multiLvlStrRef>
           </c:cat>
           <c:val>
             <c:numRef>
-              <c:f>Sheet1!$B$2:$B$10</c:f>
+              <c:f>Sheet1!$B$2:$B$11</c:f>
               <c:numCache>
                 <c:formatCode>General</c:formatCode>
-                <c:ptCount val="9"/>
+                <c:ptCount val="10"/>
                 <c:pt idx="0">
                   <c:v>845</c:v>
                 </c:pt>
@@ -628,6 +631,9 @@
                 </c:pt>
                 <c:pt idx="8">
                   <c:v>902</c:v>
+                </c:pt>
+                <c:pt idx="9">
+                  <c:v>887</c:v>
                 </c:pt>
               </c:numCache>
             </c:numRef>
@@ -737,9 +743,9 @@
           </c:marker>
           <c:cat>
             <c:multiLvlStrRef>
-              <c:f>Sheet1!$A$2:$A$10</c:f>
+              <c:f>Sheet1!$A$2:$A$11</c:f>
               <c:multiLvlStrCache>
-                <c:ptCount val="9"/>
+                <c:ptCount val="10"/>
                 <c:lvl>
                   <c:pt idx="0">
                     <c:v>Rev 3.2</c:v>
@@ -768,16 +774,19 @@
                   <c:pt idx="8">
                     <c:v>22/10</c:v>
                   </c:pt>
+                  <c:pt idx="9">
+                    <c:v>26/10</c:v>
+                  </c:pt>
                 </c:lvl>
               </c:multiLvlStrCache>
             </c:multiLvlStrRef>
           </c:cat>
           <c:val>
             <c:numRef>
-              <c:f>Sheet1!$C$2:$C$10</c:f>
+              <c:f>Sheet1!$C$2:$C$11</c:f>
               <c:numCache>
                 <c:formatCode>General</c:formatCode>
-                <c:ptCount val="9"/>
+                <c:ptCount val="10"/>
                 <c:pt idx="0">
                   <c:v>1000</c:v>
                 </c:pt>
@@ -803,6 +812,9 @@
                   <c:v>1000</c:v>
                 </c:pt>
                 <c:pt idx="8">
+                  <c:v>1000</c:v>
+                </c:pt>
+                <c:pt idx="9">
                   <c:v>1000</c:v>
                 </c:pt>
               </c:numCache>
@@ -1546,7 +1558,7 @@
           <a:p>
             <a:r>
               <a:rPr lang="en-US" dirty="0"/>
-              <a:t>Total RAB 902 ribu rupiah. Terbesar untuk fabrikasi dua PCB dan 12 sensor. Rincian lengkap tiap item ada di lampiran.</a:t>
+              <a:t>Total RAB 887 ribu rupiah. Terbesar untuk fabrikasi dua PCB dan 12 sensor. Rincian lengkap tiap item ada di lampiran.</a:t>
             </a:r>
             <a:endParaRPr lang="en-US" dirty="0"/>
           </a:p>
@@ -1722,7 +1734,7 @@
           <a:p>
             <a:r>
               <a:rPr lang="en-US" dirty="0"/>
-              <a:t>RAB sudah sembilan kali direvisi. Kenaikan terbesar dari harga QRE1113GR lokal yang ternyata tiga kali perkiraan, sedangkan penghematan datang dari penghapusan MCP23017 dan LED indikator, skid nilon, serta alat yang dipinjam dari lab. Dengan batas anggaran Rp1.000.000, RAB 902 ribu masih menyisakan 98 ribu (9,8 persen) untuk kenaikan harga atau item yang belum masuk RAB seperti body 3D print.</a:t>
+              <a:t>RAB sudah sepuluh kali direvisi. Kenaikan terbesar dari harga QRE1113GR lokal yang ternyata tiga kali perkiraan, sedangkan penghematan datang dari penghapusan MCP23017 dan LED indikator, skid nilon, serta alat yang dipinjam dari lab; revisi terakhir 26/10: IC multiplexer dapat harga toko 20 ribu, turun 15 ribu dari perkiraan. Dengan batas anggaran Rp1.000.000, RAB 887 ribu masih menyisakan 113 ribu (11,3 persen) untuk kenaikan harga atau item yang belum masuk RAB seperti body 3D print.</a:t>
             </a:r>
             <a:endParaRPr lang="en-US" dirty="0"/>
           </a:p>
@@ -1898,7 +1910,7 @@
           <a:p>
             <a:r>
               <a:rPr lang="en-US" dirty="0"/>
-              <a:t>Penutup: kami mohon persetujuan dana 902 ribu rupiah. Rencana sesudah dana cair ada di sisi kanan. Terima kasih, kami siap menjawab pertanyaan.</a:t>
+              <a:t>Penutup: kami mohon persetujuan dana 887 ribu rupiah. Rencana sesudah dana cair ada di sisi kanan. Terima kasih, kami siap menjawab pertanyaan.</a:t>
             </a:r>
             <a:endParaRPr lang="en-US" dirty="0"/>
           </a:p>
@@ -2074,7 +2086,7 @@
           <a:p>
             <a:r>
               <a:rPr lang="en-US" dirty="0"/>
-              <a:t>Rincian RAB elektrikal bagian kedua; total elektrikal 847 ribu.</a:t>
+              <a:t>Rincian RAB elektrikal bagian kedua; total elektrikal 832 ribu.</a:t>
             </a:r>
             <a:endParaRPr lang="en-US" dirty="0"/>
           </a:p>
@@ -2162,7 +2174,7 @@
           <a:p>
             <a:r>
               <a:rPr lang="en-US" dirty="0"/>
-              <a:t>RAB mekanik dan rekap total 902 ribu. Lintasan uji, breadboard, dan timah di luar RAB.</a:t>
+              <a:t>RAB mekanik dan rekap total 887 ribu. Lintasan uji, breadboard, dan timah di luar RAB.</a:t>
             </a:r>
             <a:endParaRPr lang="en-US" dirty="0"/>
           </a:p>
@@ -2426,7 +2438,7 @@
           <a:p>
             <a:r>
               <a:rPr lang="en-US" dirty="0"/>
-              <a:t>Solusi kami empat fitur utama: ikut garis dengan PID, path planning dengan peta by index seperti Ichiduino (rute ditulis sebagai urutan langkah: pola sensor lalu aksi), block coding berbasis web, dan fitur keamanan. Biayanya sekitar 45 persen harga kit pembanding.</a:t>
+              <a:t>Solusi kami empat fitur utama: ikut garis dengan PID, path planning dengan peta by index seperti Ichiduino (rute ditulis sebagai urutan langkah: pola sensor lalu aksi), block coding berbasis web, dan fitur keamanan. Biayanya sekitar 44 persen harga kit pembanding.</a:t>
             </a:r>
             <a:endParaRPr lang="en-US" dirty="0"/>
           </a:p>
@@ -4636,7 +4648,7 @@
                   <a:schemeClr val="accent2"/>
                 </a:solidFill>
               </a:rPr>
-              <a:t>Rp902.000</a:t>
+              <a:t>Rp887.000</a:t>
             </a:r>
             <a:endParaRPr lang="en-US" sz="4800" dirty="0"/>
           </a:p>
@@ -4650,7 +4662,7 @@
                   <a:schemeClr val="bg1"/>
                 </a:solidFill>
               </a:rPr>
-              <a:t>Elektrikal Rp847.000 + Mekanik Rp55.000</a:t>
+              <a:t>Elektrikal Rp832.000 + Mekanik Rp55.000</a:t>
             </a:r>
             <a:endParaRPr lang="en-US" sz="4800" dirty="0"/>
           </a:p>
@@ -4734,7 +4746,7 @@
       </p:sp>
       <p:graphicFrame>
         <p:nvGraphicFramePr>
-          <p:cNvPr id="5" name="Grafik RAB per kelompok" descr="Grafik batang biaya per kelompok: PCB dan konektor 240 ribu, sensor garis 218 ribu, penggerak 170 ribu, daya dan baterai 136 ribu, otak dan antarmuka 118 ribu, mekanik lain 20 ribu"/>
+          <p:cNvPr id="5" name="Grafik RAB per kelompok" descr="Grafik batang biaya per kelompok: PCB dan konektor 240 ribu, sensor garis 203 ribu, penggerak 170 ribu, daya dan baterai 136 ribu, otak dan antarmuka 118 ribu, mekanik lain 20 ribu"/>
           <p:cNvGraphicFramePr/>
           <p:nvPr/>
         </p:nvGraphicFramePr>
@@ -5314,7 +5326,7 @@
       </p:sp>
       <p:graphicFrame>
         <p:nvGraphicFramePr>
-          <p:cNvPr id="3" name="Grafik riwayat RAB" descr="Grafik garis total RAB per revisi dari 845 sampai 902 ribu rupiah, dengan garis batas 1 juta rupiah"/>
+          <p:cNvPr id="3" name="Grafik riwayat RAB" descr="Grafik garis total RAB per revisi antara 833 dan 902 ribu rupiah, terakhir 887 ribu, dengan garis batas 1 juta rupiah"/>
           <p:cNvGraphicFramePr/>
           <p:nvPr/>
         </p:nvGraphicFramePr>
@@ -5358,7 +5370,7 @@
                   <a:schemeClr val="accent2"/>
                 </a:solidFill>
               </a:rPr>
-              <a:t>Sisa Rp98.000</a:t>
+              <a:t>Sisa Rp113.000</a:t>
             </a:r>
             <a:endParaRPr lang="en-US" sz="3600" dirty="0"/>
           </a:p>
@@ -5372,7 +5384,7 @@
                   <a:schemeClr val="bg1"/>
                 </a:solidFill>
               </a:rPr>
-              <a:t>(9,8%) di bawah batas Rp1.000.000</a:t>
+              <a:t>(11,3%) di bawah batas Rp1.000.000</a:t>
             </a:r>
             <a:endParaRPr lang="en-US" sz="3600" dirty="0"/>
           </a:p>
@@ -5412,7 +5424,7 @@
                   <a:schemeClr val="bg1"/>
                 </a:solidFill>
               </a:rPr>
-              <a:t>Kenaikan terbesar: QRE1113GR lokal Rp15.000/pcs, 3× perkiraan awal (+Rp105.000).</a:t>
+              <a:t>Kenaikan terbesar: QRE1113GR lokal Rp15.000/pcs (+Rp105.000).</a:t>
             </a:r>
             <a:endParaRPr lang="en-US" sz="1400" dirty="0"/>
           </a:p>
@@ -5430,7 +5442,7 @@
                   <a:schemeClr val="bg1"/>
                 </a:solidFill>
               </a:rPr>
-              <a:t>Sudah dihemat: MCP23017 + LED indikator dihapus, skid nilon, alat pinjam lab (−Rp85.000).</a:t>
+              <a:t>Dihemat: MCP23017 + LED dihapus, skid nilon, alat pinjam lab (−Rp85.000), mux harga toko (−Rp15.000).</a:t>
             </a:r>
             <a:endParaRPr lang="en-US" sz="1400" dirty="0"/>
           </a:p>
@@ -5448,7 +5460,7 @@
                   <a:schemeClr val="bg1"/>
                 </a:solidFill>
               </a:rPr>
-              <a:t>Sisa bisa menutup kenaikan harga atau body 3D print (belum di RAB).</a:t>
+              <a:t>Sisa untuk kenaikan harga atau body 3D print (belum di RAB).</a:t>
             </a:r>
             <a:endParaRPr lang="en-US" sz="1400" dirty="0"/>
           </a:p>
@@ -6550,7 +6562,7 @@
                   <a:schemeClr val="accent2"/>
                 </a:solidFill>
               </a:rPr>
-              <a:t>Rp902.000</a:t>
+              <a:t>Rp887.000</a:t>
             </a:r>
             <a:endParaRPr lang="en-US" sz="1800" dirty="0"/>
           </a:p>
@@ -7840,7 +7852,7 @@
                             <a:schemeClr val="bg1"/>
                           </a:solidFill>
                         </a:rPr>
-                        <a:t>IC multiplexer CD74HC4067 SOIC-24</a:t>
+                        <a:t>IC multiplexer CD74HC4067M SOP-24 (WKH Electronic)</a:t>
                       </a:r>
                       <a:endParaRPr lang="en-US" sz="1400" dirty="0"/>
                     </a:p>
@@ -7901,7 +7913,7 @@
                             <a:schemeClr val="bg1"/>
                           </a:solidFill>
                         </a:rPr>
-                        <a:t>Rp35.000</a:t>
+                        <a:t>Rp20.000</a:t>
                       </a:r>
                       <a:endParaRPr lang="en-US" sz="1400" dirty="0"/>
                     </a:p>
@@ -8023,7 +8035,7 @@
                             <a:schemeClr val="bg1"/>
                           </a:solidFill>
                         </a:rPr>
-                        <a:t>Rp35.000</a:t>
+                        <a:t>Rp20.000</a:t>
                       </a:r>
                       <a:endParaRPr lang="en-US" sz="1400" dirty="0"/>
                     </a:p>
@@ -9729,7 +9741,7 @@
                             <a:schemeClr val="bg1"/>
                           </a:solidFill>
                         </a:rPr>
-                        <a:t>Rp471.000</a:t>
+                        <a:t>Rp456.000</a:t>
                       </a:r>
                       <a:endParaRPr lang="en-US" sz="1400" dirty="0"/>
                     </a:p>
@@ -12760,7 +12772,7 @@
                             <a:schemeClr val="bg1"/>
                           </a:solidFill>
                         </a:rPr>
-                        <a:t>Rp847.000</a:t>
+                        <a:t>Rp832.000</a:t>
                       </a:r>
                       <a:endParaRPr lang="en-US" sz="1400" dirty="0"/>
                     </a:p>
@@ -14434,7 +14446,7 @@
                   <a:schemeClr val="accent2"/>
                 </a:solidFill>
               </a:rPr>
-              <a:t>Rp847.000</a:t>
+              <a:t>Rp832.000</a:t>
             </a:r>
             <a:endParaRPr lang="en-US" sz="1400" dirty="0"/>
           </a:p>
@@ -14580,7 +14592,7 @@
                   <a:schemeClr val="bg1"/>
                 </a:solidFill>
               </a:rPr>
-              <a:t>Rp902.000</a:t>
+              <a:t>Rp887.000</a:t>
             </a:r>
             <a:endParaRPr lang="en-US" sz="1400" dirty="0"/>
           </a:p>
@@ -15740,7 +15752,7 @@
                   <a:schemeClr val="accent2"/>
                 </a:solidFill>
               </a:rPr>
-              <a:t>Rp902.000</a:t>
+              <a:t>Rp887.000</a:t>
             </a:r>
             <a:endParaRPr lang="en-US" sz="3600" dirty="0"/>
           </a:p>
@@ -15754,7 +15766,7 @@
                   <a:schemeClr val="bg1"/>
                 </a:solidFill>
               </a:rPr>
-              <a:t>± 45% harga kit pembanding</a:t>
+              <a:t>± 44% harga kit pembanding</a:t>
             </a:r>
             <a:endParaRPr lang="en-US" sz="3600" dirty="0"/>
           </a:p>
@@ -16562,7 +16574,7 @@
                             <a:schemeClr val="bg1"/>
                           </a:solidFill>
                         </a:rPr>
-                        <a:t>Rp902.000</a:t>
+                        <a:t>Rp887.000</a:t>
                       </a:r>
                       <a:endParaRPr lang="en-US" sz="1400" dirty="0"/>
                     </a:p>
@@ -16623,7 +16635,7 @@
                             <a:schemeClr val="accent2"/>
                           </a:solidFill>
                         </a:rPr>
-                        <a:t>55% lebih murah</a:t>
+                        <a:t>56% lebih murah</a:t>
                       </a:r>
                       <a:endParaRPr lang="en-US" sz="1400" dirty="0"/>
                     </a:p>

</xml_diff>

<commit_message>
Deck: slide Simulasi (lintasan uji 2D, model CoppeliaSim, hasil uji logika) + naskah
Co-Authored-By: Claude Opus 5.5 <noreply@anthropic.com>
Claude-Session: https://claude.ai/code/session_0155yf5wpAX58VAfqTZWuQQK
</commit_message>
<xml_diff>
--- a/docs/pitching-rab/LFM_Pitching_RAB_P01-5.pptx
+++ b/docs/pitching-rab/LFM_Pitching_RAB_P01-5.pptx
@@ -23,9 +23,10 @@
     <p:sldId id="271" r:id="rId17"/>
     <p:sldId id="272" r:id="rId18"/>
     <p:sldId id="273" r:id="rId19"/>
+    <p:sldId id="274" r:id="rId20"/>
   </p:sldIdLst>
   <p:notesMasterIdLst>
-    <p:notesMasterId r:id="rId20"/>
+    <p:notesMasterId r:id="rId21"/>
   </p:notesMasterIdLst>
   <p:sldSz cx="12192000" cy="6858000"/>
   <p:notesSz cx="6858000" cy="12192000"/>
@@ -124,13 +125,13 @@
   <p:extLst>
     <p:ext uri="{521415D9-36F7-43E2-AB2F-B90AF26B5E84}">
       <p14:sectionLst xmlns:p14="http://schemas.microsoft.com/office/powerpoint/2010/main">
-        <p14:section name="Pembuka" id="{11e51e26-de48-c815-b1ed-3da7d32f00d5}">
+        <p14:section name="Pembuka" id="{dcdbb29b-5556-073f-8a2c-de11cf27a72c}">
           <p14:sldIdLst>
             <p14:sldId id="256"/>
             <p14:sldId id="257"/>
           </p14:sldIdLst>
         </p14:section>
-        <p14:section name="Masalah dan solusi" id="{60064b55-b994-35ad-3841-636ca2a31fad}">
+        <p14:section name="Masalah dan solusi" id="{1b9f668d-244d-4fee-09e9-f6bb2e36caae}">
           <p14:sldIdLst>
             <p14:sldId id="258"/>
             <p14:sldId id="259"/>
@@ -138,32 +139,33 @@
             <p14:sldId id="261"/>
           </p14:sldIdLst>
         </p14:section>
-        <p14:section name="Rancangan" id="{a6e05fd5-aee9-d111-44b9-cf9da7a47860}">
+        <p14:section name="Rancangan" id="{aba1cca5-c8c0-5ad9-0f30-53c388af8f3e}">
           <p14:sldIdLst>
             <p14:sldId id="262"/>
             <p14:sldId id="263"/>
             <p14:sldId id="264"/>
             <p14:sldId id="265"/>
+            <p14:sldId id="266"/>
           </p14:sldIdLst>
         </p14:section>
-        <p14:section name="Anggaran" id="{722b5b8f-739b-8224-206b-9caed72e1309}">
+        <p14:section name="Anggaran" id="{15dbebcb-3169-4de8-90ed-fad98896e5dd}">
           <p14:sldIdLst>
-            <p14:sldId id="266"/>
             <p14:sldId id="267"/>
             <p14:sldId id="268"/>
+            <p14:sldId id="269"/>
           </p14:sldIdLst>
         </p14:section>
-        <p14:section name="Penutup" id="{d93f419f-14e8-66f3-bf04-d11a517d35a2}">
+        <p14:section name="Penutup" id="{1644ada7-e173-64d5-3003-c75f23f98ab3}">
           <p14:sldIdLst>
-            <p14:sldId id="269"/>
             <p14:sldId id="270"/>
+            <p14:sldId id="271"/>
           </p14:sldIdLst>
         </p14:section>
-        <p14:section name="Lampiran" id="{7f3aa96d-3a95-51b2-7174-c5ea11273bc5}">
+        <p14:section name="Lampiran" id="{fd340a60-f382-908a-d9f1-8c95cf606e6c}">
           <p14:sldIdLst>
-            <p14:sldId id="271"/>
             <p14:sldId id="272"/>
             <p14:sldId id="273"/>
+            <p14:sldId id="274"/>
           </p14:sldIdLst>
         </p14:section>
       </p14:sectionLst>
@@ -1558,7 +1560,7 @@
           <a:p>
             <a:r>
               <a:rPr lang="en-US" dirty="0"/>
-              <a:t>Total RAB 887 ribu rupiah. Terbesar untuk fabrikasi dua PCB dan 12 sensor. Rincian lengkap tiap item ada di lampiran.</a:t>
+              <a:t>Simulasi sesuai arahan dosen. Model robot ukuran asli dibangun otomatis di CoppeliaSim dari skrip Python: roda 34 mm berjarak 91 mm, motor N20 500 RPM, dan 12 sensor di posisi PCB sensor rev B. Arena grid 30 cm dengan garis hitam 2 cm seperti lomba. Logikanya sama dengan yang akan masuk firmware: PID ikut garis dan path planning per indeks, belok diukur encoder lalu dikunci ke garis oleh sensor. Sebelum dijalankan di CoppeliaSim, logika yang sama diuji dulu di simulasi 2D (gambar kiri): rute contoh dari S ke T selesai 8,2 detik dan berhenti 9 mm dari titik tujuan; kecepatan 0,3 sampai 0,7 meter per detik lulus semua; rute terpendek otomatis juga lulus saat ada simpul terhalang.</a:t>
             </a:r>
             <a:endParaRPr lang="en-US" dirty="0"/>
           </a:p>
@@ -1646,7 +1648,7 @@
           <a:p>
             <a:r>
               <a:rPr lang="en-US" dirty="0"/>
-              <a:t>Alasan pemilihan enam komponen dengan biaya terbesar. Semua harga dari daftar harga toko (tautan di charter).</a:t>
+              <a:t>Total RAB 887 ribu rupiah. Terbesar untuk fabrikasi dua PCB dan 12 sensor. Rincian lengkap tiap item ada di lampiran.</a:t>
             </a:r>
             <a:endParaRPr lang="en-US" dirty="0"/>
           </a:p>
@@ -1734,7 +1736,7 @@
           <a:p>
             <a:r>
               <a:rPr lang="en-US" dirty="0"/>
-              <a:t>RAB sudah sepuluh kali direvisi. Kenaikan terbesar dari harga QRE1113GR lokal yang ternyata tiga kali perkiraan, sedangkan penghematan datang dari penghapusan MCP23017 dan LED indikator, skid nilon, serta alat yang dipinjam dari lab; revisi terakhir 26/10: IC multiplexer dapat harga toko 20 ribu, turun 15 ribu dari perkiraan. Dengan batas anggaran Rp1.000.000, RAB 887 ribu masih menyisakan 113 ribu (11,3 persen) untuk kenaikan harga atau item yang belum masuk RAB seperti body 3D print.</a:t>
+              <a:t>Alasan pemilihan enam komponen dengan biaya terbesar. Semua harga dari daftar harga toko (tautan di charter).</a:t>
             </a:r>
             <a:endParaRPr lang="en-US" dirty="0"/>
           </a:p>
@@ -1822,7 +1824,7 @@
           <a:p>
             <a:r>
               <a:rPr lang="en-US" dirty="0"/>
-              <a:t>Jadwal mengikuti gerbang PjBL. G1 sudah lulus 2 Oktober, hari ini bagian dari G2. Sesudah dana cair: beli komponen, uji di breadboard, lalu pesan PCB paling lambat minggu 10 untuk G3. Tiga risiko yang berkaitan dengan dana dan penanganannya.</a:t>
+              <a:t>RAB sudah sepuluh kali direvisi. Kenaikan terbesar dari harga QRE1113GR lokal yang ternyata tiga kali perkiraan, sedangkan penghematan datang dari penghapusan MCP23017 dan LED indikator, skid nilon, serta alat yang dipinjam dari lab; revisi terakhir 26/10: IC multiplexer dapat harga toko 20 ribu, turun 15 ribu dari perkiraan. Dengan batas anggaran Rp1.000.000, RAB 887 ribu masih menyisakan 113 ribu (11,3 persen) untuk kenaikan harga atau item yang belum masuk RAB seperti body 3D print.</a:t>
             </a:r>
             <a:endParaRPr lang="en-US" dirty="0"/>
           </a:p>
@@ -1910,7 +1912,7 @@
           <a:p>
             <a:r>
               <a:rPr lang="en-US" dirty="0"/>
-              <a:t>Penutup: kami mohon persetujuan dana 887 ribu rupiah. Rencana sesudah dana cair ada di sisi kanan. Terima kasih, kami siap menjawab pertanyaan.</a:t>
+              <a:t>Jadwal mengikuti gerbang PjBL. G1 sudah lulus 2 Oktober, hari ini bagian dari G2. Sesudah dana cair: beli komponen, uji di breadboard, lalu pesan PCB paling lambat minggu 10 untuk G3. Tiga risiko yang berkaitan dengan dana dan penanganannya.</a:t>
             </a:r>
             <a:endParaRPr lang="en-US" dirty="0"/>
           </a:p>
@@ -1998,7 +2000,7 @@
           <a:p>
             <a:r>
               <a:rPr lang="en-US" dirty="0"/>
-              <a:t>Rincian RAB elektrikal bagian pertama.</a:t>
+              <a:t>Penutup: kami mohon persetujuan dana 887 ribu rupiah. Rencana sesudah dana cair ada di sisi kanan. Terima kasih, kami siap menjawab pertanyaan.</a:t>
             </a:r>
             <a:endParaRPr lang="en-US" dirty="0"/>
           </a:p>
@@ -2086,7 +2088,7 @@
           <a:p>
             <a:r>
               <a:rPr lang="en-US" dirty="0"/>
-              <a:t>Rincian RAB elektrikal bagian kedua; total elektrikal 832 ribu.</a:t>
+              <a:t>Rincian RAB elektrikal bagian pertama.</a:t>
             </a:r>
             <a:endParaRPr lang="en-US" dirty="0"/>
           </a:p>
@@ -2174,7 +2176,7 @@
           <a:p>
             <a:r>
               <a:rPr lang="en-US" dirty="0"/>
-              <a:t>RAB mekanik dan rekap total 887 ribu. Lintasan uji, breadboard, dan timah di luar RAB.</a:t>
+              <a:t>Rincian RAB elektrikal bagian kedua; total elektrikal 832 ribu.</a:t>
             </a:r>
             <a:endParaRPr lang="en-US" dirty="0"/>
           </a:p>
@@ -2198,6 +2200,94 @@
             <a:fld id="{F7021451-1387-4CA6-816F-3879F97B5CBC}" type="slidenum">
               <a:rPr lang="en-US"/>
               <a:t>18</a:t>
+            </a:fld>
+            <a:endParaRPr lang="en-US"/>
+          </a:p>
+        </p:txBody>
+      </p:sp>
+    </p:spTree>
+    <p:extLst>
+      <p:ext uri="{BB962C8B-B14F-4D97-AF65-F5344CB8AC3E}">
+        <p14:creationId xmlns:p14="http://schemas.microsoft.com/office/powerpoint/2010/main" val="1024086991"/>
+      </p:ext>
+    </p:extLst>
+  </p:cSld>
+  <p:clrMapOvr>
+    <a:masterClrMapping/>
+  </p:clrMapOvr>
+</p:notes>
+</file>
+
+<file path=ppt/notesSlides/notesSlide19.xml><?xml version="1.0" encoding="utf-8"?>
+<p:notes xmlns:a="http://schemas.openxmlformats.org/drawingml/2006/main" xmlns:r="http://schemas.openxmlformats.org/officeDocument/2006/relationships" xmlns:p="http://schemas.openxmlformats.org/presentationml/2006/main">
+  <p:cSld>
+    <p:spTree>
+      <p:nvGrpSpPr>
+        <p:cNvPr id="1" name=""/>
+        <p:cNvGrpSpPr/>
+        <p:nvPr/>
+      </p:nvGrpSpPr>
+      <p:grpSpPr>
+        <a:xfrm>
+          <a:off x="0" y="0"/>
+          <a:ext cx="0" cy="0"/>
+          <a:chOff x="0" y="0"/>
+          <a:chExt cx="0" cy="0"/>
+        </a:xfrm>
+      </p:grpSpPr>
+      <p:sp>
+        <p:nvSpPr>
+          <p:cNvPr id="2" name="Slide Image Placeholder 1"/>
+          <p:cNvSpPr>
+            <a:spLocks noGrp="1" noRot="1" noChangeAspect="1"/>
+          </p:cNvSpPr>
+          <p:nvPr>
+            <p:ph type="sldImg"/>
+          </p:nvPr>
+        </p:nvSpPr>
+        <p:spPr/>
+      </p:sp>
+      <p:sp>
+        <p:nvSpPr>
+          <p:cNvPr id="3" name="Notes Placeholder 2"/>
+          <p:cNvSpPr>
+            <a:spLocks noGrp="1"/>
+          </p:cNvSpPr>
+          <p:nvPr>
+            <p:ph type="body" idx="1"/>
+          </p:nvPr>
+        </p:nvSpPr>
+        <p:spPr/>
+        <p:txBody>
+          <a:bodyPr/>
+          <a:lstStyle/>
+          <a:p>
+            <a:r>
+              <a:rPr lang="en-US" dirty="0"/>
+              <a:t>RAB mekanik dan rekap total 887 ribu. Lintasan uji, breadboard, dan timah di luar RAB.</a:t>
+            </a:r>
+            <a:endParaRPr lang="en-US" dirty="0"/>
+          </a:p>
+        </p:txBody>
+      </p:sp>
+      <p:sp>
+        <p:nvSpPr>
+          <p:cNvPr id="4" name="Slide Number Placeholder 3"/>
+          <p:cNvSpPr>
+            <a:spLocks noGrp="1"/>
+          </p:cNvSpPr>
+          <p:nvPr>
+            <p:ph type="sldNum" sz="quarter" idx="10"/>
+          </p:nvPr>
+        </p:nvSpPr>
+        <p:spPr/>
+        <p:txBody>
+          <a:bodyPr/>
+          <a:lstStyle/>
+          <a:p>
+            <a:fld id="{F7021451-1387-4CA6-816F-3879F97B5CBC}" type="slidenum">
+              <a:rPr lang="en-US"/>
+              <a:t>19</a:t>
             </a:fld>
             <a:endParaRPr lang="en-US"/>
           </a:p>
@@ -4612,7 +4702,7 @@
                   <a:schemeClr val="bg1"/>
                 </a:solidFill>
               </a:rPr>
-              <a:t>RENCANA ANGGARAN BIAYA</a:t>
+              <a:t>SIMULASI</a:t>
             </a:r>
             <a:endParaRPr lang="en-US" sz="4000" dirty="0"/>
           </a:p>
@@ -4620,64 +4710,58 @@
       </p:sp>
       <p:sp>
         <p:nvSpPr>
-          <p:cNvPr id="3" name="Total RAB"/>
+          <p:cNvPr id="3" name="Gambar simulasi bingkai"/>
+          <p:cNvSpPr/>
+          <p:nvPr/>
+        </p:nvSpPr>
+        <p:spPr>
+          <a:xfrm>
+            <a:off x="1124712" y="2048256"/>
+            <a:ext cx="3630168" cy="3630168"/>
+          </a:xfrm>
+          <a:prstGeom prst="rect">
+            <a:avLst/>
+          </a:prstGeom>
+          <a:solidFill>
+            <a:schemeClr val="bg1"/>
+          </a:solidFill>
+          <a:ln/>
+        </p:spPr>
+      </p:sp>
+      <p:pic>
+        <p:nvPicPr>
+          <p:cNvPr id="4" name="Gambar simulasi" descr="Lintasan robot hasil simulasi di arena grid 4 kali 4: dari S belok di indeks 1 sampai 5 lalu berhenti di T">    </p:cNvPr>
+          <p:cNvPicPr>
+            <a:picLocks noChangeAspect="1"/>
+          </p:cNvPicPr>
+          <p:nvPr/>
+        </p:nvPicPr>
+        <p:blipFill>
+          <a:blip r:embed="rId1"/>
+          <a:stretch>
+            <a:fillRect/>
+          </a:stretch>
+        </p:blipFill>
+        <p:spPr>
+          <a:xfrm>
+            <a:off x="1179576" y="2103120"/>
+            <a:ext cx="3520440" cy="3520440"/>
+          </a:xfrm>
+          <a:prstGeom prst="rect">
+            <a:avLst/>
+          </a:prstGeom>
+        </p:spPr>
+      </p:pic>
+      <p:sp>
+        <p:nvSpPr>
+          <p:cNvPr id="5" name="Simulasi poin"/>
           <p:cNvSpPr txBox="1"/>
           <p:nvPr/>
         </p:nvSpPr>
         <p:spPr>
           <a:xfrm>
-            <a:off x="1124712" y="2148840"/>
-            <a:ext cx="4206240" cy="1234440"/>
-          </a:xfrm>
-          <a:prstGeom prst="rect">
-            <a:avLst/>
-          </a:prstGeom>
-          <a:noFill/>
-          <a:ln/>
-        </p:spPr>
-        <p:txBody>
-          <a:bodyPr wrap="square" lIns="0" tIns="0" rIns="0" bIns="0" rtlCol="0" anchor="t"/>
-          <a:lstStyle/>
-          <a:p>
-            <a:pPr indent="0" marL="0">
-              <a:buNone/>
-            </a:pPr>
-            <a:r>
-              <a:rPr lang="en-US" sz="4800" b="1" dirty="0">
-                <a:solidFill>
-                  <a:schemeClr val="accent2"/>
-                </a:solidFill>
-              </a:rPr>
-              <a:t>Rp887.000</a:t>
-            </a:r>
-            <a:endParaRPr lang="en-US" sz="4800" dirty="0"/>
-          </a:p>
-          <a:p>
-            <a:pPr indent="0" marL="0">
-              <a:buNone/>
-            </a:pPr>
-            <a:r>
-              <a:rPr lang="en-US" sz="1600" dirty="0">
-                <a:solidFill>
-                  <a:schemeClr val="bg1"/>
-                </a:solidFill>
-              </a:rPr>
-              <a:t>Elektrikal Rp832.000 + Mekanik Rp55.000</a:t>
-            </a:r>
-            <a:endParaRPr lang="en-US" sz="4800" dirty="0"/>
-          </a:p>
-        </p:txBody>
-      </p:sp>
-      <p:sp>
-        <p:nvSpPr>
-          <p:cNvPr id="4" name="RAB poin"/>
-          <p:cNvSpPr txBox="1"/>
-          <p:nvPr/>
-        </p:nvSpPr>
-        <p:spPr>
-          <a:xfrm>
-            <a:off x="1124712" y="3611880"/>
-            <a:ext cx="4206240" cy="1965960"/>
+            <a:off x="5074920" y="2103120"/>
+            <a:ext cx="5943600" cy="1554480"/>
           </a:xfrm>
           <a:prstGeom prst="rect">
             <a:avLst/>
@@ -4702,7 +4786,7 @@
                   <a:schemeClr val="bg1"/>
                 </a:solidFill>
               </a:rPr>
-              <a:t>Porsi terbesar: fabrikasi 2 PCB (Rp200.000) dan 12 sensor QRE1113GR (Rp180.000).</a:t>
+              <a:t>Model robot ukuran asli dibangun otomatis di CoppeliaSim dari skrip Python: roda Ø34 jarak 91 mm, N20 500 RPM, 12 sensor di posisi PCB rev B.</a:t>
             </a:r>
             <a:endParaRPr lang="en-US" sz="1400" dirty="0"/>
           </a:p>
@@ -4720,17 +4804,108 @@
                   <a:schemeClr val="bg1"/>
                 </a:solidFill>
               </a:rPr>
-              <a:t>Di luar RAB: lintasan uji, breadboard dan timah (pinjam lab), software gratis (Blockly, Arduino, KiCad).</a:t>
+              <a:t>Arena grid 30 cm, garis hitam 2 cm. Logika sama dengan firmware: PID + path planning per indeks, belok diukur encoder.</a:t>
             </a:r>
             <a:endParaRPr lang="en-US" sz="1400" dirty="0"/>
           </a:p>
-          <a:p>
-            <a:pPr marL="203200" indent="-203200">
+        </p:txBody>
+      </p:sp>
+      <p:sp>
+        <p:nvSpPr>
+          <p:cNvPr id="6" name="Hasil simulasi judul"/>
+          <p:cNvSpPr txBox="1"/>
+          <p:nvPr/>
+        </p:nvSpPr>
+        <p:spPr>
+          <a:xfrm>
+            <a:off x="5074920" y="3703320"/>
+            <a:ext cx="5943600" cy="292608"/>
+          </a:xfrm>
+          <a:prstGeom prst="rect">
+            <a:avLst/>
+          </a:prstGeom>
+          <a:noFill/>
+          <a:ln/>
+        </p:spPr>
+        <p:txBody>
+          <a:bodyPr wrap="square" lIns="0" tIns="0" rIns="0" bIns="0" rtlCol="0" anchor="ctr"/>
+          <a:lstStyle/>
+          <a:p>
+            <a:pPr indent="0" marL="0">
+              <a:buNone/>
+            </a:pPr>
+            <a:r>
+              <a:rPr lang="en-US" sz="1400" b="1" dirty="0">
+                <a:solidFill>
+                  <a:schemeClr val="bg2"/>
+                </a:solidFill>
+              </a:rPr>
+              <a:t>Hasil uji logika kendali (simulasi 2D, gambar kiri):</a:t>
+            </a:r>
+            <a:endParaRPr lang="en-US" sz="1400" dirty="0"/>
+          </a:p>
+        </p:txBody>
+      </p:sp>
+      <p:sp>
+        <p:nvSpPr>
+          <p:cNvPr id="7" name="Hasil simulasi 1 latar"/>
+          <p:cNvSpPr/>
+          <p:nvPr/>
+        </p:nvSpPr>
+        <p:spPr>
+          <a:xfrm>
+            <a:off x="5074920" y="4069080"/>
+            <a:ext cx="1874520" cy="1417320"/>
+          </a:xfrm>
+          <a:prstGeom prst="rect">
+            <a:avLst/>
+          </a:prstGeom>
+          <a:solidFill>
+            <a:schemeClr val="accent1"/>
+          </a:solidFill>
+          <a:ln/>
+        </p:spPr>
+      </p:sp>
+      <p:sp>
+        <p:nvSpPr>
+          <p:cNvPr id="8" name="Hasil simulasi 1 teks"/>
+          <p:cNvSpPr txBox="1"/>
+          <p:nvPr/>
+        </p:nvSpPr>
+        <p:spPr>
+          <a:xfrm>
+            <a:off x="5239512" y="4215384"/>
+            <a:ext cx="1545336" cy="1124712"/>
+          </a:xfrm>
+          <a:prstGeom prst="rect">
+            <a:avLst/>
+          </a:prstGeom>
+          <a:noFill/>
+          <a:ln/>
+        </p:spPr>
+        <p:txBody>
+          <a:bodyPr wrap="square" lIns="0" tIns="0" rIns="0" bIns="0" rtlCol="0" anchor="t"/>
+          <a:lstStyle/>
+          <a:p>
+            <a:pPr indent="0" marL="0">
               <a:spcAft>
-                <a:spcPts val="800"/>
+                <a:spcPts val="600"/>
               </a:spcAft>
-              <a:buSzPct val="100000"/>
-              <a:buChar char="•"/>
+              <a:buNone/>
+            </a:pPr>
+            <a:r>
+              <a:rPr lang="en-US" sz="1600" b="1" dirty="0">
+                <a:solidFill>
+                  <a:schemeClr val="bg1"/>
+                </a:solidFill>
+              </a:rPr>
+              <a:t>8,2 s · 9 mm</a:t>
+            </a:r>
+            <a:endParaRPr lang="en-US" sz="1600" dirty="0"/>
+          </a:p>
+          <a:p>
+            <a:pPr indent="0" marL="0">
+              <a:buNone/>
             </a:pPr>
             <a:r>
               <a:rPr lang="en-US" sz="1400" dirty="0">
@@ -4738,28 +4913,158 @@
                   <a:schemeClr val="bg1"/>
                 </a:solidFill>
               </a:rPr>
-              <a:t>Kit Ichiduino Pro hanya pembanding, tidak dianggarkan ulang.</a:t>
+              <a:t>rute contoh S → T, berhenti 9 mm dari T</a:t>
             </a:r>
-            <a:endParaRPr lang="en-US" sz="1400" dirty="0"/>
+            <a:endParaRPr lang="en-US" sz="1600" dirty="0"/>
           </a:p>
         </p:txBody>
       </p:sp>
-      <p:graphicFrame>
-        <p:nvGraphicFramePr>
-          <p:cNvPr id="5" name="Grafik RAB per kelompok" descr="Grafik batang biaya per kelompok: PCB dan konektor 240 ribu, sensor garis 203 ribu, penggerak 170 ribu, daya dan baterai 136 ribu, otak dan antarmuka 118 ribu, mekanik lain 20 ribu"/>
-          <p:cNvGraphicFramePr/>
+      <p:sp>
+        <p:nvSpPr>
+          <p:cNvPr id="9" name="Hasil simulasi 2 latar"/>
+          <p:cNvSpPr/>
           <p:nvPr/>
-        </p:nvGraphicFramePr>
-        <p:xfrm>
-          <a:off x="5669280" y="2011680"/>
-          <a:ext cx="5440680" cy="3611880"/>
-        </p:xfrm>
-        <a:graphic xmlns:a="http://schemas.openxmlformats.org/drawingml/2006/main">
-          <a:graphicData uri="http://schemas.openxmlformats.org/drawingml/2006/chart">
-            <c:chart xmlns:c="http://schemas.openxmlformats.org/drawingml/2006/chart" r:id="rId1"/>
-          </a:graphicData>
-        </a:graphic>
-      </p:graphicFrame>
+        </p:nvSpPr>
+        <p:spPr>
+          <a:xfrm>
+            <a:off x="7086600" y="4069080"/>
+            <a:ext cx="1874520" cy="1417320"/>
+          </a:xfrm>
+          <a:prstGeom prst="rect">
+            <a:avLst/>
+          </a:prstGeom>
+          <a:solidFill>
+            <a:schemeClr val="accent1"/>
+          </a:solidFill>
+          <a:ln/>
+        </p:spPr>
+      </p:sp>
+      <p:sp>
+        <p:nvSpPr>
+          <p:cNvPr id="10" name="Hasil simulasi 2 teks"/>
+          <p:cNvSpPr txBox="1"/>
+          <p:nvPr/>
+        </p:nvSpPr>
+        <p:spPr>
+          <a:xfrm>
+            <a:off x="7251192" y="4215384"/>
+            <a:ext cx="1545336" cy="1124712"/>
+          </a:xfrm>
+          <a:prstGeom prst="rect">
+            <a:avLst/>
+          </a:prstGeom>
+          <a:noFill/>
+          <a:ln/>
+        </p:spPr>
+        <p:txBody>
+          <a:bodyPr wrap="square" lIns="0" tIns="0" rIns="0" bIns="0" rtlCol="0" anchor="t"/>
+          <a:lstStyle/>
+          <a:p>
+            <a:pPr indent="0" marL="0">
+              <a:spcAft>
+                <a:spcPts val="600"/>
+              </a:spcAft>
+              <a:buNone/>
+            </a:pPr>
+            <a:r>
+              <a:rPr lang="en-US" sz="1600" b="1" dirty="0">
+                <a:solidFill>
+                  <a:schemeClr val="bg1"/>
+                </a:solidFill>
+              </a:rPr>
+              <a:t>25 / 25 lulus</a:t>
+            </a:r>
+            <a:endParaRPr lang="en-US" sz="1600" dirty="0"/>
+          </a:p>
+          <a:p>
+            <a:pPr indent="0" marL="0">
+              <a:buNone/>
+            </a:pPr>
+            <a:r>
+              <a:rPr lang="en-US" sz="1400" dirty="0">
+                <a:solidFill>
+                  <a:schemeClr val="bg1"/>
+                </a:solidFill>
+              </a:rPr>
+              <a:t>kecepatan 0,3–0,7 m/s, 5 variasi derau sensor</a:t>
+            </a:r>
+            <a:endParaRPr lang="en-US" sz="1600" dirty="0"/>
+          </a:p>
+        </p:txBody>
+      </p:sp>
+      <p:sp>
+        <p:nvSpPr>
+          <p:cNvPr id="11" name="Hasil simulasi 3 latar"/>
+          <p:cNvSpPr/>
+          <p:nvPr/>
+        </p:nvSpPr>
+        <p:spPr>
+          <a:xfrm>
+            <a:off x="9098280" y="4069080"/>
+            <a:ext cx="1874520" cy="1417320"/>
+          </a:xfrm>
+          <a:prstGeom prst="rect">
+            <a:avLst/>
+          </a:prstGeom>
+          <a:solidFill>
+            <a:schemeClr val="accent1"/>
+          </a:solidFill>
+          <a:ln/>
+        </p:spPr>
+      </p:sp>
+      <p:sp>
+        <p:nvSpPr>
+          <p:cNvPr id="12" name="Hasil simulasi 3 teks"/>
+          <p:cNvSpPr txBox="1"/>
+          <p:nvPr/>
+        </p:nvSpPr>
+        <p:spPr>
+          <a:xfrm>
+            <a:off x="9262872" y="4215384"/>
+            <a:ext cx="1545336" cy="1124712"/>
+          </a:xfrm>
+          <a:prstGeom prst="rect">
+            <a:avLst/>
+          </a:prstGeom>
+          <a:noFill/>
+          <a:ln/>
+        </p:spPr>
+        <p:txBody>
+          <a:bodyPr wrap="square" lIns="0" tIns="0" rIns="0" bIns="0" rtlCol="0" anchor="t"/>
+          <a:lstStyle/>
+          <a:p>
+            <a:pPr indent="0" marL="0">
+              <a:spcAft>
+                <a:spcPts val="600"/>
+              </a:spcAft>
+              <a:buNone/>
+            </a:pPr>
+            <a:r>
+              <a:rPr lang="en-US" sz="1600" b="1" dirty="0">
+                <a:solidFill>
+                  <a:schemeClr val="bg1"/>
+                </a:solidFill>
+              </a:rPr>
+              <a:t>Rute otomatis</a:t>
+            </a:r>
+            <a:endParaRPr lang="en-US" sz="1600" dirty="0"/>
+          </a:p>
+          <a:p>
+            <a:pPr indent="0" marL="0">
+              <a:buNone/>
+            </a:pPr>
+            <a:r>
+              <a:rPr lang="en-US" sz="1400" dirty="0">
+                <a:solidFill>
+                  <a:schemeClr val="bg1"/>
+                </a:solidFill>
+              </a:rPr>
+              <a:t>rute terpendek, juga saat simpul terhalang kubus</a:t>
+            </a:r>
+            <a:endParaRPr lang="en-US" sz="1600" dirty="0"/>
+          </a:p>
+        </p:txBody>
+      </p:sp>
     </p:spTree>
   </p:cSld>
   <p:clrMapOvr>
@@ -4817,7 +5122,7 @@
                   <a:schemeClr val="bg1"/>
                 </a:solidFill>
               </a:rPr>
-              <a:t>ALASAN KOMPONEN UTAMA</a:t>
+              <a:t>RENCANA ANGGARAN BIAYA</a:t>
             </a:r>
             <a:endParaRPr lang="en-US" sz="4000" dirty="0"/>
           </a:p>
@@ -4825,34 +5130,14 @@
       </p:sp>
       <p:sp>
         <p:nvSpPr>
-          <p:cNvPr id="3" name="Komponen 1 latar"/>
-          <p:cNvSpPr/>
-          <p:nvPr/>
-        </p:nvSpPr>
-        <p:spPr>
-          <a:xfrm>
-            <a:off x="1124712" y="2103120"/>
-            <a:ext cx="3127248" cy="1609344"/>
-          </a:xfrm>
-          <a:prstGeom prst="rect">
-            <a:avLst/>
-          </a:prstGeom>
-          <a:solidFill>
-            <a:schemeClr val="accent1"/>
-          </a:solidFill>
-          <a:ln/>
-        </p:spPr>
-      </p:sp>
-      <p:sp>
-        <p:nvSpPr>
-          <p:cNvPr id="4" name="Komponen 1 teks"/>
+          <p:cNvPr id="3" name="Total RAB"/>
           <p:cNvSpPr txBox="1"/>
           <p:nvPr/>
         </p:nvSpPr>
         <p:spPr>
           <a:xfrm>
-            <a:off x="1289304" y="2249424"/>
-            <a:ext cx="2798064" cy="1316736"/>
+            <a:off x="1124712" y="2148840"/>
+            <a:ext cx="4206240" cy="1234440"/>
           </a:xfrm>
           <a:prstGeom prst="rect">
             <a:avLst/>
@@ -4865,24 +5150,61 @@
           <a:lstStyle/>
           <a:p>
             <a:pPr indent="0" marL="0">
-              <a:spcAft>
-                <a:spcPts val="600"/>
-              </a:spcAft>
               <a:buNone/>
             </a:pPr>
             <a:r>
-              <a:rPr lang="en-US" sz="1600" b="1" dirty="0">
+              <a:rPr lang="en-US" sz="4800" b="1" dirty="0">
+                <a:solidFill>
+                  <a:schemeClr val="accent2"/>
+                </a:solidFill>
+              </a:rPr>
+              <a:t>Rp887.000</a:t>
+            </a:r>
+            <a:endParaRPr lang="en-US" sz="4800" dirty="0"/>
+          </a:p>
+          <a:p>
+            <a:pPr indent="0" marL="0">
+              <a:buNone/>
+            </a:pPr>
+            <a:r>
+              <a:rPr lang="en-US" sz="1600" dirty="0">
                 <a:solidFill>
                   <a:schemeClr val="bg1"/>
                 </a:solidFill>
               </a:rPr>
-              <a:t>ESP32 DevKit · Rp76.000</a:t>
+              <a:t>Elektrikal Rp832.000 + Mekanik Rp55.000</a:t>
             </a:r>
-            <a:endParaRPr lang="en-US" sz="1600" dirty="0"/>
-          </a:p>
-          <a:p>
-            <a:pPr indent="0" marL="0">
-              <a:buNone/>
+            <a:endParaRPr lang="en-US" sz="4800" dirty="0"/>
+          </a:p>
+        </p:txBody>
+      </p:sp>
+      <p:sp>
+        <p:nvSpPr>
+          <p:cNvPr id="4" name="RAB poin"/>
+          <p:cNvSpPr txBox="1"/>
+          <p:nvPr/>
+        </p:nvSpPr>
+        <p:spPr>
+          <a:xfrm>
+            <a:off x="1124712" y="3611880"/>
+            <a:ext cx="4206240" cy="1965960"/>
+          </a:xfrm>
+          <a:prstGeom prst="rect">
+            <a:avLst/>
+          </a:prstGeom>
+          <a:noFill/>
+          <a:ln/>
+        </p:spPr>
+        <p:txBody>
+          <a:bodyPr wrap="square" lIns="0" tIns="0" rIns="0" bIns="0" rtlCol="0" anchor="t"/>
+          <a:lstStyle/>
+          <a:p>
+            <a:pPr marL="203200" indent="-203200">
+              <a:spcAft>
+                <a:spcPts val="800"/>
+              </a:spcAft>
+              <a:buSzPct val="100000"/>
+              <a:buChar char="•"/>
             </a:pPr>
             <a:r>
               <a:rPr lang="en-US" sz="1400" dirty="0">
@@ -4890,72 +5212,17 @@
                   <a:schemeClr val="bg1"/>
                 </a:solidFill>
               </a:rPr>
-              <a:t>240 MHz dual-core + WiFi untuk Blockly; ESP32-S3 &gt; Rp130.000</a:t>
+              <a:t>Porsi terbesar: fabrikasi 2 PCB (Rp200.000) dan 12 sensor QRE1113GR (Rp180.000).</a:t>
             </a:r>
-            <a:endParaRPr lang="en-US" sz="1600" dirty="0"/>
-          </a:p>
-        </p:txBody>
-      </p:sp>
-      <p:sp>
-        <p:nvSpPr>
-          <p:cNvPr id="5" name="Komponen 2 latar"/>
-          <p:cNvSpPr/>
-          <p:nvPr/>
-        </p:nvSpPr>
-        <p:spPr>
-          <a:xfrm>
-            <a:off x="4416552" y="2103120"/>
-            <a:ext cx="3127248" cy="1609344"/>
-          </a:xfrm>
-          <a:prstGeom prst="rect">
-            <a:avLst/>
-          </a:prstGeom>
-          <a:solidFill>
-            <a:schemeClr val="accent1"/>
-          </a:solidFill>
-          <a:ln/>
-        </p:spPr>
-      </p:sp>
-      <p:sp>
-        <p:nvSpPr>
-          <p:cNvPr id="6" name="Komponen 2 teks"/>
-          <p:cNvSpPr txBox="1"/>
-          <p:nvPr/>
-        </p:nvSpPr>
-        <p:spPr>
-          <a:xfrm>
-            <a:off x="4581144" y="2249424"/>
-            <a:ext cx="2798064" cy="1316736"/>
-          </a:xfrm>
-          <a:prstGeom prst="rect">
-            <a:avLst/>
-          </a:prstGeom>
-          <a:noFill/>
-          <a:ln/>
-        </p:spPr>
-        <p:txBody>
-          <a:bodyPr wrap="square" lIns="0" tIns="0" rIns="0" bIns="0" rtlCol="0" anchor="t"/>
-          <a:lstStyle/>
-          <a:p>
-            <a:pPr indent="0" marL="0">
+            <a:endParaRPr lang="en-US" sz="1400" dirty="0"/>
+          </a:p>
+          <a:p>
+            <a:pPr marL="203200" indent="-203200">
               <a:spcAft>
-                <a:spcPts val="600"/>
+                <a:spcPts val="800"/>
               </a:spcAft>
-              <a:buNone/>
-            </a:pPr>
-            <a:r>
-              <a:rPr lang="en-US" sz="1600" b="1" dirty="0">
-                <a:solidFill>
-                  <a:schemeClr val="bg1"/>
-                </a:solidFill>
-              </a:rPr>
-              <a:t>12× QRE1113GR · Rp180.000</a:t>
-            </a:r>
-            <a:endParaRPr lang="en-US" sz="1600" dirty="0"/>
-          </a:p>
-          <a:p>
-            <a:pPr indent="0" marL="0">
-              <a:buNone/>
+              <a:buSzPct val="100000"/>
+              <a:buChar char="•"/>
             </a:pPr>
             <a:r>
               <a:rPr lang="en-US" sz="1400" dirty="0">
@@ -4963,72 +5230,17 @@
                   <a:schemeClr val="bg1"/>
                 </a:solidFill>
               </a:rPr>
-              <a:t>LED IR + fototransistor satu kemasan bersekat: papan tipis, sensor ± 3 mm dari lantai</a:t>
+              <a:t>Di luar RAB: lintasan uji, breadboard dan timah (pinjam lab), software gratis (Blockly, Arduino, KiCad).</a:t>
             </a:r>
-            <a:endParaRPr lang="en-US" sz="1600" dirty="0"/>
-          </a:p>
-        </p:txBody>
-      </p:sp>
-      <p:sp>
-        <p:nvSpPr>
-          <p:cNvPr id="7" name="Komponen 3 latar"/>
-          <p:cNvSpPr/>
-          <p:nvPr/>
-        </p:nvSpPr>
-        <p:spPr>
-          <a:xfrm>
-            <a:off x="7708392" y="2103120"/>
-            <a:ext cx="3127248" cy="1609344"/>
-          </a:xfrm>
-          <a:prstGeom prst="rect">
-            <a:avLst/>
-          </a:prstGeom>
-          <a:solidFill>
-            <a:schemeClr val="accent1"/>
-          </a:solidFill>
-          <a:ln/>
-        </p:spPr>
-      </p:sp>
-      <p:sp>
-        <p:nvSpPr>
-          <p:cNvPr id="8" name="Komponen 3 teks"/>
-          <p:cNvSpPr txBox="1"/>
-          <p:nvPr/>
-        </p:nvSpPr>
-        <p:spPr>
-          <a:xfrm>
-            <a:off x="7872984" y="2249424"/>
-            <a:ext cx="2798064" cy="1316736"/>
-          </a:xfrm>
-          <a:prstGeom prst="rect">
-            <a:avLst/>
-          </a:prstGeom>
-          <a:noFill/>
-          <a:ln/>
-        </p:spPr>
-        <p:txBody>
-          <a:bodyPr wrap="square" lIns="0" tIns="0" rIns="0" bIns="0" rtlCol="0" anchor="t"/>
-          <a:lstStyle/>
-          <a:p>
-            <a:pPr indent="0" marL="0">
+            <a:endParaRPr lang="en-US" sz="1400" dirty="0"/>
+          </a:p>
+          <a:p>
+            <a:pPr marL="203200" indent="-203200">
               <a:spcAft>
-                <a:spcPts val="600"/>
+                <a:spcPts val="800"/>
               </a:spcAft>
-              <a:buNone/>
-            </a:pPr>
-            <a:r>
-              <a:rPr lang="en-US" sz="1600" b="1" dirty="0">
-                <a:solidFill>
-                  <a:schemeClr val="bg1"/>
-                </a:solidFill>
-              </a:rPr>
-              <a:t>2× N20 + encoder · Rp110.000</a:t>
-            </a:r>
-            <a:endParaRPr lang="en-US" sz="1600" dirty="0"/>
-          </a:p>
-          <a:p>
-            <a:pPr indent="0" marL="0">
-              <a:buNone/>
+              <a:buSzPct val="100000"/>
+              <a:buChar char="•"/>
             </a:pPr>
             <a:r>
               <a:rPr lang="en-US" sz="1400" dirty="0">
@@ -5036,231 +5248,28 @@
                   <a:schemeClr val="bg1"/>
                 </a:solidFill>
               </a:rPr>
-              <a:t>v maks 0,89 m/s (sasaran ≥ 0,5 m/s); encoder untuk belok 90° dan jarak tempuh</a:t>
+              <a:t>Kit Ichiduino Pro hanya pembanding, tidak dianggarkan ulang.</a:t>
             </a:r>
-            <a:endParaRPr lang="en-US" sz="1600" dirty="0"/>
+            <a:endParaRPr lang="en-US" sz="1400" dirty="0"/>
           </a:p>
         </p:txBody>
       </p:sp>
-      <p:sp>
-        <p:nvSpPr>
-          <p:cNvPr id="9" name="Komponen 4 latar"/>
-          <p:cNvSpPr/>
+      <p:graphicFrame>
+        <p:nvGraphicFramePr>
+          <p:cNvPr id="5" name="Grafik RAB per kelompok" descr="Grafik batang biaya per kelompok: PCB dan konektor 240 ribu, sensor garis 203 ribu, penggerak 170 ribu, daya dan baterai 136 ribu, otak dan antarmuka 118 ribu, mekanik lain 20 ribu"/>
+          <p:cNvGraphicFramePr/>
           <p:nvPr/>
-        </p:nvSpPr>
-        <p:spPr>
-          <a:xfrm>
-            <a:off x="1124712" y="3858768"/>
-            <a:ext cx="3127248" cy="1609344"/>
-          </a:xfrm>
-          <a:prstGeom prst="rect">
-            <a:avLst/>
-          </a:prstGeom>
-          <a:solidFill>
-            <a:schemeClr val="accent1"/>
-          </a:solidFill>
-          <a:ln/>
-        </p:spPr>
-      </p:sp>
-      <p:sp>
-        <p:nvSpPr>
-          <p:cNvPr id="10" name="Komponen 4 teks"/>
-          <p:cNvSpPr txBox="1"/>
-          <p:nvPr/>
-        </p:nvSpPr>
-        <p:spPr>
-          <a:xfrm>
-            <a:off x="1289304" y="4005072"/>
-            <a:ext cx="2798064" cy="1316736"/>
-          </a:xfrm>
-          <a:prstGeom prst="rect">
-            <a:avLst/>
-          </a:prstGeom>
-          <a:noFill/>
-          <a:ln/>
-        </p:spPr>
-        <p:txBody>
-          <a:bodyPr wrap="square" lIns="0" tIns="0" rIns="0" bIns="0" rtlCol="0" anchor="t"/>
-          <a:lstStyle/>
-          <a:p>
-            <a:pPr indent="0" marL="0">
-              <a:spcAft>
-                <a:spcPts val="600"/>
-              </a:spcAft>
-              <a:buNone/>
-            </a:pPr>
-            <a:r>
-              <a:rPr lang="en-US" sz="1600" b="1" dirty="0">
-                <a:solidFill>
-                  <a:schemeClr val="bg1"/>
-                </a:solidFill>
-              </a:rPr>
-              <a:t>TB6612FNG · Rp25.000</a:t>
-            </a:r>
-            <a:endParaRPr lang="en-US" sz="1600" dirty="0"/>
-          </a:p>
-          <a:p>
-            <a:pPr indent="0" marL="0">
-              <a:buNone/>
-            </a:pPr>
-            <a:r>
-              <a:rPr lang="en-US" sz="1400" dirty="0">
-                <a:solidFill>
-                  <a:schemeClr val="bg1"/>
-                </a:solidFill>
-              </a:rPr>
-              <a:t>Tegangan jatuh jauh lebih kecil dari L298N, sehingga tidak panas</a:t>
-            </a:r>
-            <a:endParaRPr lang="en-US" sz="1600" dirty="0"/>
-          </a:p>
-        </p:txBody>
-      </p:sp>
-      <p:sp>
-        <p:nvSpPr>
-          <p:cNvPr id="11" name="Komponen 5 latar"/>
-          <p:cNvSpPr/>
-          <p:nvPr/>
-        </p:nvSpPr>
-        <p:spPr>
-          <a:xfrm>
-            <a:off x="4416552" y="3858768"/>
-            <a:ext cx="3127248" cy="1609344"/>
-          </a:xfrm>
-          <a:prstGeom prst="rect">
-            <a:avLst/>
-          </a:prstGeom>
-          <a:solidFill>
-            <a:schemeClr val="accent1"/>
-          </a:solidFill>
-          <a:ln/>
-        </p:spPr>
-      </p:sp>
-      <p:sp>
-        <p:nvSpPr>
-          <p:cNvPr id="12" name="Komponen 5 teks"/>
-          <p:cNvSpPr txBox="1"/>
-          <p:nvPr/>
-        </p:nvSpPr>
-        <p:spPr>
-          <a:xfrm>
-            <a:off x="4581144" y="4005072"/>
-            <a:ext cx="2798064" cy="1316736"/>
-          </a:xfrm>
-          <a:prstGeom prst="rect">
-            <a:avLst/>
-          </a:prstGeom>
-          <a:noFill/>
-          <a:ln/>
-        </p:spPr>
-        <p:txBody>
-          <a:bodyPr wrap="square" lIns="0" tIns="0" rIns="0" bIns="0" rtlCol="0" anchor="t"/>
-          <a:lstStyle/>
-          <a:p>
-            <a:pPr indent="0" marL="0">
-              <a:spcAft>
-                <a:spcPts val="600"/>
-              </a:spcAft>
-              <a:buNone/>
-            </a:pPr>
-            <a:r>
-              <a:rPr lang="en-US" sz="1600" b="1" dirty="0">
-                <a:solidFill>
-                  <a:schemeClr val="bg1"/>
-                </a:solidFill>
-              </a:rPr>
-              <a:t>2× 18650 + BMS + charger · Rp115.000</a:t>
-            </a:r>
-            <a:endParaRPr lang="en-US" sz="1600" dirty="0"/>
-          </a:p>
-          <a:p>
-            <a:pPr indent="0" marL="0">
-              <a:buNone/>
-            </a:pPr>
-            <a:r>
-              <a:rPr lang="en-US" sz="1400" dirty="0">
-                <a:solidFill>
-                  <a:schemeClr val="bg1"/>
-                </a:solidFill>
-              </a:rPr>
-              <a:t>± 3 jam pemakaian, dilindungi BMS, diisi lewat USB-C</a:t>
-            </a:r>
-            <a:endParaRPr lang="en-US" sz="1600" dirty="0"/>
-          </a:p>
-        </p:txBody>
-      </p:sp>
-      <p:sp>
-        <p:nvSpPr>
-          <p:cNvPr id="13" name="Komponen 6 latar"/>
-          <p:cNvSpPr/>
-          <p:nvPr/>
-        </p:nvSpPr>
-        <p:spPr>
-          <a:xfrm>
-            <a:off x="7708392" y="3858768"/>
-            <a:ext cx="3127248" cy="1609344"/>
-          </a:xfrm>
-          <a:prstGeom prst="rect">
-            <a:avLst/>
-          </a:prstGeom>
-          <a:solidFill>
-            <a:schemeClr val="accent1"/>
-          </a:solidFill>
-          <a:ln/>
-        </p:spPr>
-      </p:sp>
-      <p:sp>
-        <p:nvSpPr>
-          <p:cNvPr id="14" name="Komponen 6 teks"/>
-          <p:cNvSpPr txBox="1"/>
-          <p:nvPr/>
-        </p:nvSpPr>
-        <p:spPr>
-          <a:xfrm>
-            <a:off x="7872984" y="4005072"/>
-            <a:ext cx="2798064" cy="1316736"/>
-          </a:xfrm>
-          <a:prstGeom prst="rect">
-            <a:avLst/>
-          </a:prstGeom>
-          <a:noFill/>
-          <a:ln/>
-        </p:spPr>
-        <p:txBody>
-          <a:bodyPr wrap="square" lIns="0" tIns="0" rIns="0" bIns="0" rtlCol="0" anchor="t"/>
-          <a:lstStyle/>
-          <a:p>
-            <a:pPr indent="0" marL="0">
-              <a:spcAft>
-                <a:spcPts val="600"/>
-              </a:spcAft>
-              <a:buNone/>
-            </a:pPr>
-            <a:r>
-              <a:rPr lang="en-US" sz="1600" b="1" dirty="0">
-                <a:solidFill>
-                  <a:schemeClr val="bg1"/>
-                </a:solidFill>
-              </a:rPr>
-              <a:t>Fabrikasi 2 PCB · Rp200.000</a:t>
-            </a:r>
-            <a:endParaRPr lang="en-US" sz="1600" dirty="0"/>
-          </a:p>
-          <a:p>
-            <a:pPr indent="0" marL="0">
-              <a:buNone/>
-            </a:pPr>
-            <a:r>
-              <a:rPr lang="en-US" sz="1400" dirty="0">
-                <a:solidFill>
-                  <a:schemeClr val="bg1"/>
-                </a:solidFill>
-              </a:rPr>
-              <a:t>Papan custom menggantikan kabel breadboard: rapi dan awet dipakai siswa</a:t>
-            </a:r>
-            <a:endParaRPr lang="en-US" sz="1600" dirty="0"/>
-          </a:p>
-        </p:txBody>
-      </p:sp>
+        </p:nvGraphicFramePr>
+        <p:xfrm>
+          <a:off x="5669280" y="2011680"/>
+          <a:ext cx="5440680" cy="3611880"/>
+        </p:xfrm>
+        <a:graphic xmlns:a="http://schemas.openxmlformats.org/drawingml/2006/main">
+          <a:graphicData uri="http://schemas.openxmlformats.org/drawingml/2006/chart">
+            <c:chart xmlns:c="http://schemas.openxmlformats.org/drawingml/2006/chart" r:id="rId1"/>
+          </a:graphicData>
+        </a:graphic>
+      </p:graphicFrame>
     </p:spTree>
   </p:cSld>
   <p:clrMapOvr>
@@ -5318,38 +5327,42 @@
                   <a:schemeClr val="bg1"/>
                 </a:solidFill>
               </a:rPr>
-              <a:t>RIWAYAT RAB &amp; EFISIENSI</a:t>
+              <a:t>ALASAN KOMPONEN UTAMA</a:t>
             </a:r>
             <a:endParaRPr lang="en-US" sz="4000" dirty="0"/>
           </a:p>
         </p:txBody>
       </p:sp>
-      <p:graphicFrame>
-        <p:nvGraphicFramePr>
-          <p:cNvPr id="3" name="Grafik riwayat RAB" descr="Grafik garis total RAB per revisi antara 833 dan 902 ribu rupiah, terakhir 887 ribu, dengan garis batas 1 juta rupiah"/>
-          <p:cNvGraphicFramePr/>
+      <p:sp>
+        <p:nvSpPr>
+          <p:cNvPr id="3" name="Komponen 1 latar"/>
+          <p:cNvSpPr/>
           <p:nvPr/>
-        </p:nvGraphicFramePr>
-        <p:xfrm>
-          <a:off x="1051560" y="2011680"/>
-          <a:ext cx="6400800" cy="3611880"/>
-        </p:xfrm>
-        <a:graphic xmlns:a="http://schemas.openxmlformats.org/drawingml/2006/main">
-          <a:graphicData uri="http://schemas.openxmlformats.org/drawingml/2006/chart">
-            <c:chart xmlns:c="http://schemas.openxmlformats.org/drawingml/2006/chart" r:id="rId1"/>
-          </a:graphicData>
-        </a:graphic>
-      </p:graphicFrame>
-      <p:sp>
-        <p:nvSpPr>
-          <p:cNvPr id="4" name="Selisih anggaran"/>
+        </p:nvSpPr>
+        <p:spPr>
+          <a:xfrm>
+            <a:off x="1124712" y="2103120"/>
+            <a:ext cx="3127248" cy="1609344"/>
+          </a:xfrm>
+          <a:prstGeom prst="rect">
+            <a:avLst/>
+          </a:prstGeom>
+          <a:solidFill>
+            <a:schemeClr val="accent1"/>
+          </a:solidFill>
+          <a:ln/>
+        </p:spPr>
+      </p:sp>
+      <p:sp>
+        <p:nvSpPr>
+          <p:cNvPr id="4" name="Komponen 1 teks"/>
           <p:cNvSpPr txBox="1"/>
           <p:nvPr/>
         </p:nvSpPr>
         <p:spPr>
           <a:xfrm>
-            <a:off x="7726680" y="2103120"/>
-            <a:ext cx="3383280" cy="1143000"/>
+            <a:off x="1289304" y="2249424"/>
+            <a:ext cx="2798064" cy="1316736"/>
           </a:xfrm>
           <a:prstGeom prst="rect">
             <a:avLst/>
@@ -5362,61 +5375,24 @@
           <a:lstStyle/>
           <a:p>
             <a:pPr indent="0" marL="0">
+              <a:spcAft>
+                <a:spcPts val="600"/>
+              </a:spcAft>
               <a:buNone/>
             </a:pPr>
             <a:r>
-              <a:rPr lang="en-US" sz="3600" b="1" dirty="0">
-                <a:solidFill>
-                  <a:schemeClr val="accent2"/>
-                </a:solidFill>
-              </a:rPr>
-              <a:t>Sisa Rp113.000</a:t>
-            </a:r>
-            <a:endParaRPr lang="en-US" sz="3600" dirty="0"/>
-          </a:p>
-          <a:p>
-            <a:pPr indent="0" marL="0">
-              <a:buNone/>
-            </a:pPr>
-            <a:r>
-              <a:rPr lang="en-US" sz="1600" dirty="0">
+              <a:rPr lang="en-US" sz="1600" b="1" dirty="0">
                 <a:solidFill>
                   <a:schemeClr val="bg1"/>
                 </a:solidFill>
               </a:rPr>
-              <a:t>(11,3%) di bawah batas Rp1.000.000</a:t>
+              <a:t>ESP32 DevKit · Rp76.000</a:t>
             </a:r>
-            <a:endParaRPr lang="en-US" sz="3600" dirty="0"/>
-          </a:p>
-        </p:txBody>
-      </p:sp>
-      <p:sp>
-        <p:nvSpPr>
-          <p:cNvPr id="5" name="Selisih poin"/>
-          <p:cNvSpPr txBox="1"/>
-          <p:nvPr/>
-        </p:nvSpPr>
-        <p:spPr>
-          <a:xfrm>
-            <a:off x="7726680" y="3200400"/>
-            <a:ext cx="3383280" cy="2103120"/>
-          </a:xfrm>
-          <a:prstGeom prst="rect">
-            <a:avLst/>
-          </a:prstGeom>
-          <a:noFill/>
-          <a:ln/>
-        </p:spPr>
-        <p:txBody>
-          <a:bodyPr wrap="square" lIns="0" tIns="0" rIns="0" bIns="0" rtlCol="0" anchor="t"/>
-          <a:lstStyle/>
-          <a:p>
-            <a:pPr marL="203200" indent="-203200">
-              <a:spcAft>
-                <a:spcPts val="800"/>
-              </a:spcAft>
-              <a:buSzPct val="100000"/>
-              <a:buChar char="•"/>
+            <a:endParaRPr lang="en-US" sz="1600" dirty="0"/>
+          </a:p>
+          <a:p>
+            <a:pPr indent="0" marL="0">
+              <a:buNone/>
             </a:pPr>
             <a:r>
               <a:rPr lang="en-US" sz="1400" dirty="0">
@@ -5424,17 +5400,72 @@
                   <a:schemeClr val="bg1"/>
                 </a:solidFill>
               </a:rPr>
-              <a:t>Kenaikan terbesar: QRE1113GR lokal Rp15.000/pcs (+Rp105.000).</a:t>
+              <a:t>240 MHz dual-core + WiFi untuk Blockly; ESP32-S3 &gt; Rp130.000</a:t>
             </a:r>
-            <a:endParaRPr lang="en-US" sz="1400" dirty="0"/>
-          </a:p>
-          <a:p>
-            <a:pPr marL="203200" indent="-203200">
+            <a:endParaRPr lang="en-US" sz="1600" dirty="0"/>
+          </a:p>
+        </p:txBody>
+      </p:sp>
+      <p:sp>
+        <p:nvSpPr>
+          <p:cNvPr id="5" name="Komponen 2 latar"/>
+          <p:cNvSpPr/>
+          <p:nvPr/>
+        </p:nvSpPr>
+        <p:spPr>
+          <a:xfrm>
+            <a:off x="4416552" y="2103120"/>
+            <a:ext cx="3127248" cy="1609344"/>
+          </a:xfrm>
+          <a:prstGeom prst="rect">
+            <a:avLst/>
+          </a:prstGeom>
+          <a:solidFill>
+            <a:schemeClr val="accent1"/>
+          </a:solidFill>
+          <a:ln/>
+        </p:spPr>
+      </p:sp>
+      <p:sp>
+        <p:nvSpPr>
+          <p:cNvPr id="6" name="Komponen 2 teks"/>
+          <p:cNvSpPr txBox="1"/>
+          <p:nvPr/>
+        </p:nvSpPr>
+        <p:spPr>
+          <a:xfrm>
+            <a:off x="4581144" y="2249424"/>
+            <a:ext cx="2798064" cy="1316736"/>
+          </a:xfrm>
+          <a:prstGeom prst="rect">
+            <a:avLst/>
+          </a:prstGeom>
+          <a:noFill/>
+          <a:ln/>
+        </p:spPr>
+        <p:txBody>
+          <a:bodyPr wrap="square" lIns="0" tIns="0" rIns="0" bIns="0" rtlCol="0" anchor="t"/>
+          <a:lstStyle/>
+          <a:p>
+            <a:pPr indent="0" marL="0">
               <a:spcAft>
-                <a:spcPts val="800"/>
+                <a:spcPts val="600"/>
               </a:spcAft>
-              <a:buSzPct val="100000"/>
-              <a:buChar char="•"/>
+              <a:buNone/>
+            </a:pPr>
+            <a:r>
+              <a:rPr lang="en-US" sz="1600" b="1" dirty="0">
+                <a:solidFill>
+                  <a:schemeClr val="bg1"/>
+                </a:solidFill>
+              </a:rPr>
+              <a:t>12× QRE1113GR · Rp180.000</a:t>
+            </a:r>
+            <a:endParaRPr lang="en-US" sz="1600" dirty="0"/>
+          </a:p>
+          <a:p>
+            <a:pPr indent="0" marL="0">
+              <a:buNone/>
             </a:pPr>
             <a:r>
               <a:rPr lang="en-US" sz="1400" dirty="0">
@@ -5442,17 +5473,72 @@
                   <a:schemeClr val="bg1"/>
                 </a:solidFill>
               </a:rPr>
-              <a:t>Dihemat: MCP23017 + LED dihapus, skid nilon, alat pinjam lab (−Rp85.000), mux harga toko (−Rp15.000).</a:t>
+              <a:t>LED IR + fototransistor satu kemasan bersekat: papan tipis, sensor ± 3 mm dari lantai</a:t>
             </a:r>
-            <a:endParaRPr lang="en-US" sz="1400" dirty="0"/>
-          </a:p>
-          <a:p>
-            <a:pPr marL="203200" indent="-203200">
+            <a:endParaRPr lang="en-US" sz="1600" dirty="0"/>
+          </a:p>
+        </p:txBody>
+      </p:sp>
+      <p:sp>
+        <p:nvSpPr>
+          <p:cNvPr id="7" name="Komponen 3 latar"/>
+          <p:cNvSpPr/>
+          <p:nvPr/>
+        </p:nvSpPr>
+        <p:spPr>
+          <a:xfrm>
+            <a:off x="7708392" y="2103120"/>
+            <a:ext cx="3127248" cy="1609344"/>
+          </a:xfrm>
+          <a:prstGeom prst="rect">
+            <a:avLst/>
+          </a:prstGeom>
+          <a:solidFill>
+            <a:schemeClr val="accent1"/>
+          </a:solidFill>
+          <a:ln/>
+        </p:spPr>
+      </p:sp>
+      <p:sp>
+        <p:nvSpPr>
+          <p:cNvPr id="8" name="Komponen 3 teks"/>
+          <p:cNvSpPr txBox="1"/>
+          <p:nvPr/>
+        </p:nvSpPr>
+        <p:spPr>
+          <a:xfrm>
+            <a:off x="7872984" y="2249424"/>
+            <a:ext cx="2798064" cy="1316736"/>
+          </a:xfrm>
+          <a:prstGeom prst="rect">
+            <a:avLst/>
+          </a:prstGeom>
+          <a:noFill/>
+          <a:ln/>
+        </p:spPr>
+        <p:txBody>
+          <a:bodyPr wrap="square" lIns="0" tIns="0" rIns="0" bIns="0" rtlCol="0" anchor="t"/>
+          <a:lstStyle/>
+          <a:p>
+            <a:pPr indent="0" marL="0">
               <a:spcAft>
-                <a:spcPts val="800"/>
+                <a:spcPts val="600"/>
               </a:spcAft>
-              <a:buSzPct val="100000"/>
-              <a:buChar char="•"/>
+              <a:buNone/>
+            </a:pPr>
+            <a:r>
+              <a:rPr lang="en-US" sz="1600" b="1" dirty="0">
+                <a:solidFill>
+                  <a:schemeClr val="bg1"/>
+                </a:solidFill>
+              </a:rPr>
+              <a:t>2× N20 + encoder · Rp110.000</a:t>
+            </a:r>
+            <a:endParaRPr lang="en-US" sz="1600" dirty="0"/>
+          </a:p>
+          <a:p>
+            <a:pPr indent="0" marL="0">
+              <a:buNone/>
             </a:pPr>
             <a:r>
               <a:rPr lang="en-US" sz="1400" dirty="0">
@@ -5460,9 +5546,228 @@
                   <a:schemeClr val="bg1"/>
                 </a:solidFill>
               </a:rPr>
-              <a:t>Sisa untuk kenaikan harga atau body 3D print (belum di RAB).</a:t>
+              <a:t>v maks 0,89 m/s (sasaran ≥ 0,5 m/s); encoder untuk belok 90° dan jarak tempuh</a:t>
             </a:r>
-            <a:endParaRPr lang="en-US" sz="1400" dirty="0"/>
+            <a:endParaRPr lang="en-US" sz="1600" dirty="0"/>
+          </a:p>
+        </p:txBody>
+      </p:sp>
+      <p:sp>
+        <p:nvSpPr>
+          <p:cNvPr id="9" name="Komponen 4 latar"/>
+          <p:cNvSpPr/>
+          <p:nvPr/>
+        </p:nvSpPr>
+        <p:spPr>
+          <a:xfrm>
+            <a:off x="1124712" y="3858768"/>
+            <a:ext cx="3127248" cy="1609344"/>
+          </a:xfrm>
+          <a:prstGeom prst="rect">
+            <a:avLst/>
+          </a:prstGeom>
+          <a:solidFill>
+            <a:schemeClr val="accent1"/>
+          </a:solidFill>
+          <a:ln/>
+        </p:spPr>
+      </p:sp>
+      <p:sp>
+        <p:nvSpPr>
+          <p:cNvPr id="10" name="Komponen 4 teks"/>
+          <p:cNvSpPr txBox="1"/>
+          <p:nvPr/>
+        </p:nvSpPr>
+        <p:spPr>
+          <a:xfrm>
+            <a:off x="1289304" y="4005072"/>
+            <a:ext cx="2798064" cy="1316736"/>
+          </a:xfrm>
+          <a:prstGeom prst="rect">
+            <a:avLst/>
+          </a:prstGeom>
+          <a:noFill/>
+          <a:ln/>
+        </p:spPr>
+        <p:txBody>
+          <a:bodyPr wrap="square" lIns="0" tIns="0" rIns="0" bIns="0" rtlCol="0" anchor="t"/>
+          <a:lstStyle/>
+          <a:p>
+            <a:pPr indent="0" marL="0">
+              <a:spcAft>
+                <a:spcPts val="600"/>
+              </a:spcAft>
+              <a:buNone/>
+            </a:pPr>
+            <a:r>
+              <a:rPr lang="en-US" sz="1600" b="1" dirty="0">
+                <a:solidFill>
+                  <a:schemeClr val="bg1"/>
+                </a:solidFill>
+              </a:rPr>
+              <a:t>TB6612FNG · Rp25.000</a:t>
+            </a:r>
+            <a:endParaRPr lang="en-US" sz="1600" dirty="0"/>
+          </a:p>
+          <a:p>
+            <a:pPr indent="0" marL="0">
+              <a:buNone/>
+            </a:pPr>
+            <a:r>
+              <a:rPr lang="en-US" sz="1400" dirty="0">
+                <a:solidFill>
+                  <a:schemeClr val="bg1"/>
+                </a:solidFill>
+              </a:rPr>
+              <a:t>Tegangan jatuh jauh lebih kecil dari L298N, sehingga tidak panas</a:t>
+            </a:r>
+            <a:endParaRPr lang="en-US" sz="1600" dirty="0"/>
+          </a:p>
+        </p:txBody>
+      </p:sp>
+      <p:sp>
+        <p:nvSpPr>
+          <p:cNvPr id="11" name="Komponen 5 latar"/>
+          <p:cNvSpPr/>
+          <p:nvPr/>
+        </p:nvSpPr>
+        <p:spPr>
+          <a:xfrm>
+            <a:off x="4416552" y="3858768"/>
+            <a:ext cx="3127248" cy="1609344"/>
+          </a:xfrm>
+          <a:prstGeom prst="rect">
+            <a:avLst/>
+          </a:prstGeom>
+          <a:solidFill>
+            <a:schemeClr val="accent1"/>
+          </a:solidFill>
+          <a:ln/>
+        </p:spPr>
+      </p:sp>
+      <p:sp>
+        <p:nvSpPr>
+          <p:cNvPr id="12" name="Komponen 5 teks"/>
+          <p:cNvSpPr txBox="1"/>
+          <p:nvPr/>
+        </p:nvSpPr>
+        <p:spPr>
+          <a:xfrm>
+            <a:off x="4581144" y="4005072"/>
+            <a:ext cx="2798064" cy="1316736"/>
+          </a:xfrm>
+          <a:prstGeom prst="rect">
+            <a:avLst/>
+          </a:prstGeom>
+          <a:noFill/>
+          <a:ln/>
+        </p:spPr>
+        <p:txBody>
+          <a:bodyPr wrap="square" lIns="0" tIns="0" rIns="0" bIns="0" rtlCol="0" anchor="t"/>
+          <a:lstStyle/>
+          <a:p>
+            <a:pPr indent="0" marL="0">
+              <a:spcAft>
+                <a:spcPts val="600"/>
+              </a:spcAft>
+              <a:buNone/>
+            </a:pPr>
+            <a:r>
+              <a:rPr lang="en-US" sz="1600" b="1" dirty="0">
+                <a:solidFill>
+                  <a:schemeClr val="bg1"/>
+                </a:solidFill>
+              </a:rPr>
+              <a:t>2× 18650 + BMS + charger · Rp115.000</a:t>
+            </a:r>
+            <a:endParaRPr lang="en-US" sz="1600" dirty="0"/>
+          </a:p>
+          <a:p>
+            <a:pPr indent="0" marL="0">
+              <a:buNone/>
+            </a:pPr>
+            <a:r>
+              <a:rPr lang="en-US" sz="1400" dirty="0">
+                <a:solidFill>
+                  <a:schemeClr val="bg1"/>
+                </a:solidFill>
+              </a:rPr>
+              <a:t>± 3 jam pemakaian, dilindungi BMS, diisi lewat USB-C</a:t>
+            </a:r>
+            <a:endParaRPr lang="en-US" sz="1600" dirty="0"/>
+          </a:p>
+        </p:txBody>
+      </p:sp>
+      <p:sp>
+        <p:nvSpPr>
+          <p:cNvPr id="13" name="Komponen 6 latar"/>
+          <p:cNvSpPr/>
+          <p:nvPr/>
+        </p:nvSpPr>
+        <p:spPr>
+          <a:xfrm>
+            <a:off x="7708392" y="3858768"/>
+            <a:ext cx="3127248" cy="1609344"/>
+          </a:xfrm>
+          <a:prstGeom prst="rect">
+            <a:avLst/>
+          </a:prstGeom>
+          <a:solidFill>
+            <a:schemeClr val="accent1"/>
+          </a:solidFill>
+          <a:ln/>
+        </p:spPr>
+      </p:sp>
+      <p:sp>
+        <p:nvSpPr>
+          <p:cNvPr id="14" name="Komponen 6 teks"/>
+          <p:cNvSpPr txBox="1"/>
+          <p:nvPr/>
+        </p:nvSpPr>
+        <p:spPr>
+          <a:xfrm>
+            <a:off x="7872984" y="4005072"/>
+            <a:ext cx="2798064" cy="1316736"/>
+          </a:xfrm>
+          <a:prstGeom prst="rect">
+            <a:avLst/>
+          </a:prstGeom>
+          <a:noFill/>
+          <a:ln/>
+        </p:spPr>
+        <p:txBody>
+          <a:bodyPr wrap="square" lIns="0" tIns="0" rIns="0" bIns="0" rtlCol="0" anchor="t"/>
+          <a:lstStyle/>
+          <a:p>
+            <a:pPr indent="0" marL="0">
+              <a:spcAft>
+                <a:spcPts val="600"/>
+              </a:spcAft>
+              <a:buNone/>
+            </a:pPr>
+            <a:r>
+              <a:rPr lang="en-US" sz="1600" b="1" dirty="0">
+                <a:solidFill>
+                  <a:schemeClr val="bg1"/>
+                </a:solidFill>
+              </a:rPr>
+              <a:t>Fabrikasi 2 PCB · Rp200.000</a:t>
+            </a:r>
+            <a:endParaRPr lang="en-US" sz="1600" dirty="0"/>
+          </a:p>
+          <a:p>
+            <a:pPr indent="0" marL="0">
+              <a:buNone/>
+            </a:pPr>
+            <a:r>
+              <a:rPr lang="en-US" sz="1400" dirty="0">
+                <a:solidFill>
+                  <a:schemeClr val="bg1"/>
+                </a:solidFill>
+              </a:rPr>
+              <a:t>Papan custom menggantikan kabel breadboard: rapi dan awet dipakai siswa</a:t>
+            </a:r>
+            <a:endParaRPr lang="en-US" sz="1600" dirty="0"/>
           </a:p>
         </p:txBody>
       </p:sp>
@@ -5493,16 +5798,16 @@
       </p:grpSpPr>
       <p:sp>
         <p:nvSpPr>
-          <p:cNvPr id="2" name="Text 2"/>
+          <p:cNvPr id="2" name="Text 3"/>
           <p:cNvSpPr/>
           <p:nvPr>
-            <p:ph idx="102" type="title" hasCustomPrompt="1"/>
+            <p:ph idx="103" type="title" hasCustomPrompt="1"/>
           </p:nvPr>
         </p:nvSpPr>
         <p:spPr>
           <a:xfrm>
-            <a:off x="1463040" y="1024128"/>
-            <a:ext cx="9262872" cy="786384"/>
+            <a:off x="1353312" y="1069848"/>
+            <a:ext cx="9784080" cy="786384"/>
           </a:xfrm>
           <a:prstGeom prst="rect">
             <a:avLst/>
@@ -5514,7 +5819,7 @@
           <a:bodyPr wrap="square" lIns="0" tIns="0" rIns="0" bIns="0" rtlCol="0" anchor="ctr"/>
           <a:lstStyle/>
           <a:p>
-            <a:pPr algn="ctr" indent="0" marL="0">
+            <a:pPr algn="l" indent="0" marL="0">
               <a:buNone/>
             </a:pPr>
             <a:r>
@@ -5523,65 +5828,38 @@
                   <a:schemeClr val="bg1"/>
                 </a:solidFill>
               </a:rPr>
-              <a:t>JADWAL &amp; RISIKO</a:t>
+              <a:t>RIWAYAT RAB &amp; EFISIENSI</a:t>
             </a:r>
             <a:endParaRPr lang="en-US" sz="4000" dirty="0"/>
           </a:p>
         </p:txBody>
       </p:sp>
-      <p:sp>
-        <p:nvSpPr>
-          <p:cNvPr id="3" name="Garis waktu"/>
-          <p:cNvSpPr/>
+      <p:graphicFrame>
+        <p:nvGraphicFramePr>
+          <p:cNvPr id="3" name="Grafik riwayat RAB" descr="Grafik garis total RAB per revisi antara 833 dan 902 ribu rupiah, terakhir 887 ribu, dengan garis batas 1 juta rupiah"/>
+          <p:cNvGraphicFramePr/>
           <p:nvPr/>
-        </p:nvSpPr>
-        <p:spPr>
-          <a:xfrm>
-            <a:off x="1920240" y="2514600"/>
-            <a:ext cx="8366760" cy="0"/>
-          </a:xfrm>
-          <a:prstGeom prst="line">
-            <a:avLst/>
-          </a:prstGeom>
-          <a:noFill/>
-          <a:ln w="38100">
-            <a:solidFill>
-              <a:schemeClr val="accent3"/>
-            </a:solidFill>
-            <a:prstDash val="solid"/>
-          </a:ln>
-        </p:spPr>
-      </p:sp>
-      <p:sp>
-        <p:nvSpPr>
-          <p:cNvPr id="4" name="Gerbang G1 lingkaran"/>
-          <p:cNvSpPr/>
-          <p:nvPr/>
-        </p:nvSpPr>
-        <p:spPr>
-          <a:xfrm>
-            <a:off x="1673352" y="2267712"/>
-            <a:ext cx="493776" cy="493776"/>
-          </a:xfrm>
-          <a:prstGeom prst="ellipse">
-            <a:avLst/>
-          </a:prstGeom>
-          <a:solidFill>
-            <a:schemeClr val="accent2"/>
-          </a:solidFill>
-          <a:ln/>
-        </p:spPr>
-      </p:sp>
-      <p:sp>
-        <p:nvSpPr>
-          <p:cNvPr id="5" name="Gerbang G1"/>
+        </p:nvGraphicFramePr>
+        <p:xfrm>
+          <a:off x="1051560" y="2011680"/>
+          <a:ext cx="6400800" cy="3611880"/>
+        </p:xfrm>
+        <a:graphic xmlns:a="http://schemas.openxmlformats.org/drawingml/2006/main">
+          <a:graphicData uri="http://schemas.openxmlformats.org/drawingml/2006/chart">
+            <c:chart xmlns:c="http://schemas.openxmlformats.org/drawingml/2006/chart" r:id="rId1"/>
+          </a:graphicData>
+        </a:graphic>
+      </p:graphicFrame>
+      <p:sp>
+        <p:nvSpPr>
+          <p:cNvPr id="4" name="Selisih anggaran"/>
           <p:cNvSpPr txBox="1"/>
           <p:nvPr/>
         </p:nvSpPr>
         <p:spPr>
           <a:xfrm>
-            <a:off x="1508760" y="2267712"/>
-            <a:ext cx="822960" cy="493776"/>
+            <a:off x="7726680" y="2103120"/>
+            <a:ext cx="3383280" cy="1143000"/>
           </a:xfrm>
           <a:prstGeom prst="rect">
             <a:avLst/>
@@ -5590,154 +5868,48 @@
           <a:ln/>
         </p:spPr>
         <p:txBody>
-          <a:bodyPr wrap="square" lIns="0" tIns="0" rIns="0" bIns="0" rtlCol="0" anchor="ctr"/>
+          <a:bodyPr wrap="square" lIns="0" tIns="0" rIns="0" bIns="0" rtlCol="0" anchor="t"/>
           <a:lstStyle/>
           <a:p>
-            <a:pPr algn="ctr" indent="0" marL="0">
+            <a:pPr indent="0" marL="0">
               <a:buNone/>
             </a:pPr>
             <a:r>
-              <a:rPr lang="en-US" sz="1400" b="1" dirty="0">
+              <a:rPr lang="en-US" sz="3600" b="1" dirty="0">
                 <a:solidFill>
-                  <a:schemeClr val="tx1"/>
+                  <a:schemeClr val="accent2"/>
                 </a:solidFill>
               </a:rPr>
-              <a:t>G1</a:t>
+              <a:t>Sisa Rp113.000</a:t>
             </a:r>
-            <a:endParaRPr lang="en-US" sz="1400" dirty="0"/>
-          </a:p>
-        </p:txBody>
-      </p:sp>
-      <p:sp>
-        <p:nvSpPr>
-          <p:cNvPr id="6" name="Gerbang G1 keterangan"/>
-          <p:cNvSpPr txBox="1"/>
-          <p:nvPr/>
-        </p:nvSpPr>
-        <p:spPr>
-          <a:xfrm>
-            <a:off x="1143000" y="2862072"/>
-            <a:ext cx="1554480" cy="1051560"/>
-          </a:xfrm>
-          <a:prstGeom prst="rect">
-            <a:avLst/>
-          </a:prstGeom>
-          <a:noFill/>
-          <a:ln/>
-        </p:spPr>
-        <p:txBody>
-          <a:bodyPr wrap="square" lIns="0" tIns="0" rIns="0" bIns="0" rtlCol="0" anchor="t"/>
-          <a:lstStyle/>
-          <a:p>
-            <a:pPr algn="ctr" indent="0" marL="0">
+            <a:endParaRPr lang="en-US" sz="3600" dirty="0"/>
+          </a:p>
+          <a:p>
+            <a:pPr indent="0" marL="0">
               <a:buNone/>
             </a:pPr>
             <a:r>
-              <a:rPr lang="en-US" sz="1300" b="1" dirty="0">
+              <a:rPr lang="en-US" sz="1600" dirty="0">
                 <a:solidFill>
                   <a:schemeClr val="bg1"/>
                 </a:solidFill>
               </a:rPr>
-              <a:t>Penetapan</a:t>
+              <a:t>(11,3%) di bawah batas Rp1.000.000</a:t>
             </a:r>
-            <a:endParaRPr lang="en-US" sz="1300" dirty="0"/>
-          </a:p>
-          <a:p>
-            <a:pPr algn="ctr" indent="0" marL="0">
-              <a:buNone/>
-            </a:pPr>
-            <a:r>
-              <a:rPr lang="en-US" sz="1300" dirty="0">
-                <a:solidFill>
-                  <a:schemeClr val="bg2"/>
-                </a:solidFill>
-              </a:rPr>
-              <a:t>minggu 1–2</a:t>
-            </a:r>
-            <a:endParaRPr lang="en-US" sz="1300" dirty="0"/>
-          </a:p>
-          <a:p>
-            <a:pPr algn="ctr" indent="0" marL="0">
-              <a:buNone/>
-            </a:pPr>
-            <a:r>
-              <a:rPr lang="en-US" sz="1300" b="1" dirty="0">
-                <a:solidFill>
-                  <a:schemeClr val="accent2"/>
-                </a:solidFill>
-              </a:rPr>
-              <a:t>lulus 02/10</a:t>
-            </a:r>
-            <a:endParaRPr lang="en-US" sz="1300" dirty="0"/>
+            <a:endParaRPr lang="en-US" sz="3600" dirty="0"/>
           </a:p>
         </p:txBody>
       </p:sp>
       <p:sp>
         <p:nvSpPr>
-          <p:cNvPr id="7" name="Gerbang G2 lingkaran"/>
-          <p:cNvSpPr/>
-          <p:nvPr/>
-        </p:nvSpPr>
-        <p:spPr>
-          <a:xfrm>
-            <a:off x="3346704" y="2267712"/>
-            <a:ext cx="493776" cy="493776"/>
-          </a:xfrm>
-          <a:prstGeom prst="ellipse">
-            <a:avLst/>
-          </a:prstGeom>
-          <a:solidFill>
-            <a:schemeClr val="accent2"/>
-          </a:solidFill>
-          <a:ln/>
-        </p:spPr>
-      </p:sp>
-      <p:sp>
-        <p:nvSpPr>
-          <p:cNvPr id="8" name="Gerbang G2"/>
+          <p:cNvPr id="5" name="Selisih poin"/>
           <p:cNvSpPr txBox="1"/>
           <p:nvPr/>
         </p:nvSpPr>
         <p:spPr>
           <a:xfrm>
-            <a:off x="3182112" y="2267712"/>
-            <a:ext cx="822960" cy="493776"/>
-          </a:xfrm>
-          <a:prstGeom prst="rect">
-            <a:avLst/>
-          </a:prstGeom>
-          <a:noFill/>
-          <a:ln/>
-        </p:spPr>
-        <p:txBody>
-          <a:bodyPr wrap="square" lIns="0" tIns="0" rIns="0" bIns="0" rtlCol="0" anchor="ctr"/>
-          <a:lstStyle/>
-          <a:p>
-            <a:pPr algn="ctr" indent="0" marL="0">
-              <a:buNone/>
-            </a:pPr>
-            <a:r>
-              <a:rPr lang="en-US" sz="1400" b="1" dirty="0">
-                <a:solidFill>
-                  <a:schemeClr val="tx1"/>
-                </a:solidFill>
-              </a:rPr>
-              <a:t>G2</a:t>
-            </a:r>
-            <a:endParaRPr lang="en-US" sz="1400" dirty="0"/>
-          </a:p>
-        </p:txBody>
-      </p:sp>
-      <p:sp>
-        <p:nvSpPr>
-          <p:cNvPr id="9" name="Gerbang G2 keterangan"/>
-          <p:cNvSpPr txBox="1"/>
-          <p:nvPr/>
-        </p:nvSpPr>
-        <p:spPr>
-          <a:xfrm>
-            <a:off x="2816352" y="2862072"/>
-            <a:ext cx="1554480" cy="1051560"/>
+            <a:off x="7726680" y="3200400"/>
+            <a:ext cx="3383280" cy="2103120"/>
           </a:xfrm>
           <a:prstGeom prst="rect">
             <a:avLst/>
@@ -5749,533 +5921,12 @@
           <a:bodyPr wrap="square" lIns="0" tIns="0" rIns="0" bIns="0" rtlCol="0" anchor="t"/>
           <a:lstStyle/>
           <a:p>
-            <a:pPr algn="ctr" indent="0" marL="0">
-              <a:buNone/>
-            </a:pPr>
-            <a:r>
-              <a:rPr lang="en-US" sz="1300" b="1" dirty="0">
-                <a:solidFill>
-                  <a:schemeClr val="bg1"/>
-                </a:solidFill>
-              </a:rPr>
-              <a:t>Rancangan + RAB</a:t>
-            </a:r>
-            <a:endParaRPr lang="en-US" sz="1300" dirty="0"/>
-          </a:p>
-          <a:p>
-            <a:pPr algn="ctr" indent="0" marL="0">
-              <a:buNone/>
-            </a:pPr>
-            <a:r>
-              <a:rPr lang="en-US" sz="1300" dirty="0">
-                <a:solidFill>
-                  <a:schemeClr val="bg2"/>
-                </a:solidFill>
-              </a:rPr>
-              <a:t>minggu 3–6</a:t>
-            </a:r>
-            <a:endParaRPr lang="en-US" sz="1300" dirty="0"/>
-          </a:p>
-          <a:p>
-            <a:pPr algn="ctr" indent="0" marL="0">
-              <a:buNone/>
-            </a:pPr>
-            <a:r>
-              <a:rPr lang="en-US" sz="1300" b="1" dirty="0">
-                <a:solidFill>
-                  <a:schemeClr val="accent2"/>
-                </a:solidFill>
-              </a:rPr>
-              <a:t>hari ini</a:t>
-            </a:r>
-            <a:endParaRPr lang="en-US" sz="1300" dirty="0"/>
-          </a:p>
-        </p:txBody>
-      </p:sp>
-      <p:sp>
-        <p:nvSpPr>
-          <p:cNvPr id="10" name="Gerbang FMEA lingkaran"/>
-          <p:cNvSpPr/>
-          <p:nvPr/>
-        </p:nvSpPr>
-        <p:spPr>
-          <a:xfrm>
-            <a:off x="5020056" y="2267712"/>
-            <a:ext cx="493776" cy="493776"/>
-          </a:xfrm>
-          <a:prstGeom prst="ellipse">
-            <a:avLst/>
-          </a:prstGeom>
-          <a:solidFill>
-            <a:schemeClr val="accent1"/>
-          </a:solidFill>
-          <a:ln/>
-        </p:spPr>
-      </p:sp>
-      <p:sp>
-        <p:nvSpPr>
-          <p:cNvPr id="11" name="Gerbang FMEA"/>
-          <p:cNvSpPr txBox="1"/>
-          <p:nvPr/>
-        </p:nvSpPr>
-        <p:spPr>
-          <a:xfrm>
-            <a:off x="4855464" y="2267712"/>
-            <a:ext cx="822960" cy="493776"/>
-          </a:xfrm>
-          <a:prstGeom prst="rect">
-            <a:avLst/>
-          </a:prstGeom>
-          <a:noFill/>
-          <a:ln/>
-        </p:spPr>
-        <p:txBody>
-          <a:bodyPr wrap="square" lIns="0" tIns="0" rIns="0" bIns="0" rtlCol="0" anchor="ctr"/>
-          <a:lstStyle/>
-          <a:p>
-            <a:pPr algn="ctr" indent="0" marL="0">
-              <a:buNone/>
-            </a:pPr>
-            <a:r>
-              <a:rPr lang="en-US" sz="1100" b="1" dirty="0">
-                <a:solidFill>
-                  <a:schemeClr val="bg1"/>
-                </a:solidFill>
-              </a:rPr>
-              <a:t>FMEA</a:t>
-            </a:r>
-            <a:endParaRPr lang="en-US" sz="1100" dirty="0"/>
-          </a:p>
-        </p:txBody>
-      </p:sp>
-      <p:sp>
-        <p:nvSpPr>
-          <p:cNvPr id="12" name="Gerbang FMEA keterangan"/>
-          <p:cNvSpPr txBox="1"/>
-          <p:nvPr/>
-        </p:nvSpPr>
-        <p:spPr>
-          <a:xfrm>
-            <a:off x="4489704" y="2862072"/>
-            <a:ext cx="1554480" cy="1051560"/>
-          </a:xfrm>
-          <a:prstGeom prst="rect">
-            <a:avLst/>
-          </a:prstGeom>
-          <a:noFill/>
-          <a:ln/>
-        </p:spPr>
-        <p:txBody>
-          <a:bodyPr wrap="square" lIns="0" tIns="0" rIns="0" bIns="0" rtlCol="0" anchor="t"/>
-          <a:lstStyle/>
-          <a:p>
-            <a:pPr algn="ctr" indent="0" marL="0">
-              <a:buNone/>
-            </a:pPr>
-            <a:r>
-              <a:rPr lang="en-US" sz="1300" b="1" dirty="0">
-                <a:solidFill>
-                  <a:schemeClr val="bg1"/>
-                </a:solidFill>
-              </a:rPr>
-              <a:t>Analisis bahaya</a:t>
-            </a:r>
-            <a:endParaRPr lang="en-US" sz="1300" dirty="0"/>
-          </a:p>
-          <a:p>
-            <a:pPr algn="ctr" indent="0" marL="0">
-              <a:buNone/>
-            </a:pPr>
-            <a:r>
-              <a:rPr lang="en-US" sz="1300" dirty="0">
-                <a:solidFill>
-                  <a:schemeClr val="bg2"/>
-                </a:solidFill>
-              </a:rPr>
-              <a:t>minggu 7–8</a:t>
-            </a:r>
-            <a:endParaRPr lang="en-US" sz="1300" dirty="0"/>
-          </a:p>
-        </p:txBody>
-      </p:sp>
-      <p:sp>
-        <p:nvSpPr>
-          <p:cNvPr id="13" name="Gerbang G3 lingkaran"/>
-          <p:cNvSpPr/>
-          <p:nvPr/>
-        </p:nvSpPr>
-        <p:spPr>
-          <a:xfrm>
-            <a:off x="6693408" y="2267712"/>
-            <a:ext cx="493776" cy="493776"/>
-          </a:xfrm>
-          <a:prstGeom prst="ellipse">
-            <a:avLst/>
-          </a:prstGeom>
-          <a:solidFill>
-            <a:schemeClr val="accent1"/>
-          </a:solidFill>
-          <a:ln/>
-        </p:spPr>
-      </p:sp>
-      <p:sp>
-        <p:nvSpPr>
-          <p:cNvPr id="14" name="Gerbang G3"/>
-          <p:cNvSpPr txBox="1"/>
-          <p:nvPr/>
-        </p:nvSpPr>
-        <p:spPr>
-          <a:xfrm>
-            <a:off x="6528816" y="2267712"/>
-            <a:ext cx="822960" cy="493776"/>
-          </a:xfrm>
-          <a:prstGeom prst="rect">
-            <a:avLst/>
-          </a:prstGeom>
-          <a:noFill/>
-          <a:ln/>
-        </p:spPr>
-        <p:txBody>
-          <a:bodyPr wrap="square" lIns="0" tIns="0" rIns="0" bIns="0" rtlCol="0" anchor="ctr"/>
-          <a:lstStyle/>
-          <a:p>
-            <a:pPr algn="ctr" indent="0" marL="0">
-              <a:buNone/>
-            </a:pPr>
-            <a:r>
-              <a:rPr lang="en-US" sz="1400" b="1" dirty="0">
-                <a:solidFill>
-                  <a:schemeClr val="bg1"/>
-                </a:solidFill>
-              </a:rPr>
-              <a:t>G3</a:t>
-            </a:r>
-            <a:endParaRPr lang="en-US" sz="1400" dirty="0"/>
-          </a:p>
-        </p:txBody>
-      </p:sp>
-      <p:sp>
-        <p:nvSpPr>
-          <p:cNvPr id="15" name="Gerbang G3 keterangan"/>
-          <p:cNvSpPr txBox="1"/>
-          <p:nvPr/>
-        </p:nvSpPr>
-        <p:spPr>
-          <a:xfrm>
-            <a:off x="6163056" y="2862072"/>
-            <a:ext cx="1554480" cy="1051560"/>
-          </a:xfrm>
-          <a:prstGeom prst="rect">
-            <a:avLst/>
-          </a:prstGeom>
-          <a:noFill/>
-          <a:ln/>
-        </p:spPr>
-        <p:txBody>
-          <a:bodyPr wrap="square" lIns="0" tIns="0" rIns="0" bIns="0" rtlCol="0" anchor="t"/>
-          <a:lstStyle/>
-          <a:p>
-            <a:pPr algn="ctr" indent="0" marL="0">
-              <a:buNone/>
-            </a:pPr>
-            <a:r>
-              <a:rPr lang="en-US" sz="1300" b="1" dirty="0">
-                <a:solidFill>
-                  <a:schemeClr val="bg1"/>
-                </a:solidFill>
-              </a:rPr>
-              <a:t>Prototipe jalan 3×, PCB dipesan</a:t>
-            </a:r>
-            <a:endParaRPr lang="en-US" sz="1300" dirty="0"/>
-          </a:p>
-          <a:p>
-            <a:pPr algn="ctr" indent="0" marL="0">
-              <a:buNone/>
-            </a:pPr>
-            <a:r>
-              <a:rPr lang="en-US" sz="1300" dirty="0">
-                <a:solidFill>
-                  <a:schemeClr val="bg2"/>
-                </a:solidFill>
-              </a:rPr>
-              <a:t>≤ minggu 10</a:t>
-            </a:r>
-            <a:endParaRPr lang="en-US" sz="1300" dirty="0"/>
-          </a:p>
-        </p:txBody>
-      </p:sp>
-      <p:sp>
-        <p:nvSpPr>
-          <p:cNvPr id="16" name="Gerbang G4 lingkaran"/>
-          <p:cNvSpPr/>
-          <p:nvPr/>
-        </p:nvSpPr>
-        <p:spPr>
-          <a:xfrm>
-            <a:off x="8366760" y="2267712"/>
-            <a:ext cx="493776" cy="493776"/>
-          </a:xfrm>
-          <a:prstGeom prst="ellipse">
-            <a:avLst/>
-          </a:prstGeom>
-          <a:solidFill>
-            <a:schemeClr val="accent1"/>
-          </a:solidFill>
-          <a:ln/>
-        </p:spPr>
-      </p:sp>
-      <p:sp>
-        <p:nvSpPr>
-          <p:cNvPr id="17" name="Gerbang G4"/>
-          <p:cNvSpPr txBox="1"/>
-          <p:nvPr/>
-        </p:nvSpPr>
-        <p:spPr>
-          <a:xfrm>
-            <a:off x="8202168" y="2267712"/>
-            <a:ext cx="822960" cy="493776"/>
-          </a:xfrm>
-          <a:prstGeom prst="rect">
-            <a:avLst/>
-          </a:prstGeom>
-          <a:noFill/>
-          <a:ln/>
-        </p:spPr>
-        <p:txBody>
-          <a:bodyPr wrap="square" lIns="0" tIns="0" rIns="0" bIns="0" rtlCol="0" anchor="ctr"/>
-          <a:lstStyle/>
-          <a:p>
-            <a:pPr algn="ctr" indent="0" marL="0">
-              <a:buNone/>
-            </a:pPr>
-            <a:r>
-              <a:rPr lang="en-US" sz="1400" b="1" dirty="0">
-                <a:solidFill>
-                  <a:schemeClr val="bg1"/>
-                </a:solidFill>
-              </a:rPr>
-              <a:t>G4</a:t>
-            </a:r>
-            <a:endParaRPr lang="en-US" sz="1400" dirty="0"/>
-          </a:p>
-        </p:txBody>
-      </p:sp>
-      <p:sp>
-        <p:nvSpPr>
-          <p:cNvPr id="18" name="Gerbang G4 keterangan"/>
-          <p:cNvSpPr txBox="1"/>
-          <p:nvPr/>
-        </p:nvSpPr>
-        <p:spPr>
-          <a:xfrm>
-            <a:off x="7836408" y="2862072"/>
-            <a:ext cx="1554480" cy="1051560"/>
-          </a:xfrm>
-          <a:prstGeom prst="rect">
-            <a:avLst/>
-          </a:prstGeom>
-          <a:noFill/>
-          <a:ln/>
-        </p:spPr>
-        <p:txBody>
-          <a:bodyPr wrap="square" lIns="0" tIns="0" rIns="0" bIns="0" rtlCol="0" anchor="t"/>
-          <a:lstStyle/>
-          <a:p>
-            <a:pPr algn="ctr" indent="0" marL="0">
-              <a:buNone/>
-            </a:pPr>
-            <a:r>
-              <a:rPr lang="en-US" sz="1300" b="1" dirty="0">
-                <a:solidFill>
-                  <a:schemeClr val="bg1"/>
-                </a:solidFill>
-              </a:rPr>
-              <a:t>Pembuktian + uji siswa</a:t>
-            </a:r>
-            <a:endParaRPr lang="en-US" sz="1300" dirty="0"/>
-          </a:p>
-          <a:p>
-            <a:pPr algn="ctr" indent="0" marL="0">
-              <a:buNone/>
-            </a:pPr>
-            <a:r>
-              <a:rPr lang="en-US" sz="1300" dirty="0">
-                <a:solidFill>
-                  <a:schemeClr val="bg2"/>
-                </a:solidFill>
-              </a:rPr>
-              <a:t>minggu 11–14</a:t>
-            </a:r>
-            <a:endParaRPr lang="en-US" sz="1300" dirty="0"/>
-          </a:p>
-        </p:txBody>
-      </p:sp>
-      <p:sp>
-        <p:nvSpPr>
-          <p:cNvPr id="19" name="Gerbang G5 lingkaran"/>
-          <p:cNvSpPr/>
-          <p:nvPr/>
-        </p:nvSpPr>
-        <p:spPr>
-          <a:xfrm>
-            <a:off x="10040112" y="2267712"/>
-            <a:ext cx="493776" cy="493776"/>
-          </a:xfrm>
-          <a:prstGeom prst="ellipse">
-            <a:avLst/>
-          </a:prstGeom>
-          <a:solidFill>
-            <a:schemeClr val="accent1"/>
-          </a:solidFill>
-          <a:ln/>
-        </p:spPr>
-      </p:sp>
-      <p:sp>
-        <p:nvSpPr>
-          <p:cNvPr id="20" name="Gerbang G5"/>
-          <p:cNvSpPr txBox="1"/>
-          <p:nvPr/>
-        </p:nvSpPr>
-        <p:spPr>
-          <a:xfrm>
-            <a:off x="9875520" y="2267712"/>
-            <a:ext cx="822960" cy="493776"/>
-          </a:xfrm>
-          <a:prstGeom prst="rect">
-            <a:avLst/>
-          </a:prstGeom>
-          <a:noFill/>
-          <a:ln/>
-        </p:spPr>
-        <p:txBody>
-          <a:bodyPr wrap="square" lIns="0" tIns="0" rIns="0" bIns="0" rtlCol="0" anchor="ctr"/>
-          <a:lstStyle/>
-          <a:p>
-            <a:pPr algn="ctr" indent="0" marL="0">
-              <a:buNone/>
-            </a:pPr>
-            <a:r>
-              <a:rPr lang="en-US" sz="1400" b="1" dirty="0">
-                <a:solidFill>
-                  <a:schemeClr val="bg1"/>
-                </a:solidFill>
-              </a:rPr>
-              <a:t>G5</a:t>
-            </a:r>
-            <a:endParaRPr lang="en-US" sz="1400" dirty="0"/>
-          </a:p>
-        </p:txBody>
-      </p:sp>
-      <p:sp>
-        <p:nvSpPr>
-          <p:cNvPr id="21" name="Gerbang G5 keterangan"/>
-          <p:cNvSpPr txBox="1"/>
-          <p:nvPr/>
-        </p:nvSpPr>
-        <p:spPr>
-          <a:xfrm>
-            <a:off x="9509760" y="2862072"/>
-            <a:ext cx="1554480" cy="1051560"/>
-          </a:xfrm>
-          <a:prstGeom prst="rect">
-            <a:avLst/>
-          </a:prstGeom>
-          <a:noFill/>
-          <a:ln/>
-        </p:spPr>
-        <p:txBody>
-          <a:bodyPr wrap="square" lIns="0" tIns="0" rIns="0" bIns="0" rtlCol="0" anchor="t"/>
-          <a:lstStyle/>
-          <a:p>
-            <a:pPr algn="ctr" indent="0" marL="0">
-              <a:buNone/>
-            </a:pPr>
-            <a:r>
-              <a:rPr lang="en-US" sz="1300" b="1" dirty="0">
-                <a:solidFill>
-                  <a:schemeClr val="bg1"/>
-                </a:solidFill>
-              </a:rPr>
-              <a:t>Serah terima</a:t>
-            </a:r>
-            <a:endParaRPr lang="en-US" sz="1300" dirty="0"/>
-          </a:p>
-          <a:p>
-            <a:pPr algn="ctr" indent="0" marL="0">
-              <a:buNone/>
-            </a:pPr>
-            <a:r>
-              <a:rPr lang="en-US" sz="1300" dirty="0">
-                <a:solidFill>
-                  <a:schemeClr val="bg2"/>
-                </a:solidFill>
-              </a:rPr>
-              <a:t>minggu 15–16</a:t>
-            </a:r>
-            <a:endParaRPr lang="en-US" sz="1300" dirty="0"/>
-          </a:p>
-        </p:txBody>
-      </p:sp>
-      <p:sp>
-        <p:nvSpPr>
-          <p:cNvPr id="22" name="Risiko 1 latar"/>
-          <p:cNvSpPr/>
-          <p:nvPr/>
-        </p:nvSpPr>
-        <p:spPr>
-          <a:xfrm>
-            <a:off x="1463040" y="4069080"/>
-            <a:ext cx="2971800" cy="1325880"/>
-          </a:xfrm>
-          <a:prstGeom prst="rect">
-            <a:avLst/>
-          </a:prstGeom>
-          <a:solidFill>
-            <a:schemeClr val="accent1"/>
-          </a:solidFill>
-          <a:ln/>
-        </p:spPr>
-      </p:sp>
-      <p:sp>
-        <p:nvSpPr>
-          <p:cNvPr id="23" name="Risiko 1 teks"/>
-          <p:cNvSpPr txBox="1"/>
-          <p:nvPr/>
-        </p:nvSpPr>
-        <p:spPr>
-          <a:xfrm>
-            <a:off x="1627632" y="4215384"/>
-            <a:ext cx="2642616" cy="1033272"/>
-          </a:xfrm>
-          <a:prstGeom prst="rect">
-            <a:avLst/>
-          </a:prstGeom>
-          <a:noFill/>
-          <a:ln/>
-        </p:spPr>
-        <p:txBody>
-          <a:bodyPr wrap="square" lIns="0" tIns="0" rIns="0" bIns="0" rtlCol="0" anchor="t"/>
-          <a:lstStyle/>
-          <a:p>
-            <a:pPr indent="0" marL="0">
+            <a:pPr marL="203200" indent="-203200">
               <a:spcAft>
-                <a:spcPts val="600"/>
+                <a:spcPts val="800"/>
               </a:spcAft>
-              <a:buNone/>
-            </a:pPr>
-            <a:r>
-              <a:rPr lang="en-US" sz="1600" b="1" dirty="0">
-                <a:solidFill>
-                  <a:schemeClr val="bg1"/>
-                </a:solidFill>
-              </a:rPr>
-              <a:t>PCB salah desain / terlambat</a:t>
-            </a:r>
-            <a:endParaRPr lang="en-US" sz="1600" dirty="0"/>
-          </a:p>
-          <a:p>
-            <a:pPr indent="0" marL="0">
-              <a:buNone/>
+              <a:buSzPct val="100000"/>
+              <a:buChar char="•"/>
             </a:pPr>
             <a:r>
               <a:rPr lang="en-US" sz="1400" dirty="0">
@@ -6283,72 +5934,17 @@
                   <a:schemeClr val="bg1"/>
                 </a:solidFill>
               </a:rPr>
-              <a:t>Prototipe breadboard dulu, PCB dipesan paling lambat minggu 10</a:t>
+              <a:t>Kenaikan terbesar: QRE1113GR lokal Rp15.000/pcs (+Rp105.000).</a:t>
             </a:r>
-            <a:endParaRPr lang="en-US" sz="1600" dirty="0"/>
-          </a:p>
-        </p:txBody>
-      </p:sp>
-      <p:sp>
-        <p:nvSpPr>
-          <p:cNvPr id="24" name="Risiko 2 latar"/>
-          <p:cNvSpPr/>
-          <p:nvPr/>
-        </p:nvSpPr>
-        <p:spPr>
-          <a:xfrm>
-            <a:off x="4617720" y="4069080"/>
-            <a:ext cx="2971800" cy="1325880"/>
-          </a:xfrm>
-          <a:prstGeom prst="rect">
-            <a:avLst/>
-          </a:prstGeom>
-          <a:solidFill>
-            <a:schemeClr val="accent1"/>
-          </a:solidFill>
-          <a:ln/>
-        </p:spPr>
-      </p:sp>
-      <p:sp>
-        <p:nvSpPr>
-          <p:cNvPr id="25" name="Risiko 2 teks"/>
-          <p:cNvSpPr txBox="1"/>
-          <p:nvPr/>
-        </p:nvSpPr>
-        <p:spPr>
-          <a:xfrm>
-            <a:off x="4782312" y="4215384"/>
-            <a:ext cx="2642616" cy="1033272"/>
-          </a:xfrm>
-          <a:prstGeom prst="rect">
-            <a:avLst/>
-          </a:prstGeom>
-          <a:noFill/>
-          <a:ln/>
-        </p:spPr>
-        <p:txBody>
-          <a:bodyPr wrap="square" lIns="0" tIns="0" rIns="0" bIns="0" rtlCol="0" anchor="t"/>
-          <a:lstStyle/>
-          <a:p>
-            <a:pPr indent="0" marL="0">
+            <a:endParaRPr lang="en-US" sz="1400" dirty="0"/>
+          </a:p>
+          <a:p>
+            <a:pPr marL="203200" indent="-203200">
               <a:spcAft>
-                <a:spcPts val="600"/>
+                <a:spcPts val="800"/>
               </a:spcAft>
-              <a:buNone/>
-            </a:pPr>
-            <a:r>
-              <a:rPr lang="en-US" sz="1600" b="1" dirty="0">
-                <a:solidFill>
-                  <a:schemeClr val="bg1"/>
-                </a:solidFill>
-              </a:rPr>
-              <a:t>Biaya melebihi batas</a:t>
-            </a:r>
-            <a:endParaRPr lang="en-US" sz="1600" dirty="0"/>
-          </a:p>
-          <a:p>
-            <a:pPr indent="0" marL="0">
-              <a:buNone/>
+              <a:buSzPct val="100000"/>
+              <a:buChar char="•"/>
             </a:pPr>
             <a:r>
               <a:rPr lang="en-US" sz="1400" dirty="0">
@@ -6356,72 +5952,17 @@
                   <a:schemeClr val="bg1"/>
                 </a:solidFill>
               </a:rPr>
-              <a:t>RAB dipantau tiap pembelian, harga disertai tautan toko</a:t>
+              <a:t>Dihemat: MCP23017 + LED dihapus, skid nilon, alat pinjam lab (−Rp85.000), mux harga toko (−Rp15.000).</a:t>
             </a:r>
-            <a:endParaRPr lang="en-US" sz="1600" dirty="0"/>
-          </a:p>
-        </p:txBody>
-      </p:sp>
-      <p:sp>
-        <p:nvSpPr>
-          <p:cNvPr id="26" name="Risiko 3 latar"/>
-          <p:cNvSpPr/>
-          <p:nvPr/>
-        </p:nvSpPr>
-        <p:spPr>
-          <a:xfrm>
-            <a:off x="7772400" y="4069080"/>
-            <a:ext cx="2971800" cy="1325880"/>
-          </a:xfrm>
-          <a:prstGeom prst="rect">
-            <a:avLst/>
-          </a:prstGeom>
-          <a:solidFill>
-            <a:schemeClr val="accent1"/>
-          </a:solidFill>
-          <a:ln/>
-        </p:spPr>
-      </p:sp>
-      <p:sp>
-        <p:nvSpPr>
-          <p:cNvPr id="27" name="Risiko 3 teks"/>
-          <p:cNvSpPr txBox="1"/>
-          <p:nvPr/>
-        </p:nvSpPr>
-        <p:spPr>
-          <a:xfrm>
-            <a:off x="7936992" y="4215384"/>
-            <a:ext cx="2642616" cy="1033272"/>
-          </a:xfrm>
-          <a:prstGeom prst="rect">
-            <a:avLst/>
-          </a:prstGeom>
-          <a:noFill/>
-          <a:ln/>
-        </p:spPr>
-        <p:txBody>
-          <a:bodyPr wrap="square" lIns="0" tIns="0" rIns="0" bIns="0" rtlCol="0" anchor="t"/>
-          <a:lstStyle/>
-          <a:p>
-            <a:pPr indent="0" marL="0">
+            <a:endParaRPr lang="en-US" sz="1400" dirty="0"/>
+          </a:p>
+          <a:p>
+            <a:pPr marL="203200" indent="-203200">
               <a:spcAft>
-                <a:spcPts val="600"/>
+                <a:spcPts val="800"/>
               </a:spcAft>
-              <a:buNone/>
-            </a:pPr>
-            <a:r>
-              <a:rPr lang="en-US" sz="1600" b="1" dirty="0">
-                <a:solidFill>
-                  <a:schemeClr val="bg1"/>
-                </a:solidFill>
-              </a:rPr>
-              <a:t>QRE tanpa cadangan</a:t>
-            </a:r>
-            <a:endParaRPr lang="en-US" sz="1600" dirty="0"/>
-          </a:p>
-          <a:p>
-            <a:pPr indent="0" marL="0">
-              <a:buNone/>
+              <a:buSzPct val="100000"/>
+              <a:buChar char="•"/>
             </a:pPr>
             <a:r>
               <a:rPr lang="en-US" sz="1400" dirty="0">
@@ -6429,9 +5970,9 @@
                   <a:schemeClr val="bg1"/>
                 </a:solidFill>
               </a:rPr>
-              <a:t>Tiap sensor diuji di breadboard sebelum disolder</a:t>
+              <a:t>Sisa untuk kenaikan harga atau body 3D print (belum di RAB).</a:t>
             </a:r>
-            <a:endParaRPr lang="en-US" sz="1600" dirty="0"/>
+            <a:endParaRPr lang="en-US" sz="1400" dirty="0"/>
           </a:p>
         </p:txBody>
       </p:sp>
@@ -6462,16 +6003,16 @@
       </p:grpSpPr>
       <p:sp>
         <p:nvSpPr>
-          <p:cNvPr id="2" name="Text 3"/>
+          <p:cNvPr id="2" name="Text 2"/>
           <p:cNvSpPr/>
           <p:nvPr>
-            <p:ph idx="103" type="title" hasCustomPrompt="1"/>
+            <p:ph idx="102" type="title" hasCustomPrompt="1"/>
           </p:nvPr>
         </p:nvSpPr>
         <p:spPr>
           <a:xfrm>
-            <a:off x="1536192" y="1828800"/>
-            <a:ext cx="5669280" cy="3017520"/>
+            <a:off x="1463040" y="1024128"/>
+            <a:ext cx="9262872" cy="786384"/>
           </a:xfrm>
           <a:prstGeom prst="rect">
             <a:avLst/>
@@ -6483,51 +6024,230 @@
           <a:bodyPr wrap="square" lIns="0" tIns="0" rIns="0" bIns="0" rtlCol="0" anchor="ctr"/>
           <a:lstStyle/>
           <a:p>
-            <a:pPr algn="l" indent="0" marL="0">
-              <a:lnSpc>
-                <a:spcPct val="85000"/>
-              </a:lnSpc>
+            <a:pPr algn="ctr" indent="0" marL="0">
               <a:buNone/>
             </a:pPr>
             <a:r>
-              <a:rPr lang="en-US" sz="8800" b="1" dirty="0">
+              <a:rPr lang="en-US" sz="4000" b="1" dirty="0">
                 <a:solidFill>
                   <a:schemeClr val="bg1"/>
                 </a:solidFill>
               </a:rPr>
-              <a:t>TERIMA</a:t>
+              <a:t>JADWAL &amp; RISIKO</a:t>
             </a:r>
-            <a:endParaRPr lang="en-US" sz="8800" dirty="0"/>
-          </a:p>
-          <a:p>
-            <a:pPr algn="l" indent="0" marL="0">
-              <a:lnSpc>
-                <a:spcPct val="85000"/>
-              </a:lnSpc>
+            <a:endParaRPr lang="en-US" sz="4000" dirty="0"/>
+          </a:p>
+        </p:txBody>
+      </p:sp>
+      <p:sp>
+        <p:nvSpPr>
+          <p:cNvPr id="3" name="Garis waktu"/>
+          <p:cNvSpPr/>
+          <p:nvPr/>
+        </p:nvSpPr>
+        <p:spPr>
+          <a:xfrm>
+            <a:off x="1920240" y="2514600"/>
+            <a:ext cx="8366760" cy="0"/>
+          </a:xfrm>
+          <a:prstGeom prst="line">
+            <a:avLst/>
+          </a:prstGeom>
+          <a:noFill/>
+          <a:ln w="38100">
+            <a:solidFill>
+              <a:schemeClr val="accent3"/>
+            </a:solidFill>
+            <a:prstDash val="solid"/>
+          </a:ln>
+        </p:spPr>
+      </p:sp>
+      <p:sp>
+        <p:nvSpPr>
+          <p:cNvPr id="4" name="Gerbang G1 lingkaran"/>
+          <p:cNvSpPr/>
+          <p:nvPr/>
+        </p:nvSpPr>
+        <p:spPr>
+          <a:xfrm>
+            <a:off x="1673352" y="2267712"/>
+            <a:ext cx="493776" cy="493776"/>
+          </a:xfrm>
+          <a:prstGeom prst="ellipse">
+            <a:avLst/>
+          </a:prstGeom>
+          <a:solidFill>
+            <a:schemeClr val="accent2"/>
+          </a:solidFill>
+          <a:ln/>
+        </p:spPr>
+      </p:sp>
+      <p:sp>
+        <p:nvSpPr>
+          <p:cNvPr id="5" name="Gerbang G1"/>
+          <p:cNvSpPr txBox="1"/>
+          <p:nvPr/>
+        </p:nvSpPr>
+        <p:spPr>
+          <a:xfrm>
+            <a:off x="1508760" y="2267712"/>
+            <a:ext cx="822960" cy="493776"/>
+          </a:xfrm>
+          <a:prstGeom prst="rect">
+            <a:avLst/>
+          </a:prstGeom>
+          <a:noFill/>
+          <a:ln/>
+        </p:spPr>
+        <p:txBody>
+          <a:bodyPr wrap="square" lIns="0" tIns="0" rIns="0" bIns="0" rtlCol="0" anchor="ctr"/>
+          <a:lstStyle/>
+          <a:p>
+            <a:pPr algn="ctr" indent="0" marL="0">
               <a:buNone/>
             </a:pPr>
             <a:r>
-              <a:rPr lang="en-US" sz="8800" b="1" dirty="0">
+              <a:rPr lang="en-US" sz="1400" b="1" dirty="0">
+                <a:solidFill>
+                  <a:schemeClr val="tx1"/>
+                </a:solidFill>
+              </a:rPr>
+              <a:t>G1</a:t>
+            </a:r>
+            <a:endParaRPr lang="en-US" sz="1400" dirty="0"/>
+          </a:p>
+        </p:txBody>
+      </p:sp>
+      <p:sp>
+        <p:nvSpPr>
+          <p:cNvPr id="6" name="Gerbang G1 keterangan"/>
+          <p:cNvSpPr txBox="1"/>
+          <p:nvPr/>
+        </p:nvSpPr>
+        <p:spPr>
+          <a:xfrm>
+            <a:off x="1143000" y="2862072"/>
+            <a:ext cx="1554480" cy="1051560"/>
+          </a:xfrm>
+          <a:prstGeom prst="rect">
+            <a:avLst/>
+          </a:prstGeom>
+          <a:noFill/>
+          <a:ln/>
+        </p:spPr>
+        <p:txBody>
+          <a:bodyPr wrap="square" lIns="0" tIns="0" rIns="0" bIns="0" rtlCol="0" anchor="t"/>
+          <a:lstStyle/>
+          <a:p>
+            <a:pPr algn="ctr" indent="0" marL="0">
+              <a:buNone/>
+            </a:pPr>
+            <a:r>
+              <a:rPr lang="en-US" sz="1300" b="1" dirty="0">
                 <a:solidFill>
                   <a:schemeClr val="bg1"/>
                 </a:solidFill>
               </a:rPr>
-              <a:t>KASIH</a:t>
+              <a:t>Penetapan</a:t>
             </a:r>
-            <a:endParaRPr lang="en-US" sz="8800" dirty="0"/>
+            <a:endParaRPr lang="en-US" sz="1300" dirty="0"/>
+          </a:p>
+          <a:p>
+            <a:pPr algn="ctr" indent="0" marL="0">
+              <a:buNone/>
+            </a:pPr>
+            <a:r>
+              <a:rPr lang="en-US" sz="1300" dirty="0">
+                <a:solidFill>
+                  <a:schemeClr val="bg2"/>
+                </a:solidFill>
+              </a:rPr>
+              <a:t>minggu 1–2</a:t>
+            </a:r>
+            <a:endParaRPr lang="en-US" sz="1300" dirty="0"/>
+          </a:p>
+          <a:p>
+            <a:pPr algn="ctr" indent="0" marL="0">
+              <a:buNone/>
+            </a:pPr>
+            <a:r>
+              <a:rPr lang="en-US" sz="1300" b="1" dirty="0">
+                <a:solidFill>
+                  <a:schemeClr val="accent2"/>
+                </a:solidFill>
+              </a:rPr>
+              <a:t>lulus 02/10</a:t>
+            </a:r>
+            <a:endParaRPr lang="en-US" sz="1300" dirty="0"/>
           </a:p>
         </p:txBody>
       </p:sp>
       <p:sp>
         <p:nvSpPr>
-          <p:cNvPr id="3" name="Permohonan dana"/>
+          <p:cNvPr id="7" name="Gerbang G2 lingkaran"/>
+          <p:cNvSpPr/>
+          <p:nvPr/>
+        </p:nvSpPr>
+        <p:spPr>
+          <a:xfrm>
+            <a:off x="3346704" y="2267712"/>
+            <a:ext cx="493776" cy="493776"/>
+          </a:xfrm>
+          <a:prstGeom prst="ellipse">
+            <a:avLst/>
+          </a:prstGeom>
+          <a:solidFill>
+            <a:schemeClr val="accent2"/>
+          </a:solidFill>
+          <a:ln/>
+        </p:spPr>
+      </p:sp>
+      <p:sp>
+        <p:nvSpPr>
+          <p:cNvPr id="8" name="Gerbang G2"/>
           <p:cNvSpPr txBox="1"/>
           <p:nvPr/>
         </p:nvSpPr>
         <p:spPr>
           <a:xfrm>
-            <a:off x="7315200" y="1783080"/>
-            <a:ext cx="3840480" cy="1234440"/>
+            <a:off x="3182112" y="2267712"/>
+            <a:ext cx="822960" cy="493776"/>
+          </a:xfrm>
+          <a:prstGeom prst="rect">
+            <a:avLst/>
+          </a:prstGeom>
+          <a:noFill/>
+          <a:ln/>
+        </p:spPr>
+        <p:txBody>
+          <a:bodyPr wrap="square" lIns="0" tIns="0" rIns="0" bIns="0" rtlCol="0" anchor="ctr"/>
+          <a:lstStyle/>
+          <a:p>
+            <a:pPr algn="ctr" indent="0" marL="0">
+              <a:buNone/>
+            </a:pPr>
+            <a:r>
+              <a:rPr lang="en-US" sz="1400" b="1" dirty="0">
+                <a:solidFill>
+                  <a:schemeClr val="tx1"/>
+                </a:solidFill>
+              </a:rPr>
+              <a:t>G2</a:t>
+            </a:r>
+            <a:endParaRPr lang="en-US" sz="1400" dirty="0"/>
+          </a:p>
+        </p:txBody>
+      </p:sp>
+      <p:sp>
+        <p:nvSpPr>
+          <p:cNvPr id="9" name="Gerbang G2 keterangan"/>
+          <p:cNvSpPr txBox="1"/>
+          <p:nvPr/>
+        </p:nvSpPr>
+        <p:spPr>
+          <a:xfrm>
+            <a:off x="2816352" y="2862072"/>
+            <a:ext cx="1554480" cy="1051560"/>
           </a:xfrm>
           <a:prstGeom prst="rect">
             <a:avLst/>
@@ -6539,45 +6259,115 @@
           <a:bodyPr wrap="square" lIns="0" tIns="0" rIns="0" bIns="0" rtlCol="0" anchor="t"/>
           <a:lstStyle/>
           <a:p>
-            <a:pPr indent="0" marL="0">
+            <a:pPr algn="ctr" indent="0" marL="0">
               <a:buNone/>
             </a:pPr>
             <a:r>
-              <a:rPr lang="en-US" sz="1800" dirty="0">
+              <a:rPr lang="en-US" sz="1300" b="1" dirty="0">
                 <a:solidFill>
                   <a:schemeClr val="bg1"/>
                 </a:solidFill>
               </a:rPr>
-              <a:t>Mohon persetujuan dana</a:t>
+              <a:t>Rancangan + RAB</a:t>
             </a:r>
-            <a:endParaRPr lang="en-US" sz="1800" dirty="0"/>
-          </a:p>
-          <a:p>
-            <a:pPr indent="0" marL="0">
+            <a:endParaRPr lang="en-US" sz="1300" dirty="0"/>
+          </a:p>
+          <a:p>
+            <a:pPr algn="ctr" indent="0" marL="0">
               <a:buNone/>
             </a:pPr>
             <a:r>
-              <a:rPr lang="en-US" sz="4800" b="1" dirty="0">
+              <a:rPr lang="en-US" sz="1300" dirty="0">
+                <a:solidFill>
+                  <a:schemeClr val="bg2"/>
+                </a:solidFill>
+              </a:rPr>
+              <a:t>minggu 3–6</a:t>
+            </a:r>
+            <a:endParaRPr lang="en-US" sz="1300" dirty="0"/>
+          </a:p>
+          <a:p>
+            <a:pPr algn="ctr" indent="0" marL="0">
+              <a:buNone/>
+            </a:pPr>
+            <a:r>
+              <a:rPr lang="en-US" sz="1300" b="1" dirty="0">
                 <a:solidFill>
                   <a:schemeClr val="accent2"/>
                 </a:solidFill>
               </a:rPr>
-              <a:t>Rp887.000</a:t>
+              <a:t>hari ini</a:t>
             </a:r>
-            <a:endParaRPr lang="en-US" sz="1800" dirty="0"/>
+            <a:endParaRPr lang="en-US" sz="1300" dirty="0"/>
           </a:p>
         </p:txBody>
       </p:sp>
       <p:sp>
         <p:nvSpPr>
-          <p:cNvPr id="4" name="Permohonan keterangan"/>
+          <p:cNvPr id="10" name="Gerbang FMEA lingkaran"/>
+          <p:cNvSpPr/>
+          <p:nvPr/>
+        </p:nvSpPr>
+        <p:spPr>
+          <a:xfrm>
+            <a:off x="5020056" y="2267712"/>
+            <a:ext cx="493776" cy="493776"/>
+          </a:xfrm>
+          <a:prstGeom prst="ellipse">
+            <a:avLst/>
+          </a:prstGeom>
+          <a:solidFill>
+            <a:schemeClr val="accent1"/>
+          </a:solidFill>
+          <a:ln/>
+        </p:spPr>
+      </p:sp>
+      <p:sp>
+        <p:nvSpPr>
+          <p:cNvPr id="11" name="Gerbang FMEA"/>
           <p:cNvSpPr txBox="1"/>
           <p:nvPr/>
         </p:nvSpPr>
         <p:spPr>
           <a:xfrm>
-            <a:off x="7315200" y="3090672"/>
-            <a:ext cx="3749040" cy="548640"/>
+            <a:off x="4855464" y="2267712"/>
+            <a:ext cx="822960" cy="493776"/>
+          </a:xfrm>
+          <a:prstGeom prst="rect">
+            <a:avLst/>
+          </a:prstGeom>
+          <a:noFill/>
+          <a:ln/>
+        </p:spPr>
+        <p:txBody>
+          <a:bodyPr wrap="square" lIns="0" tIns="0" rIns="0" bIns="0" rtlCol="0" anchor="ctr"/>
+          <a:lstStyle/>
+          <a:p>
+            <a:pPr algn="ctr" indent="0" marL="0">
+              <a:buNone/>
+            </a:pPr>
+            <a:r>
+              <a:rPr lang="en-US" sz="1100" b="1" dirty="0">
+                <a:solidFill>
+                  <a:schemeClr val="bg1"/>
+                </a:solidFill>
+              </a:rPr>
+              <a:t>FMEA</a:t>
+            </a:r>
+            <a:endParaRPr lang="en-US" sz="1100" dirty="0"/>
+          </a:p>
+        </p:txBody>
+      </p:sp>
+      <p:sp>
+        <p:nvSpPr>
+          <p:cNvPr id="12" name="Gerbang FMEA keterangan"/>
+          <p:cNvSpPr txBox="1"/>
+          <p:nvPr/>
+        </p:nvSpPr>
+        <p:spPr>
+          <a:xfrm>
+            <a:off x="4489704" y="2862072"/>
+            <a:ext cx="1554480" cy="1051560"/>
           </a:xfrm>
           <a:prstGeom prst="rect">
             <a:avLst/>
@@ -6588,6 +6378,411 @@
         <p:txBody>
           <a:bodyPr wrap="square" lIns="0" tIns="0" rIns="0" bIns="0" rtlCol="0" anchor="t"/>
           <a:lstStyle/>
+          <a:p>
+            <a:pPr algn="ctr" indent="0" marL="0">
+              <a:buNone/>
+            </a:pPr>
+            <a:r>
+              <a:rPr lang="en-US" sz="1300" b="1" dirty="0">
+                <a:solidFill>
+                  <a:schemeClr val="bg1"/>
+                </a:solidFill>
+              </a:rPr>
+              <a:t>Analisis bahaya</a:t>
+            </a:r>
+            <a:endParaRPr lang="en-US" sz="1300" dirty="0"/>
+          </a:p>
+          <a:p>
+            <a:pPr algn="ctr" indent="0" marL="0">
+              <a:buNone/>
+            </a:pPr>
+            <a:r>
+              <a:rPr lang="en-US" sz="1300" dirty="0">
+                <a:solidFill>
+                  <a:schemeClr val="bg2"/>
+                </a:solidFill>
+              </a:rPr>
+              <a:t>minggu 7–8</a:t>
+            </a:r>
+            <a:endParaRPr lang="en-US" sz="1300" dirty="0"/>
+          </a:p>
+        </p:txBody>
+      </p:sp>
+      <p:sp>
+        <p:nvSpPr>
+          <p:cNvPr id="13" name="Gerbang G3 lingkaran"/>
+          <p:cNvSpPr/>
+          <p:nvPr/>
+        </p:nvSpPr>
+        <p:spPr>
+          <a:xfrm>
+            <a:off x="6693408" y="2267712"/>
+            <a:ext cx="493776" cy="493776"/>
+          </a:xfrm>
+          <a:prstGeom prst="ellipse">
+            <a:avLst/>
+          </a:prstGeom>
+          <a:solidFill>
+            <a:schemeClr val="accent1"/>
+          </a:solidFill>
+          <a:ln/>
+        </p:spPr>
+      </p:sp>
+      <p:sp>
+        <p:nvSpPr>
+          <p:cNvPr id="14" name="Gerbang G3"/>
+          <p:cNvSpPr txBox="1"/>
+          <p:nvPr/>
+        </p:nvSpPr>
+        <p:spPr>
+          <a:xfrm>
+            <a:off x="6528816" y="2267712"/>
+            <a:ext cx="822960" cy="493776"/>
+          </a:xfrm>
+          <a:prstGeom prst="rect">
+            <a:avLst/>
+          </a:prstGeom>
+          <a:noFill/>
+          <a:ln/>
+        </p:spPr>
+        <p:txBody>
+          <a:bodyPr wrap="square" lIns="0" tIns="0" rIns="0" bIns="0" rtlCol="0" anchor="ctr"/>
+          <a:lstStyle/>
+          <a:p>
+            <a:pPr algn="ctr" indent="0" marL="0">
+              <a:buNone/>
+            </a:pPr>
+            <a:r>
+              <a:rPr lang="en-US" sz="1400" b="1" dirty="0">
+                <a:solidFill>
+                  <a:schemeClr val="bg1"/>
+                </a:solidFill>
+              </a:rPr>
+              <a:t>G3</a:t>
+            </a:r>
+            <a:endParaRPr lang="en-US" sz="1400" dirty="0"/>
+          </a:p>
+        </p:txBody>
+      </p:sp>
+      <p:sp>
+        <p:nvSpPr>
+          <p:cNvPr id="15" name="Gerbang G3 keterangan"/>
+          <p:cNvSpPr txBox="1"/>
+          <p:nvPr/>
+        </p:nvSpPr>
+        <p:spPr>
+          <a:xfrm>
+            <a:off x="6163056" y="2862072"/>
+            <a:ext cx="1554480" cy="1051560"/>
+          </a:xfrm>
+          <a:prstGeom prst="rect">
+            <a:avLst/>
+          </a:prstGeom>
+          <a:noFill/>
+          <a:ln/>
+        </p:spPr>
+        <p:txBody>
+          <a:bodyPr wrap="square" lIns="0" tIns="0" rIns="0" bIns="0" rtlCol="0" anchor="t"/>
+          <a:lstStyle/>
+          <a:p>
+            <a:pPr algn="ctr" indent="0" marL="0">
+              <a:buNone/>
+            </a:pPr>
+            <a:r>
+              <a:rPr lang="en-US" sz="1300" b="1" dirty="0">
+                <a:solidFill>
+                  <a:schemeClr val="bg1"/>
+                </a:solidFill>
+              </a:rPr>
+              <a:t>Prototipe jalan 3×, PCB dipesan</a:t>
+            </a:r>
+            <a:endParaRPr lang="en-US" sz="1300" dirty="0"/>
+          </a:p>
+          <a:p>
+            <a:pPr algn="ctr" indent="0" marL="0">
+              <a:buNone/>
+            </a:pPr>
+            <a:r>
+              <a:rPr lang="en-US" sz="1300" dirty="0">
+                <a:solidFill>
+                  <a:schemeClr val="bg2"/>
+                </a:solidFill>
+              </a:rPr>
+              <a:t>≤ minggu 10</a:t>
+            </a:r>
+            <a:endParaRPr lang="en-US" sz="1300" dirty="0"/>
+          </a:p>
+        </p:txBody>
+      </p:sp>
+      <p:sp>
+        <p:nvSpPr>
+          <p:cNvPr id="16" name="Gerbang G4 lingkaran"/>
+          <p:cNvSpPr/>
+          <p:nvPr/>
+        </p:nvSpPr>
+        <p:spPr>
+          <a:xfrm>
+            <a:off x="8366760" y="2267712"/>
+            <a:ext cx="493776" cy="493776"/>
+          </a:xfrm>
+          <a:prstGeom prst="ellipse">
+            <a:avLst/>
+          </a:prstGeom>
+          <a:solidFill>
+            <a:schemeClr val="accent1"/>
+          </a:solidFill>
+          <a:ln/>
+        </p:spPr>
+      </p:sp>
+      <p:sp>
+        <p:nvSpPr>
+          <p:cNvPr id="17" name="Gerbang G4"/>
+          <p:cNvSpPr txBox="1"/>
+          <p:nvPr/>
+        </p:nvSpPr>
+        <p:spPr>
+          <a:xfrm>
+            <a:off x="8202168" y="2267712"/>
+            <a:ext cx="822960" cy="493776"/>
+          </a:xfrm>
+          <a:prstGeom prst="rect">
+            <a:avLst/>
+          </a:prstGeom>
+          <a:noFill/>
+          <a:ln/>
+        </p:spPr>
+        <p:txBody>
+          <a:bodyPr wrap="square" lIns="0" tIns="0" rIns="0" bIns="0" rtlCol="0" anchor="ctr"/>
+          <a:lstStyle/>
+          <a:p>
+            <a:pPr algn="ctr" indent="0" marL="0">
+              <a:buNone/>
+            </a:pPr>
+            <a:r>
+              <a:rPr lang="en-US" sz="1400" b="1" dirty="0">
+                <a:solidFill>
+                  <a:schemeClr val="bg1"/>
+                </a:solidFill>
+              </a:rPr>
+              <a:t>G4</a:t>
+            </a:r>
+            <a:endParaRPr lang="en-US" sz="1400" dirty="0"/>
+          </a:p>
+        </p:txBody>
+      </p:sp>
+      <p:sp>
+        <p:nvSpPr>
+          <p:cNvPr id="18" name="Gerbang G4 keterangan"/>
+          <p:cNvSpPr txBox="1"/>
+          <p:nvPr/>
+        </p:nvSpPr>
+        <p:spPr>
+          <a:xfrm>
+            <a:off x="7836408" y="2862072"/>
+            <a:ext cx="1554480" cy="1051560"/>
+          </a:xfrm>
+          <a:prstGeom prst="rect">
+            <a:avLst/>
+          </a:prstGeom>
+          <a:noFill/>
+          <a:ln/>
+        </p:spPr>
+        <p:txBody>
+          <a:bodyPr wrap="square" lIns="0" tIns="0" rIns="0" bIns="0" rtlCol="0" anchor="t"/>
+          <a:lstStyle/>
+          <a:p>
+            <a:pPr algn="ctr" indent="0" marL="0">
+              <a:buNone/>
+            </a:pPr>
+            <a:r>
+              <a:rPr lang="en-US" sz="1300" b="1" dirty="0">
+                <a:solidFill>
+                  <a:schemeClr val="bg1"/>
+                </a:solidFill>
+              </a:rPr>
+              <a:t>Pembuktian + uji siswa</a:t>
+            </a:r>
+            <a:endParaRPr lang="en-US" sz="1300" dirty="0"/>
+          </a:p>
+          <a:p>
+            <a:pPr algn="ctr" indent="0" marL="0">
+              <a:buNone/>
+            </a:pPr>
+            <a:r>
+              <a:rPr lang="en-US" sz="1300" dirty="0">
+                <a:solidFill>
+                  <a:schemeClr val="bg2"/>
+                </a:solidFill>
+              </a:rPr>
+              <a:t>minggu 11–14</a:t>
+            </a:r>
+            <a:endParaRPr lang="en-US" sz="1300" dirty="0"/>
+          </a:p>
+        </p:txBody>
+      </p:sp>
+      <p:sp>
+        <p:nvSpPr>
+          <p:cNvPr id="19" name="Gerbang G5 lingkaran"/>
+          <p:cNvSpPr/>
+          <p:nvPr/>
+        </p:nvSpPr>
+        <p:spPr>
+          <a:xfrm>
+            <a:off x="10040112" y="2267712"/>
+            <a:ext cx="493776" cy="493776"/>
+          </a:xfrm>
+          <a:prstGeom prst="ellipse">
+            <a:avLst/>
+          </a:prstGeom>
+          <a:solidFill>
+            <a:schemeClr val="accent1"/>
+          </a:solidFill>
+          <a:ln/>
+        </p:spPr>
+      </p:sp>
+      <p:sp>
+        <p:nvSpPr>
+          <p:cNvPr id="20" name="Gerbang G5"/>
+          <p:cNvSpPr txBox="1"/>
+          <p:nvPr/>
+        </p:nvSpPr>
+        <p:spPr>
+          <a:xfrm>
+            <a:off x="9875520" y="2267712"/>
+            <a:ext cx="822960" cy="493776"/>
+          </a:xfrm>
+          <a:prstGeom prst="rect">
+            <a:avLst/>
+          </a:prstGeom>
+          <a:noFill/>
+          <a:ln/>
+        </p:spPr>
+        <p:txBody>
+          <a:bodyPr wrap="square" lIns="0" tIns="0" rIns="0" bIns="0" rtlCol="0" anchor="ctr"/>
+          <a:lstStyle/>
+          <a:p>
+            <a:pPr algn="ctr" indent="0" marL="0">
+              <a:buNone/>
+            </a:pPr>
+            <a:r>
+              <a:rPr lang="en-US" sz="1400" b="1" dirty="0">
+                <a:solidFill>
+                  <a:schemeClr val="bg1"/>
+                </a:solidFill>
+              </a:rPr>
+              <a:t>G5</a:t>
+            </a:r>
+            <a:endParaRPr lang="en-US" sz="1400" dirty="0"/>
+          </a:p>
+        </p:txBody>
+      </p:sp>
+      <p:sp>
+        <p:nvSpPr>
+          <p:cNvPr id="21" name="Gerbang G5 keterangan"/>
+          <p:cNvSpPr txBox="1"/>
+          <p:nvPr/>
+        </p:nvSpPr>
+        <p:spPr>
+          <a:xfrm>
+            <a:off x="9509760" y="2862072"/>
+            <a:ext cx="1554480" cy="1051560"/>
+          </a:xfrm>
+          <a:prstGeom prst="rect">
+            <a:avLst/>
+          </a:prstGeom>
+          <a:noFill/>
+          <a:ln/>
+        </p:spPr>
+        <p:txBody>
+          <a:bodyPr wrap="square" lIns="0" tIns="0" rIns="0" bIns="0" rtlCol="0" anchor="t"/>
+          <a:lstStyle/>
+          <a:p>
+            <a:pPr algn="ctr" indent="0" marL="0">
+              <a:buNone/>
+            </a:pPr>
+            <a:r>
+              <a:rPr lang="en-US" sz="1300" b="1" dirty="0">
+                <a:solidFill>
+                  <a:schemeClr val="bg1"/>
+                </a:solidFill>
+              </a:rPr>
+              <a:t>Serah terima</a:t>
+            </a:r>
+            <a:endParaRPr lang="en-US" sz="1300" dirty="0"/>
+          </a:p>
+          <a:p>
+            <a:pPr algn="ctr" indent="0" marL="0">
+              <a:buNone/>
+            </a:pPr>
+            <a:r>
+              <a:rPr lang="en-US" sz="1300" dirty="0">
+                <a:solidFill>
+                  <a:schemeClr val="bg2"/>
+                </a:solidFill>
+              </a:rPr>
+              <a:t>minggu 15–16</a:t>
+            </a:r>
+            <a:endParaRPr lang="en-US" sz="1300" dirty="0"/>
+          </a:p>
+        </p:txBody>
+      </p:sp>
+      <p:sp>
+        <p:nvSpPr>
+          <p:cNvPr id="22" name="Risiko 1 latar"/>
+          <p:cNvSpPr/>
+          <p:nvPr/>
+        </p:nvSpPr>
+        <p:spPr>
+          <a:xfrm>
+            <a:off x="1463040" y="4069080"/>
+            <a:ext cx="2971800" cy="1325880"/>
+          </a:xfrm>
+          <a:prstGeom prst="rect">
+            <a:avLst/>
+          </a:prstGeom>
+          <a:solidFill>
+            <a:schemeClr val="accent1"/>
+          </a:solidFill>
+          <a:ln/>
+        </p:spPr>
+      </p:sp>
+      <p:sp>
+        <p:nvSpPr>
+          <p:cNvPr id="23" name="Risiko 1 teks"/>
+          <p:cNvSpPr txBox="1"/>
+          <p:nvPr/>
+        </p:nvSpPr>
+        <p:spPr>
+          <a:xfrm>
+            <a:off x="1627632" y="4215384"/>
+            <a:ext cx="2642616" cy="1033272"/>
+          </a:xfrm>
+          <a:prstGeom prst="rect">
+            <a:avLst/>
+          </a:prstGeom>
+          <a:noFill/>
+          <a:ln/>
+        </p:spPr>
+        <p:txBody>
+          <a:bodyPr wrap="square" lIns="0" tIns="0" rIns="0" bIns="0" rtlCol="0" anchor="t"/>
+          <a:lstStyle/>
+          <a:p>
+            <a:pPr indent="0" marL="0">
+              <a:spcAft>
+                <a:spcPts val="600"/>
+              </a:spcAft>
+              <a:buNone/>
+            </a:pPr>
+            <a:r>
+              <a:rPr lang="en-US" sz="1600" b="1" dirty="0">
+                <a:solidFill>
+                  <a:schemeClr val="bg1"/>
+                </a:solidFill>
+              </a:rPr>
+              <a:t>PCB salah desain / terlambat</a:t>
+            </a:r>
+            <a:endParaRPr lang="en-US" sz="1600" dirty="0"/>
+          </a:p>
           <a:p>
             <a:pPr indent="0" marL="0">
               <a:buNone/>
@@ -6598,22 +6793,42 @@
                   <a:schemeClr val="bg1"/>
                 </a:solidFill>
               </a:rPr>
-              <a:t>untuk pembelian komponen dan fabrikasi 2 PCB. Sesudah dana cair:</a:t>
+              <a:t>Prototipe breadboard dulu, PCB dipesan paling lambat minggu 10</a:t>
             </a:r>
-            <a:endParaRPr lang="en-US" sz="1400" dirty="0"/>
+            <a:endParaRPr lang="en-US" sz="1600" dirty="0"/>
           </a:p>
         </p:txBody>
       </p:sp>
       <p:sp>
         <p:nvSpPr>
-          <p:cNvPr id="5" name="Langkah sesudah dana"/>
+          <p:cNvPr id="24" name="Risiko 2 latar"/>
+          <p:cNvSpPr/>
+          <p:nvPr/>
+        </p:nvSpPr>
+        <p:spPr>
+          <a:xfrm>
+            <a:off x="4617720" y="4069080"/>
+            <a:ext cx="2971800" cy="1325880"/>
+          </a:xfrm>
+          <a:prstGeom prst="rect">
+            <a:avLst/>
+          </a:prstGeom>
+          <a:solidFill>
+            <a:schemeClr val="accent1"/>
+          </a:solidFill>
+          <a:ln/>
+        </p:spPr>
+      </p:sp>
+      <p:sp>
+        <p:nvSpPr>
+          <p:cNvPr id="25" name="Risiko 2 teks"/>
           <p:cNvSpPr txBox="1"/>
           <p:nvPr/>
         </p:nvSpPr>
         <p:spPr>
           <a:xfrm>
-            <a:off x="7315200" y="3703320"/>
-            <a:ext cx="3749040" cy="1554480"/>
+            <a:off x="4782312" y="4215384"/>
+            <a:ext cx="2642616" cy="1033272"/>
           </a:xfrm>
           <a:prstGeom prst="rect">
             <a:avLst/>
@@ -6625,142 +6840,110 @@
           <a:bodyPr wrap="square" lIns="0" tIns="0" rIns="0" bIns="0" rtlCol="0" anchor="t"/>
           <a:lstStyle/>
           <a:p>
-            <a:pPr marL="342900" indent="-342900">
+            <a:pPr indent="0" marL="0">
               <a:spcAft>
                 <a:spcPts val="600"/>
               </a:spcAft>
-              <a:buSzPct val="100000"/>
-              <a:buFont typeface="+mj-lt"/>
-              <a:buAutoNum type="arabicPeriod" startAt="1"/>
+              <a:buNone/>
             </a:pPr>
             <a:r>
-              <a:rPr lang="en-US" sz="1600" dirty="0">
+              <a:rPr lang="en-US" sz="1600" b="1" dirty="0">
                 <a:solidFill>
                   <a:schemeClr val="bg1"/>
                 </a:solidFill>
               </a:rPr>
-              <a:t>Beli komponen</a:t>
+              <a:t>Biaya melebihi batas</a:t>
             </a:r>
             <a:endParaRPr lang="en-US" sz="1600" dirty="0"/>
           </a:p>
           <a:p>
-            <a:pPr marL="342900" indent="-342900">
-              <a:spcAft>
-                <a:spcPts val="600"/>
-              </a:spcAft>
-              <a:buSzPct val="100000"/>
-              <a:buFont typeface="+mj-lt"/>
-              <a:buAutoNum type="arabicPeriod" startAt="1"/>
+            <a:pPr indent="0" marL="0">
+              <a:buNone/>
             </a:pPr>
             <a:r>
-              <a:rPr lang="en-US" sz="1600" dirty="0">
+              <a:rPr lang="en-US" sz="1400" dirty="0">
                 <a:solidFill>
                   <a:schemeClr val="bg1"/>
                 </a:solidFill>
               </a:rPr>
-              <a:t>Uji rangkaian di breadboard</a:t>
+              <a:t>RAB dipantau tiap pembelian, harga disertai tautan toko</a:t>
             </a:r>
             <a:endParaRPr lang="en-US" sz="1600" dirty="0"/>
           </a:p>
-          <a:p>
-            <a:pPr marL="342900" indent="-342900">
+        </p:txBody>
+      </p:sp>
+      <p:sp>
+        <p:nvSpPr>
+          <p:cNvPr id="26" name="Risiko 3 latar"/>
+          <p:cNvSpPr/>
+          <p:nvPr/>
+        </p:nvSpPr>
+        <p:spPr>
+          <a:xfrm>
+            <a:off x="7772400" y="4069080"/>
+            <a:ext cx="2971800" cy="1325880"/>
+          </a:xfrm>
+          <a:prstGeom prst="rect">
+            <a:avLst/>
+          </a:prstGeom>
+          <a:solidFill>
+            <a:schemeClr val="accent1"/>
+          </a:solidFill>
+          <a:ln/>
+        </p:spPr>
+      </p:sp>
+      <p:sp>
+        <p:nvSpPr>
+          <p:cNvPr id="27" name="Risiko 3 teks"/>
+          <p:cNvSpPr txBox="1"/>
+          <p:nvPr/>
+        </p:nvSpPr>
+        <p:spPr>
+          <a:xfrm>
+            <a:off x="7936992" y="4215384"/>
+            <a:ext cx="2642616" cy="1033272"/>
+          </a:xfrm>
+          <a:prstGeom prst="rect">
+            <a:avLst/>
+          </a:prstGeom>
+          <a:noFill/>
+          <a:ln/>
+        </p:spPr>
+        <p:txBody>
+          <a:bodyPr wrap="square" lIns="0" tIns="0" rIns="0" bIns="0" rtlCol="0" anchor="t"/>
+          <a:lstStyle/>
+          <a:p>
+            <a:pPr indent="0" marL="0">
               <a:spcAft>
                 <a:spcPts val="600"/>
               </a:spcAft>
-              <a:buSzPct val="100000"/>
-              <a:buFont typeface="+mj-lt"/>
-              <a:buAutoNum type="arabicPeriod" startAt="1"/>
+              <a:buNone/>
             </a:pPr>
             <a:r>
-              <a:rPr lang="en-US" sz="1600" dirty="0">
+              <a:rPr lang="en-US" sz="1600" b="1" dirty="0">
                 <a:solidFill>
                   <a:schemeClr val="bg1"/>
                 </a:solidFill>
               </a:rPr>
-              <a:t>Pesan PCB sensor + PCB utama</a:t>
+              <a:t>QRE tanpa cadangan</a:t>
             </a:r>
             <a:endParaRPr lang="en-US" sz="1600" dirty="0"/>
           </a:p>
           <a:p>
-            <a:pPr marL="342900" indent="-342900">
-              <a:spcAft>
-                <a:spcPts val="600"/>
-              </a:spcAft>
-              <a:buSzPct val="100000"/>
-              <a:buFont typeface="+mj-lt"/>
-              <a:buAutoNum type="arabicPeriod" startAt="1"/>
+            <a:pPr indent="0" marL="0">
+              <a:buNone/>
             </a:pPr>
             <a:r>
-              <a:rPr lang="en-US" sz="1600" dirty="0">
+              <a:rPr lang="en-US" sz="1400" dirty="0">
                 <a:solidFill>
                   <a:schemeClr val="bg1"/>
                 </a:solidFill>
               </a:rPr>
-              <a:t>Firmware dan prototipe untuk G3</a:t>
+              <a:t>Tiap sensor diuji di breadboard sebelum disolder</a:t>
             </a:r>
             <a:endParaRPr lang="en-US" sz="1600" dirty="0"/>
           </a:p>
         </p:txBody>
-      </p:sp>
-      <p:sp>
-        <p:nvSpPr>
-          <p:cNvPr id="6" name="Titik hias 1"/>
-          <p:cNvSpPr/>
-          <p:nvPr/>
-        </p:nvSpPr>
-        <p:spPr>
-          <a:xfrm>
-            <a:off x="4572000" y="5074920"/>
-            <a:ext cx="155448" cy="155448"/>
-          </a:xfrm>
-          <a:prstGeom prst="ellipse">
-            <a:avLst/>
-          </a:prstGeom>
-          <a:solidFill>
-            <a:schemeClr val="bg1"/>
-          </a:solidFill>
-          <a:ln/>
-        </p:spPr>
-      </p:sp>
-      <p:sp>
-        <p:nvSpPr>
-          <p:cNvPr id="7" name="Titik hias 2"/>
-          <p:cNvSpPr/>
-          <p:nvPr/>
-        </p:nvSpPr>
-        <p:spPr>
-          <a:xfrm>
-            <a:off x="4818888" y="5074920"/>
-            <a:ext cx="155448" cy="155448"/>
-          </a:xfrm>
-          <a:prstGeom prst="ellipse">
-            <a:avLst/>
-          </a:prstGeom>
-          <a:solidFill>
-            <a:schemeClr val="bg1"/>
-          </a:solidFill>
-          <a:ln/>
-        </p:spPr>
-      </p:sp>
-      <p:sp>
-        <p:nvSpPr>
-          <p:cNvPr id="8" name="Titik hias 3"/>
-          <p:cNvSpPr/>
-          <p:nvPr/>
-        </p:nvSpPr>
-        <p:spPr>
-          <a:xfrm>
-            <a:off x="5065776" y="5074920"/>
-            <a:ext cx="155448" cy="155448"/>
-          </a:xfrm>
-          <a:prstGeom prst="ellipse">
-            <a:avLst/>
-          </a:prstGeom>
-          <a:solidFill>
-            <a:schemeClr val="bg1"/>
-          </a:solidFill>
-          <a:ln/>
-        </p:spPr>
       </p:sp>
     </p:spTree>
   </p:cSld>
@@ -6797,6 +6980,333 @@
         </p:nvSpPr>
         <p:spPr>
           <a:xfrm>
+            <a:off x="1536192" y="1828800"/>
+            <a:ext cx="5669280" cy="3017520"/>
+          </a:xfrm>
+          <a:prstGeom prst="rect">
+            <a:avLst/>
+          </a:prstGeom>
+          <a:noFill/>
+          <a:ln/>
+        </p:spPr>
+        <p:txBody>
+          <a:bodyPr wrap="square" lIns="0" tIns="0" rIns="0" bIns="0" rtlCol="0" anchor="ctr"/>
+          <a:lstStyle/>
+          <a:p>
+            <a:pPr algn="l" indent="0" marL="0">
+              <a:lnSpc>
+                <a:spcPct val="85000"/>
+              </a:lnSpc>
+              <a:buNone/>
+            </a:pPr>
+            <a:r>
+              <a:rPr lang="en-US" sz="8800" b="1" dirty="0">
+                <a:solidFill>
+                  <a:schemeClr val="bg1"/>
+                </a:solidFill>
+              </a:rPr>
+              <a:t>TERIMA</a:t>
+            </a:r>
+            <a:endParaRPr lang="en-US" sz="8800" dirty="0"/>
+          </a:p>
+          <a:p>
+            <a:pPr algn="l" indent="0" marL="0">
+              <a:lnSpc>
+                <a:spcPct val="85000"/>
+              </a:lnSpc>
+              <a:buNone/>
+            </a:pPr>
+            <a:r>
+              <a:rPr lang="en-US" sz="8800" b="1" dirty="0">
+                <a:solidFill>
+                  <a:schemeClr val="bg1"/>
+                </a:solidFill>
+              </a:rPr>
+              <a:t>KASIH</a:t>
+            </a:r>
+            <a:endParaRPr lang="en-US" sz="8800" dirty="0"/>
+          </a:p>
+        </p:txBody>
+      </p:sp>
+      <p:sp>
+        <p:nvSpPr>
+          <p:cNvPr id="3" name="Permohonan dana"/>
+          <p:cNvSpPr txBox="1"/>
+          <p:nvPr/>
+        </p:nvSpPr>
+        <p:spPr>
+          <a:xfrm>
+            <a:off x="7315200" y="1783080"/>
+            <a:ext cx="3840480" cy="1234440"/>
+          </a:xfrm>
+          <a:prstGeom prst="rect">
+            <a:avLst/>
+          </a:prstGeom>
+          <a:noFill/>
+          <a:ln/>
+        </p:spPr>
+        <p:txBody>
+          <a:bodyPr wrap="square" lIns="0" tIns="0" rIns="0" bIns="0" rtlCol="0" anchor="t"/>
+          <a:lstStyle/>
+          <a:p>
+            <a:pPr indent="0" marL="0">
+              <a:buNone/>
+            </a:pPr>
+            <a:r>
+              <a:rPr lang="en-US" sz="1800" dirty="0">
+                <a:solidFill>
+                  <a:schemeClr val="bg1"/>
+                </a:solidFill>
+              </a:rPr>
+              <a:t>Mohon persetujuan dana</a:t>
+            </a:r>
+            <a:endParaRPr lang="en-US" sz="1800" dirty="0"/>
+          </a:p>
+          <a:p>
+            <a:pPr indent="0" marL="0">
+              <a:buNone/>
+            </a:pPr>
+            <a:r>
+              <a:rPr lang="en-US" sz="4800" b="1" dirty="0">
+                <a:solidFill>
+                  <a:schemeClr val="accent2"/>
+                </a:solidFill>
+              </a:rPr>
+              <a:t>Rp887.000</a:t>
+            </a:r>
+            <a:endParaRPr lang="en-US" sz="1800" dirty="0"/>
+          </a:p>
+        </p:txBody>
+      </p:sp>
+      <p:sp>
+        <p:nvSpPr>
+          <p:cNvPr id="4" name="Permohonan keterangan"/>
+          <p:cNvSpPr txBox="1"/>
+          <p:nvPr/>
+        </p:nvSpPr>
+        <p:spPr>
+          <a:xfrm>
+            <a:off x="7315200" y="3090672"/>
+            <a:ext cx="3749040" cy="548640"/>
+          </a:xfrm>
+          <a:prstGeom prst="rect">
+            <a:avLst/>
+          </a:prstGeom>
+          <a:noFill/>
+          <a:ln/>
+        </p:spPr>
+        <p:txBody>
+          <a:bodyPr wrap="square" lIns="0" tIns="0" rIns="0" bIns="0" rtlCol="0" anchor="t"/>
+          <a:lstStyle/>
+          <a:p>
+            <a:pPr indent="0" marL="0">
+              <a:buNone/>
+            </a:pPr>
+            <a:r>
+              <a:rPr lang="en-US" sz="1400" dirty="0">
+                <a:solidFill>
+                  <a:schemeClr val="bg1"/>
+                </a:solidFill>
+              </a:rPr>
+              <a:t>untuk pembelian komponen dan fabrikasi 2 PCB. Sesudah dana cair:</a:t>
+            </a:r>
+            <a:endParaRPr lang="en-US" sz="1400" dirty="0"/>
+          </a:p>
+        </p:txBody>
+      </p:sp>
+      <p:sp>
+        <p:nvSpPr>
+          <p:cNvPr id="5" name="Langkah sesudah dana"/>
+          <p:cNvSpPr txBox="1"/>
+          <p:nvPr/>
+        </p:nvSpPr>
+        <p:spPr>
+          <a:xfrm>
+            <a:off x="7315200" y="3703320"/>
+            <a:ext cx="3749040" cy="1554480"/>
+          </a:xfrm>
+          <a:prstGeom prst="rect">
+            <a:avLst/>
+          </a:prstGeom>
+          <a:noFill/>
+          <a:ln/>
+        </p:spPr>
+        <p:txBody>
+          <a:bodyPr wrap="square" lIns="0" tIns="0" rIns="0" bIns="0" rtlCol="0" anchor="t"/>
+          <a:lstStyle/>
+          <a:p>
+            <a:pPr marL="342900" indent="-342900">
+              <a:spcAft>
+                <a:spcPts val="600"/>
+              </a:spcAft>
+              <a:buSzPct val="100000"/>
+              <a:buFont typeface="+mj-lt"/>
+              <a:buAutoNum type="arabicPeriod" startAt="1"/>
+            </a:pPr>
+            <a:r>
+              <a:rPr lang="en-US" sz="1600" dirty="0">
+                <a:solidFill>
+                  <a:schemeClr val="bg1"/>
+                </a:solidFill>
+              </a:rPr>
+              <a:t>Beli komponen</a:t>
+            </a:r>
+            <a:endParaRPr lang="en-US" sz="1600" dirty="0"/>
+          </a:p>
+          <a:p>
+            <a:pPr marL="342900" indent="-342900">
+              <a:spcAft>
+                <a:spcPts val="600"/>
+              </a:spcAft>
+              <a:buSzPct val="100000"/>
+              <a:buFont typeface="+mj-lt"/>
+              <a:buAutoNum type="arabicPeriod" startAt="1"/>
+            </a:pPr>
+            <a:r>
+              <a:rPr lang="en-US" sz="1600" dirty="0">
+                <a:solidFill>
+                  <a:schemeClr val="bg1"/>
+                </a:solidFill>
+              </a:rPr>
+              <a:t>Uji rangkaian di breadboard</a:t>
+            </a:r>
+            <a:endParaRPr lang="en-US" sz="1600" dirty="0"/>
+          </a:p>
+          <a:p>
+            <a:pPr marL="342900" indent="-342900">
+              <a:spcAft>
+                <a:spcPts val="600"/>
+              </a:spcAft>
+              <a:buSzPct val="100000"/>
+              <a:buFont typeface="+mj-lt"/>
+              <a:buAutoNum type="arabicPeriod" startAt="1"/>
+            </a:pPr>
+            <a:r>
+              <a:rPr lang="en-US" sz="1600" dirty="0">
+                <a:solidFill>
+                  <a:schemeClr val="bg1"/>
+                </a:solidFill>
+              </a:rPr>
+              <a:t>Pesan PCB sensor + PCB utama</a:t>
+            </a:r>
+            <a:endParaRPr lang="en-US" sz="1600" dirty="0"/>
+          </a:p>
+          <a:p>
+            <a:pPr marL="342900" indent="-342900">
+              <a:spcAft>
+                <a:spcPts val="600"/>
+              </a:spcAft>
+              <a:buSzPct val="100000"/>
+              <a:buFont typeface="+mj-lt"/>
+              <a:buAutoNum type="arabicPeriod" startAt="1"/>
+            </a:pPr>
+            <a:r>
+              <a:rPr lang="en-US" sz="1600" dirty="0">
+                <a:solidFill>
+                  <a:schemeClr val="bg1"/>
+                </a:solidFill>
+              </a:rPr>
+              <a:t>Firmware dan prototipe untuk G3</a:t>
+            </a:r>
+            <a:endParaRPr lang="en-US" sz="1600" dirty="0"/>
+          </a:p>
+        </p:txBody>
+      </p:sp>
+      <p:sp>
+        <p:nvSpPr>
+          <p:cNvPr id="6" name="Titik hias 1"/>
+          <p:cNvSpPr/>
+          <p:nvPr/>
+        </p:nvSpPr>
+        <p:spPr>
+          <a:xfrm>
+            <a:off x="4572000" y="5074920"/>
+            <a:ext cx="155448" cy="155448"/>
+          </a:xfrm>
+          <a:prstGeom prst="ellipse">
+            <a:avLst/>
+          </a:prstGeom>
+          <a:solidFill>
+            <a:schemeClr val="bg1"/>
+          </a:solidFill>
+          <a:ln/>
+        </p:spPr>
+      </p:sp>
+      <p:sp>
+        <p:nvSpPr>
+          <p:cNvPr id="7" name="Titik hias 2"/>
+          <p:cNvSpPr/>
+          <p:nvPr/>
+        </p:nvSpPr>
+        <p:spPr>
+          <a:xfrm>
+            <a:off x="4818888" y="5074920"/>
+            <a:ext cx="155448" cy="155448"/>
+          </a:xfrm>
+          <a:prstGeom prst="ellipse">
+            <a:avLst/>
+          </a:prstGeom>
+          <a:solidFill>
+            <a:schemeClr val="bg1"/>
+          </a:solidFill>
+          <a:ln/>
+        </p:spPr>
+      </p:sp>
+      <p:sp>
+        <p:nvSpPr>
+          <p:cNvPr id="8" name="Titik hias 3"/>
+          <p:cNvSpPr/>
+          <p:nvPr/>
+        </p:nvSpPr>
+        <p:spPr>
+          <a:xfrm>
+            <a:off x="5065776" y="5074920"/>
+            <a:ext cx="155448" cy="155448"/>
+          </a:xfrm>
+          <a:prstGeom prst="ellipse">
+            <a:avLst/>
+          </a:prstGeom>
+          <a:solidFill>
+            <a:schemeClr val="bg1"/>
+          </a:solidFill>
+          <a:ln/>
+        </p:spPr>
+      </p:sp>
+    </p:spTree>
+  </p:cSld>
+  <p:clrMapOvr>
+    <a:masterClrMapping/>
+  </p:clrMapOvr>
+</p:sld>
+</file>
+
+<file path=ppt/slides/slide17.xml><?xml version="1.0" encoding="utf-8"?>
+<p:sld xmlns:a="http://schemas.openxmlformats.org/drawingml/2006/main" xmlns:r="http://schemas.openxmlformats.org/officeDocument/2006/relationships" xmlns:p="http://schemas.openxmlformats.org/presentationml/2006/main">
+  <p:cSld name="Slide 17">
+    <p:spTree>
+      <p:nvGrpSpPr>
+        <p:cNvPr id="1" name=""/>
+        <p:cNvGrpSpPr/>
+        <p:nvPr/>
+      </p:nvGrpSpPr>
+      <p:grpSpPr>
+        <a:xfrm>
+          <a:off x="0" y="0"/>
+          <a:ext cx="0" cy="0"/>
+          <a:chOff x="0" y="0"/>
+          <a:chExt cx="0" cy="0"/>
+        </a:xfrm>
+      </p:grpSpPr>
+      <p:sp>
+        <p:nvSpPr>
+          <p:cNvPr id="2" name="Text 3"/>
+          <p:cNvSpPr/>
+          <p:nvPr>
+            <p:ph idx="103" type="title" hasCustomPrompt="1"/>
+          </p:nvPr>
+        </p:nvSpPr>
+        <p:spPr>
+          <a:xfrm>
             <a:off x="1353312" y="1069848"/>
             <a:ext cx="9784080" cy="786384"/>
           </a:xfrm>
@@ -6827,7 +7337,7 @@
       </p:sp>
       <p:graphicFrame>
         <p:nvGraphicFramePr>
-          <p:cNvPr id="17" name="Tabel RAB elektrikal 1"/>
+          <p:cNvPr id="18" name="Tabel RAB elektrikal 1"/>
           <p:cNvGraphicFramePr>
             <a:graphicFrameLocks noGrp="1"/>
           </p:cNvGraphicFramePr>
@@ -9801,9 +10311,9 @@
 </p:sld>
 </file>
 
-<file path=ppt/slides/slide17.xml><?xml version="1.0" encoding="utf-8"?>
+<file path=ppt/slides/slide18.xml><?xml version="1.0" encoding="utf-8"?>
 <p:sld xmlns:a="http://schemas.openxmlformats.org/drawingml/2006/main" xmlns:r="http://schemas.openxmlformats.org/officeDocument/2006/relationships" xmlns:p="http://schemas.openxmlformats.org/presentationml/2006/main">
-  <p:cSld name="Slide 17">
+  <p:cSld name="Slide 18">
     <p:spTree>
       <p:nvGrpSpPr>
         <p:cNvPr id="1" name=""/>
@@ -9858,7 +10368,7 @@
       </p:sp>
       <p:graphicFrame>
         <p:nvGraphicFramePr>
-          <p:cNvPr id="18" name="Tabel RAB elektrikal 2"/>
+          <p:cNvPr id="19" name="Tabel RAB elektrikal 2"/>
           <p:cNvGraphicFramePr>
             <a:graphicFrameLocks noGrp="1"/>
           </p:cNvGraphicFramePr>
@@ -12832,9 +13342,9 @@
 </p:sld>
 </file>
 
-<file path=ppt/slides/slide18.xml><?xml version="1.0" encoding="utf-8"?>
+<file path=ppt/slides/slide19.xml><?xml version="1.0" encoding="utf-8"?>
 <p:sld xmlns:a="http://schemas.openxmlformats.org/drawingml/2006/main" xmlns:r="http://schemas.openxmlformats.org/officeDocument/2006/relationships" xmlns:p="http://schemas.openxmlformats.org/presentationml/2006/main">
-  <p:cSld name="Slide 18">
+  <p:cSld name="Slide 19">
     <p:spTree>
       <p:nvGrpSpPr>
         <p:cNvPr id="1" name=""/>
@@ -12889,7 +13399,7 @@
       </p:sp>
       <p:graphicFrame>
         <p:nvGraphicFramePr>
-          <p:cNvPr id="19" name="Tabel RAB mekanik"/>
+          <p:cNvPr id="20" name="Tabel RAB mekanik"/>
           <p:cNvGraphicFramePr>
             <a:graphicFrameLocks noGrp="1"/>
           </p:cNvGraphicFramePr>

</xml_diff>

<commit_message>
RAB jadi Rp937.390: harga hasil validasi marketplace dari spreadsheet kelompok (charter + docx, deck, naskah)
Sumber: RAB PJBL P01.ods. Electrical Rp862.390 + Mechanical Rp50.000 + Lain-lain (timah + flux)
Rp25.000, sisa Rp62.610 dari Rp1.000.000. Keputusan user: mux tetap IC CD74HC4067M WKH Rp20.000
(baris spreadsheet ternyata modul kakarobot Rp35.000), ball caster ganti skid nilon, bracket motor
dihapus, resistor THT masuk komponen pendukung, PCB utama nanti ikut barang di link (tombol 12x12 mm,
JST XH 6 pin untuk motor). Charter dapat tabel tautan toko. Deck diubah langsung di XML .pptx
(slide 4, 5, 12, 13, 14, 16, lampiran A-C, grafik, catatan); build.js disamakan.

Co-Authored-By: Claude Opus 5.5 <noreply@anthropic.com>
</commit_message>
<xml_diff>
--- a/docs/pitching-rab/LFM_Pitching_RAB_P01-5.pptx
+++ b/docs/pitching-rab/LFM_Pitching_RAB_P01-5.pptx
@@ -285,7 +285,7 @@
                     <c:v>Otak &amp; antarmuka</c:v>
                   </c:pt>
                   <c:pt idx="5">
-                    <c:v>Mekanik lain</c:v>
+                    <c:v>Mekanik &amp; timah</c:v>
                   </c:pt>
                 </c:lvl>
               </c:multiLvlStrCache>
@@ -304,16 +304,16 @@
                   <c:v>203</c:v>
                 </c:pt>
                 <c:pt idx="2">
-                  <c:v>170</c:v>
+                  <c:v>185</c:v>
                 </c:pt>
                 <c:pt idx="3">
-                  <c:v>136</c:v>
+                  <c:v>150.99</c:v>
                 </c:pt>
                 <c:pt idx="4">
-                  <c:v>118</c:v>
+                  <c:v>108.4</c:v>
                 </c:pt>
                 <c:pt idx="5">
-                  <c:v>20</c:v>
+                  <c:v>50</c:v>
                 </c:pt>
               </c:numCache>
             </c:numRef>
@@ -563,9 +563,9 @@
           </c:marker>
           <c:cat>
             <c:multiLvlStrRef>
-              <c:f>Sheet1!$A$2:$A$11</c:f>
+              <c:f>Sheet1!$A$2:$A$12</c:f>
               <c:multiLvlStrCache>
-                <c:ptCount val="10"/>
+                <c:ptCount val="11"/>
                 <c:lvl>
                   <c:pt idx="0">
                     <c:v>Rev 3.2</c:v>
@@ -597,16 +597,19 @@
                   <c:pt idx="9">
                     <c:v>26/10</c:v>
                   </c:pt>
+                  <c:pt idx="10">
+                    <c:v>27/10</c:v>
+                  </c:pt>
                 </c:lvl>
               </c:multiLvlStrCache>
             </c:multiLvlStrRef>
           </c:cat>
           <c:val>
             <c:numRef>
-              <c:f>Sheet1!$B$2:$B$11</c:f>
+              <c:f>Sheet1!$B$2:$B$12</c:f>
               <c:numCache>
                 <c:formatCode>General</c:formatCode>
-                <c:ptCount val="10"/>
+                <c:ptCount val="11"/>
                 <c:pt idx="0">
                   <c:v>845</c:v>
                 </c:pt>
@@ -636,6 +639,9 @@
                 </c:pt>
                 <c:pt idx="9">
                   <c:v>887</c:v>
+                </c:pt>
+                <c:pt idx="10">
+                  <c:v>937.4</c:v>
                 </c:pt>
               </c:numCache>
             </c:numRef>
@@ -745,9 +751,9 @@
           </c:marker>
           <c:cat>
             <c:multiLvlStrRef>
-              <c:f>Sheet1!$A$2:$A$11</c:f>
+              <c:f>Sheet1!$A$2:$A$12</c:f>
               <c:multiLvlStrCache>
-                <c:ptCount val="10"/>
+                <c:ptCount val="11"/>
                 <c:lvl>
                   <c:pt idx="0">
                     <c:v>Rev 3.2</c:v>
@@ -779,16 +785,19 @@
                   <c:pt idx="9">
                     <c:v>26/10</c:v>
                   </c:pt>
+                  <c:pt idx="10">
+                    <c:v>27/10</c:v>
+                  </c:pt>
                 </c:lvl>
               </c:multiLvlStrCache>
             </c:multiLvlStrRef>
           </c:cat>
           <c:val>
             <c:numRef>
-              <c:f>Sheet1!$C$2:$C$11</c:f>
+              <c:f>Sheet1!$C$2:$C$12</c:f>
               <c:numCache>
                 <c:formatCode>General</c:formatCode>
-                <c:ptCount val="10"/>
+                <c:ptCount val="11"/>
                 <c:pt idx="0">
                   <c:v>1000</c:v>
                 </c:pt>
@@ -817,6 +826,9 @@
                   <c:v>1000</c:v>
                 </c:pt>
                 <c:pt idx="9">
+                  <c:v>1000</c:v>
+                </c:pt>
+                <c:pt idx="10">
                   <c:v>1000</c:v>
                 </c:pt>
               </c:numCache>
@@ -1648,7 +1660,7 @@
           <a:p>
             <a:r>
               <a:rPr lang="en-US" dirty="0"/>
-              <a:t>Total RAB 887 ribu rupiah. Terbesar untuk fabrikasi dua PCB dan 12 sensor. Rincian lengkap tiap item ada di lampiran.</a:t>
+              <a:t>Total RAB Rp937.390, semua harga sudah divalidasi di marketplace online. Terbesar untuk fabrikasi dua PCB dan 12 sensor. Rincian lengkap tiap item ada di lampiran.</a:t>
             </a:r>
             <a:endParaRPr lang="en-US" dirty="0"/>
           </a:p>
@@ -1824,7 +1836,7 @@
           <a:p>
             <a:r>
               <a:rPr lang="en-US" dirty="0"/>
-              <a:t>RAB sudah sepuluh kali direvisi. Kenaikan terbesar dari harga QRE1113GR lokal yang ternyata tiga kali perkiraan, sedangkan penghematan datang dari penghapusan MCP23017 dan LED indikator, skid nilon, serta alat yang dipinjam dari lab; revisi terakhir 26/10: IC multiplexer dapat harga toko 20 ribu, turun 15 ribu dari perkiraan. Dengan batas anggaran Rp1.000.000, RAB 887 ribu masih menyisakan 113 ribu (11,3 persen) untuk kenaikan harga atau item yang belum masuk RAB seperti body 3D print.</a:t>
+              <a:t>RAB sudah sebelas kali direvisi. Kenaikan terbesar dari harga QRE1113GR lokal yang ternyata tiga kali perkiraan. Revisi terakhir 27/10 memakai harga yang sudah divalidasi di marketplace online: naik 50 ribu, terutama karena TB6612FNG ternyata 50 ribu (perkiraan 25 ribu) dan timah solder kini masuk RAB, sebagian tertutup ESP32 yang lebih murah dan bracket motor yang diganti dudukan 3D print. Penghematan sebelumnya datang dari penghapusan MCP23017 dan LED indikator, breadboard pinjam lab, dan IC multiplexer harga toko. Dengan batas anggaran Rp1.000.000, RAB Rp937.390 masih menyisakan Rp62.610 (6,3 persen) untuk kenaikan harga atau item yang belum masuk RAB seperti body 3D print.</a:t>
             </a:r>
             <a:endParaRPr lang="en-US" dirty="0"/>
           </a:p>
@@ -2000,7 +2012,7 @@
           <a:p>
             <a:r>
               <a:rPr lang="en-US" dirty="0"/>
-              <a:t>Penutup: kami mohon persetujuan dana 887 ribu rupiah. Rencana sesudah dana cair ada di sisi kanan. Terima kasih, kami siap menjawab pertanyaan.</a:t>
+              <a:t>Penutup: kami mohon persetujuan dana Rp937.390. Rencana sesudah dana cair ada di sisi kanan. Terima kasih, kami siap menjawab pertanyaan.</a:t>
             </a:r>
             <a:endParaRPr lang="en-US" dirty="0"/>
           </a:p>
@@ -2176,7 +2188,7 @@
           <a:p>
             <a:r>
               <a:rPr lang="en-US" dirty="0"/>
-              <a:t>Rincian RAB elektrikal bagian kedua; total elektrikal 832 ribu.</a:t>
+              <a:t>Rincian RAB elektrikal bagian kedua; total elektrikal Rp862.390.</a:t>
             </a:r>
             <a:endParaRPr lang="en-US" dirty="0"/>
           </a:p>
@@ -2264,7 +2276,7 @@
           <a:p>
             <a:r>
               <a:rPr lang="en-US" dirty="0"/>
-              <a:t>RAB mekanik dan rekap total 887 ribu. Lintasan uji, breadboard, dan timah di luar RAB.</a:t>
+              <a:t>RAB mekanik, lain-lain (timah solder + flux), dan rekap total Rp937.390. Lintasan uji dan breadboard di luar RAB.</a:t>
             </a:r>
             <a:endParaRPr lang="en-US" dirty="0"/>
           </a:p>
@@ -2528,7 +2540,7 @@
           <a:p>
             <a:r>
               <a:rPr lang="en-US" dirty="0"/>
-              <a:t>Solusi kami empat fitur utama: ikut garis dengan PID, path planning dengan peta by index seperti Ichiduino (rute ditulis sebagai urutan langkah: pola sensor lalu aksi), block coding berbasis web, dan fitur keamanan. Biayanya sekitar 44 persen harga kit pembanding.</a:t>
+              <a:t>Solusi kami empat fitur utama: ikut garis dengan PID, path planning dengan peta by index seperti Ichiduino (rute ditulis sebagai urutan langkah: pola sensor lalu aksi), block coding berbasis web, dan fitur keamanan. Biayanya sekitar 47 persen harga kit pembanding.</a:t>
             </a:r>
             <a:endParaRPr lang="en-US" dirty="0"/>
           </a:p>
@@ -5158,7 +5170,7 @@
                   <a:schemeClr val="accent2"/>
                 </a:solidFill>
               </a:rPr>
-              <a:t>Rp887.000</a:t>
+              <a:t>Rp937.390</a:t>
             </a:r>
             <a:endParaRPr lang="en-US" sz="4800" dirty="0"/>
           </a:p>
@@ -5172,7 +5184,7 @@
                   <a:schemeClr val="bg1"/>
                 </a:solidFill>
               </a:rPr>
-              <a:t>Elektrikal Rp832.000 + Mekanik Rp55.000</a:t>
+              <a:t>Elektrikal Rp862.390 + Mekanik Rp50.000 + Timah Rp25.000</a:t>
             </a:r>
             <a:endParaRPr lang="en-US" sz="4800" dirty="0"/>
           </a:p>
@@ -5230,7 +5242,7 @@
                   <a:schemeClr val="bg1"/>
                 </a:solidFill>
               </a:rPr>
-              <a:t>Di luar RAB: lintasan uji, breadboard dan timah (pinjam lab), software gratis (Blockly, Arduino, KiCad).</a:t>
+              <a:t>Di luar RAB: lintasan uji, breadboard (pinjam lab), software gratis (Blockly, Arduino, KiCad).</a:t>
             </a:r>
             <a:endParaRPr lang="en-US" sz="1400" dirty="0"/>
           </a:p>
@@ -5248,7 +5260,7 @@
                   <a:schemeClr val="bg1"/>
                 </a:solidFill>
               </a:rPr>
-              <a:t>Kit Ichiduino Pro hanya pembanding, tidak dianggarkan ulang.</a:t>
+              <a:t>Harga sudah divalidasi di marketplace online (27/10); kit Ichiduino Pro hanya pembanding.</a:t>
             </a:r>
             <a:endParaRPr lang="en-US" sz="1400" dirty="0"/>
           </a:p>
@@ -5256,7 +5268,7 @@
       </p:sp>
       <p:graphicFrame>
         <p:nvGraphicFramePr>
-          <p:cNvPr id="5" name="Grafik RAB per kelompok" descr="Grafik batang biaya per kelompok: PCB dan konektor 240 ribu, sensor garis 203 ribu, penggerak 170 ribu, daya dan baterai 136 ribu, otak dan antarmuka 118 ribu, mekanik lain 20 ribu"/>
+          <p:cNvPr id="5" name="Grafik RAB per kelompok" descr="Grafik batang biaya per kelompok: PCB dan konektor 240 ribu, sensor garis 203 ribu, penggerak 185 ribu, daya dan baterai 151 ribu, otak dan antarmuka 108 ribu, mekanik dan timah 50 ribu"/>
           <p:cNvGraphicFramePr/>
           <p:nvPr/>
         </p:nvGraphicFramePr>
@@ -5386,7 +5398,7 @@
                   <a:schemeClr val="bg1"/>
                 </a:solidFill>
               </a:rPr>
-              <a:t>ESP32 DevKit · Rp76.000</a:t>
+              <a:t>ESP32 DevKit · Rp65.900</a:t>
             </a:r>
             <a:endParaRPr lang="en-US" sz="1600" dirty="0"/>
           </a:p>
@@ -5605,7 +5617,7 @@
                   <a:schemeClr val="bg1"/>
                 </a:solidFill>
               </a:rPr>
-              <a:t>TB6612FNG · Rp25.000</a:t>
+              <a:t>TB6612FNG · Rp50.000</a:t>
             </a:r>
             <a:endParaRPr lang="en-US" sz="1600" dirty="0"/>
           </a:p>
@@ -5678,7 +5690,7 @@
                   <a:schemeClr val="bg1"/>
                 </a:solidFill>
               </a:rPr>
-              <a:t>2× 18650 + BMS + charger · Rp115.000</a:t>
+              <a:t>2× 18650 + BMS + charger · Rp129.990</a:t>
             </a:r>
             <a:endParaRPr lang="en-US" sz="1600" dirty="0"/>
           </a:p>
@@ -5836,7 +5848,7 @@
       </p:sp>
       <p:graphicFrame>
         <p:nvGraphicFramePr>
-          <p:cNvPr id="3" name="Grafik riwayat RAB" descr="Grafik garis total RAB per revisi antara 833 dan 902 ribu rupiah, terakhir 887 ribu, dengan garis batas 1 juta rupiah"/>
+          <p:cNvPr id="3" name="Grafik riwayat RAB" descr="Grafik garis total RAB per revisi antara 833 dan 937 ribu rupiah, terakhir 937,4 ribu, dengan garis batas 1 juta rupiah"/>
           <p:cNvGraphicFramePr/>
           <p:nvPr/>
         </p:nvGraphicFramePr>
@@ -5880,7 +5892,7 @@
                   <a:schemeClr val="accent2"/>
                 </a:solidFill>
               </a:rPr>
-              <a:t>Sisa Rp113.000</a:t>
+              <a:t>Sisa Rp62.610</a:t>
             </a:r>
             <a:endParaRPr lang="en-US" sz="3600" dirty="0"/>
           </a:p>
@@ -5894,7 +5906,7 @@
                   <a:schemeClr val="bg1"/>
                 </a:solidFill>
               </a:rPr>
-              <a:t>(11,3%) di bawah batas Rp1.000.000</a:t>
+              <a:t>(6,3%) di bawah batas Rp1.000.000</a:t>
             </a:r>
             <a:endParaRPr lang="en-US" sz="3600" dirty="0"/>
           </a:p>
@@ -5934,7 +5946,7 @@
                   <a:schemeClr val="bg1"/>
                 </a:solidFill>
               </a:rPr>
-              <a:t>Kenaikan terbesar: QRE1113GR lokal Rp15.000/pcs (+Rp105.000).</a:t>
+              <a:t>Kenaikan terbesar: QRE1113GR lokal (+Rp105.000), harga marketplace 27/10 (+Rp50.390).</a:t>
             </a:r>
             <a:endParaRPr lang="en-US" sz="1400" dirty="0"/>
           </a:p>
@@ -5952,7 +5964,7 @@
                   <a:schemeClr val="bg1"/>
                 </a:solidFill>
               </a:rPr>
-              <a:t>Dihemat: MCP23017 + LED dihapus, skid nilon, alat pinjam lab (−Rp85.000), mux harga toko (−Rp15.000).</a:t>
+              <a:t>Dihemat: MCP23017 + LED dihapus, breadboard pinjam lab, mux harga toko (−Rp15.000).</a:t>
             </a:r>
             <a:endParaRPr lang="en-US" sz="1400" dirty="0"/>
           </a:p>
@@ -7072,7 +7084,7 @@
                   <a:schemeClr val="accent2"/>
                 </a:solidFill>
               </a:rPr>
-              <a:t>Rp887.000</a:t>
+              <a:t>Rp937.390</a:t>
             </a:r>
             <a:endParaRPr lang="en-US" sz="1800" dirty="0"/>
           </a:p>
@@ -7685,7 +7697,7 @@
                             <a:schemeClr val="bg1"/>
                           </a:solidFill>
                         </a:rPr>
-                        <a:t>Rp76.000</a:t>
+                        <a:t>Rp65.900</a:t>
                       </a:r>
                       <a:endParaRPr lang="en-US" sz="1400" dirty="0"/>
                     </a:p>
@@ -7807,7 +7819,7 @@
                             <a:schemeClr val="bg1"/>
                           </a:solidFill>
                         </a:rPr>
-                        <a:t>Rp76.000</a:t>
+                        <a:t>Rp65.900</a:t>
                       </a:r>
                       <a:endParaRPr lang="en-US" sz="1400" dirty="0"/>
                     </a:p>
@@ -7931,7 +7943,7 @@
                             <a:schemeClr val="bg1"/>
                           </a:solidFill>
                         </a:rPr>
-                        <a:t>Rp33.000</a:t>
+                        <a:t>Rp36.500</a:t>
                       </a:r>
                       <a:endParaRPr lang="en-US" sz="1400" dirty="0"/>
                     </a:p>
@@ -8053,7 +8065,7 @@
                             <a:schemeClr val="bg1"/>
                           </a:solidFill>
                         </a:rPr>
-                        <a:t>Rp33.000</a:t>
+                        <a:t>Rp36.500</a:t>
                       </a:r>
                       <a:endParaRPr lang="en-US" sz="1400" dirty="0"/>
                     </a:p>
@@ -8116,7 +8128,7 @@
                             <a:schemeClr val="bg1"/>
                           </a:solidFill>
                         </a:rPr>
-                        <a:t>Sensor reflektif QRE1113GR SMD (toko lokal)</a:t>
+                        <a:t>Sensor reflektif QRE1113GR SMD</a:t>
                       </a:r>
                       <a:endParaRPr lang="en-US" sz="1400" dirty="0"/>
                     </a:p>
@@ -8669,7 +8681,7 @@
                             <a:schemeClr val="bg1"/>
                           </a:solidFill>
                         </a:rPr>
-                        <a:t>Rp25.000</a:t>
+                        <a:t>Rp50.000</a:t>
                       </a:r>
                       <a:endParaRPr lang="en-US" sz="1400" dirty="0"/>
                     </a:p>
@@ -8791,7 +8803,7 @@
                             <a:schemeClr val="bg1"/>
                           </a:solidFill>
                         </a:rPr>
-                        <a:t>Rp25.000</a:t>
+                        <a:t>Rp50.000</a:t>
                       </a:r>
                       <a:endParaRPr lang="en-US" sz="1400" dirty="0"/>
                     </a:p>
@@ -9100,7 +9112,7 @@
                             <a:schemeClr val="bg1"/>
                           </a:solidFill>
                         </a:rPr>
-                        <a:t>Push button</a:t>
+                        <a:t>Push button tactile 12×12 mm</a:t>
                       </a:r>
                       <a:endParaRPr lang="en-US" sz="1400" dirty="0"/>
                     </a:p>
@@ -9222,7 +9234,7 @@
                             <a:schemeClr val="bg1"/>
                           </a:solidFill>
                         </a:rPr>
-                        <a:t>4</a:t>
+                        <a:t>3</a:t>
                       </a:r>
                       <a:endParaRPr lang="en-US" sz="1400" dirty="0"/>
                     </a:p>
@@ -9283,7 +9295,7 @@
                             <a:schemeClr val="bg1"/>
                           </a:solidFill>
                         </a:rPr>
-                        <a:t>Rp4.000</a:t>
+                        <a:t>Rp3.000</a:t>
                       </a:r>
                       <a:endParaRPr lang="en-US" sz="1400" dirty="0"/>
                     </a:p>
@@ -9592,7 +9604,7 @@
                             <a:schemeClr val="bg1"/>
                           </a:solidFill>
                         </a:rPr>
-                        <a:t>Resistor 10 kΩ</a:t>
+                        <a:t>Buzzer aktif 12 × 9,5 mm</a:t>
                       </a:r>
                       <a:endParaRPr lang="en-US" sz="1400" dirty="0"/>
                     </a:p>
@@ -9636,252 +9648,6 @@
                     </a:lnB>
                     <a:solidFill>
                       <a:schemeClr val="tx1"/>
-                    </a:solidFill>
-                  </a:tcPr>
-                </a:tc>
-                <a:tc>
-                  <a:txBody>
-                    <a:bodyPr/>
-                    <a:lstStyle/>
-                    <a:p>
-                      <a:pPr algn="r" indent="0" marL="0">
-                        <a:buNone/>
-                      </a:pPr>
-                      <a:r>
-                        <a:rPr lang="en-US" sz="1400" dirty="0">
-                          <a:solidFill>
-                            <a:schemeClr val="bg1"/>
-                          </a:solidFill>
-                        </a:rPr>
-                        <a:t>Rp200</a:t>
-                      </a:r>
-                      <a:endParaRPr lang="en-US" sz="1400" dirty="0"/>
-                    </a:p>
-                  </a:txBody>
-                  <a:tcPr marL="91440" marR="91440" marT="27432" marB="27432" anchor="ctr">
-                    <a:lnL w="9525" cap="flat" cmpd="sng" algn="ctr">
-                      <a:solidFill>
-                        <a:schemeClr val="accent3"/>
-                      </a:solidFill>
-                      <a:prstDash val="solid"/>
-                      <a:round/>
-                      <a:headEnd type="none" w="med" len="med"/>
-                      <a:tailEnd type="none" w="med" len="med"/>
-                    </a:lnL>
-                    <a:lnR w="9525" cap="flat" cmpd="sng" algn="ctr">
-                      <a:solidFill>
-                        <a:schemeClr val="accent3"/>
-                      </a:solidFill>
-                      <a:prstDash val="solid"/>
-                      <a:round/>
-                      <a:headEnd type="none" w="med" len="med"/>
-                      <a:tailEnd type="none" w="med" len="med"/>
-                    </a:lnR>
-                    <a:lnT w="9525" cap="flat" cmpd="sng" algn="ctr">
-                      <a:solidFill>
-                        <a:schemeClr val="accent3"/>
-                      </a:solidFill>
-                      <a:prstDash val="solid"/>
-                      <a:round/>
-                      <a:headEnd type="none" w="med" len="med"/>
-                      <a:tailEnd type="none" w="med" len="med"/>
-                    </a:lnT>
-                    <a:lnB w="9525" cap="flat" cmpd="sng" algn="ctr">
-                      <a:solidFill>
-                        <a:schemeClr val="accent3"/>
-                      </a:solidFill>
-                      <a:prstDash val="solid"/>
-                      <a:round/>
-                      <a:headEnd type="none" w="med" len="med"/>
-                      <a:tailEnd type="none" w="med" len="med"/>
-                    </a:lnB>
-                    <a:solidFill>
-                      <a:schemeClr val="tx1"/>
-                    </a:solidFill>
-                  </a:tcPr>
-                </a:tc>
-                <a:tc>
-                  <a:txBody>
-                    <a:bodyPr/>
-                    <a:lstStyle/>
-                    <a:p>
-                      <a:pPr algn="r" indent="0" marL="0">
-                        <a:buNone/>
-                      </a:pPr>
-                      <a:r>
-                        <a:rPr lang="en-US" sz="1400" dirty="0">
-                          <a:solidFill>
-                            <a:schemeClr val="bg1"/>
-                          </a:solidFill>
-                        </a:rPr>
-                        <a:t>10</a:t>
-                      </a:r>
-                      <a:endParaRPr lang="en-US" sz="1400" dirty="0"/>
-                    </a:p>
-                  </a:txBody>
-                  <a:tcPr marL="91440" marR="91440" marT="27432" marB="27432" anchor="ctr">
-                    <a:lnL w="9525" cap="flat" cmpd="sng" algn="ctr">
-                      <a:solidFill>
-                        <a:schemeClr val="accent3"/>
-                      </a:solidFill>
-                      <a:prstDash val="solid"/>
-                      <a:round/>
-                      <a:headEnd type="none" w="med" len="med"/>
-                      <a:tailEnd type="none" w="med" len="med"/>
-                    </a:lnL>
-                    <a:lnR w="9525" cap="flat" cmpd="sng" algn="ctr">
-                      <a:solidFill>
-                        <a:schemeClr val="accent3"/>
-                      </a:solidFill>
-                      <a:prstDash val="solid"/>
-                      <a:round/>
-                      <a:headEnd type="none" w="med" len="med"/>
-                      <a:tailEnd type="none" w="med" len="med"/>
-                    </a:lnR>
-                    <a:lnT w="9525" cap="flat" cmpd="sng" algn="ctr">
-                      <a:solidFill>
-                        <a:schemeClr val="accent3"/>
-                      </a:solidFill>
-                      <a:prstDash val="solid"/>
-                      <a:round/>
-                      <a:headEnd type="none" w="med" len="med"/>
-                      <a:tailEnd type="none" w="med" len="med"/>
-                    </a:lnT>
-                    <a:lnB w="9525" cap="flat" cmpd="sng" algn="ctr">
-                      <a:solidFill>
-                        <a:schemeClr val="accent3"/>
-                      </a:solidFill>
-                      <a:prstDash val="solid"/>
-                      <a:round/>
-                      <a:headEnd type="none" w="med" len="med"/>
-                      <a:tailEnd type="none" w="med" len="med"/>
-                    </a:lnB>
-                    <a:solidFill>
-                      <a:schemeClr val="tx1"/>
-                    </a:solidFill>
-                  </a:tcPr>
-                </a:tc>
-                <a:tc>
-                  <a:txBody>
-                    <a:bodyPr/>
-                    <a:lstStyle/>
-                    <a:p>
-                      <a:pPr algn="r" indent="0" marL="0">
-                        <a:buNone/>
-                      </a:pPr>
-                      <a:r>
-                        <a:rPr lang="en-US" sz="1400" dirty="0">
-                          <a:solidFill>
-                            <a:schemeClr val="bg1"/>
-                          </a:solidFill>
-                        </a:rPr>
-                        <a:t>Rp2.000</a:t>
-                      </a:r>
-                      <a:endParaRPr lang="en-US" sz="1400" dirty="0"/>
-                    </a:p>
-                  </a:txBody>
-                  <a:tcPr marL="91440" marR="91440" marT="27432" marB="27432" anchor="ctr">
-                    <a:lnL w="9525" cap="flat" cmpd="sng" algn="ctr">
-                      <a:solidFill>
-                        <a:schemeClr val="accent3"/>
-                      </a:solidFill>
-                      <a:prstDash val="solid"/>
-                      <a:round/>
-                      <a:headEnd type="none" w="med" len="med"/>
-                      <a:tailEnd type="none" w="med" len="med"/>
-                    </a:lnL>
-                    <a:lnR w="9525" cap="flat" cmpd="sng" algn="ctr">
-                      <a:solidFill>
-                        <a:schemeClr val="accent3"/>
-                      </a:solidFill>
-                      <a:prstDash val="solid"/>
-                      <a:round/>
-                      <a:headEnd type="none" w="med" len="med"/>
-                      <a:tailEnd type="none" w="med" len="med"/>
-                    </a:lnR>
-                    <a:lnT w="9525" cap="flat" cmpd="sng" algn="ctr">
-                      <a:solidFill>
-                        <a:schemeClr val="accent3"/>
-                      </a:solidFill>
-                      <a:prstDash val="solid"/>
-                      <a:round/>
-                      <a:headEnd type="none" w="med" len="med"/>
-                      <a:tailEnd type="none" w="med" len="med"/>
-                    </a:lnT>
-                    <a:lnB w="9525" cap="flat" cmpd="sng" algn="ctr">
-                      <a:solidFill>
-                        <a:schemeClr val="accent3"/>
-                      </a:solidFill>
-                      <a:prstDash val="solid"/>
-                      <a:round/>
-                      <a:headEnd type="none" w="med" len="med"/>
-                      <a:tailEnd type="none" w="med" len="med"/>
-                    </a:lnB>
-                    <a:solidFill>
-                      <a:schemeClr val="tx1"/>
-                    </a:solidFill>
-                  </a:tcPr>
-                </a:tc>
-              </a:tr>
-              <a:tr h="310896">
-                <a:tc>
-                  <a:txBody>
-                    <a:bodyPr/>
-                    <a:lstStyle/>
-                    <a:p>
-                      <a:pPr algn="l" indent="0" marL="0">
-                        <a:buNone/>
-                      </a:pPr>
-                      <a:r>
-                        <a:rPr lang="en-US" sz="1400" dirty="0">
-                          <a:solidFill>
-                            <a:schemeClr val="bg1"/>
-                          </a:solidFill>
-                        </a:rPr>
-                        <a:t>Buzzer</a:t>
-                      </a:r>
-                      <a:endParaRPr lang="en-US" sz="1400" dirty="0"/>
-                    </a:p>
-                  </a:txBody>
-                  <a:tcPr marL="91440" marR="91440" marT="27432" marB="27432" anchor="ctr">
-                    <a:lnL w="9525" cap="flat" cmpd="sng" algn="ctr">
-                      <a:solidFill>
-                        <a:schemeClr val="accent3"/>
-                      </a:solidFill>
-                      <a:prstDash val="solid"/>
-                      <a:round/>
-                      <a:headEnd type="none" w="med" len="med"/>
-                      <a:tailEnd type="none" w="med" len="med"/>
-                    </a:lnL>
-                    <a:lnR w="9525" cap="flat" cmpd="sng" algn="ctr">
-                      <a:solidFill>
-                        <a:schemeClr val="accent3"/>
-                      </a:solidFill>
-                      <a:prstDash val="solid"/>
-                      <a:round/>
-                      <a:headEnd type="none" w="med" len="med"/>
-                      <a:tailEnd type="none" w="med" len="med"/>
-                    </a:lnR>
-                    <a:lnT w="9525" cap="flat" cmpd="sng" algn="ctr">
-                      <a:solidFill>
-                        <a:schemeClr val="accent3"/>
-                      </a:solidFill>
-                      <a:prstDash val="solid"/>
-                      <a:round/>
-                      <a:headEnd type="none" w="med" len="med"/>
-                      <a:tailEnd type="none" w="med" len="med"/>
-                    </a:lnT>
-                    <a:lnB w="9525" cap="flat" cmpd="sng" algn="ctr">
-                      <a:solidFill>
-                        <a:schemeClr val="accent3"/>
-                      </a:solidFill>
-                      <a:prstDash val="solid"/>
-                      <a:round/>
-                      <a:headEnd type="none" w="med" len="med"/>
-                      <a:tailEnd type="none" w="med" len="med"/>
-                    </a:lnB>
-                    <a:solidFill>
-                      <a:schemeClr val="accent5"/>
                     </a:solidFill>
                   </a:tcPr>
                 </a:tc>
@@ -9942,7 +9708,7 @@
                       <a:tailEnd type="none" w="med" len="med"/>
                     </a:lnB>
                     <a:solidFill>
-                      <a:schemeClr val="accent5"/>
+                      <a:schemeClr val="tx1"/>
                     </a:solidFill>
                   </a:tcPr>
                 </a:tc>
@@ -10003,6 +9769,130 @@
                       <a:tailEnd type="none" w="med" len="med"/>
                     </a:lnB>
                     <a:solidFill>
+                      <a:schemeClr val="tx1"/>
+                    </a:solidFill>
+                  </a:tcPr>
+                </a:tc>
+                <a:tc>
+                  <a:txBody>
+                    <a:bodyPr/>
+                    <a:lstStyle/>
+                    <a:p>
+                      <a:pPr algn="r" indent="0" marL="0">
+                        <a:buNone/>
+                      </a:pPr>
+                      <a:r>
+                        <a:rPr lang="en-US" sz="1400" dirty="0">
+                          <a:solidFill>
+                            <a:schemeClr val="bg1"/>
+                          </a:solidFill>
+                        </a:rPr>
+                        <a:t>Rp3.000</a:t>
+                      </a:r>
+                      <a:endParaRPr lang="en-US" sz="1400" dirty="0"/>
+                    </a:p>
+                  </a:txBody>
+                  <a:tcPr marL="91440" marR="91440" marT="27432" marB="27432" anchor="ctr">
+                    <a:lnL w="9525" cap="flat" cmpd="sng" algn="ctr">
+                      <a:solidFill>
+                        <a:schemeClr val="accent3"/>
+                      </a:solidFill>
+                      <a:prstDash val="solid"/>
+                      <a:round/>
+                      <a:headEnd type="none" w="med" len="med"/>
+                      <a:tailEnd type="none" w="med" len="med"/>
+                    </a:lnL>
+                    <a:lnR w="9525" cap="flat" cmpd="sng" algn="ctr">
+                      <a:solidFill>
+                        <a:schemeClr val="accent3"/>
+                      </a:solidFill>
+                      <a:prstDash val="solid"/>
+                      <a:round/>
+                      <a:headEnd type="none" w="med" len="med"/>
+                      <a:tailEnd type="none" w="med" len="med"/>
+                    </a:lnR>
+                    <a:lnT w="9525" cap="flat" cmpd="sng" algn="ctr">
+                      <a:solidFill>
+                        <a:schemeClr val="accent3"/>
+                      </a:solidFill>
+                      <a:prstDash val="solid"/>
+                      <a:round/>
+                      <a:headEnd type="none" w="med" len="med"/>
+                      <a:tailEnd type="none" w="med" len="med"/>
+                    </a:lnT>
+                    <a:lnB w="9525" cap="flat" cmpd="sng" algn="ctr">
+                      <a:solidFill>
+                        <a:schemeClr val="accent3"/>
+                      </a:solidFill>
+                      <a:prstDash val="solid"/>
+                      <a:round/>
+                      <a:headEnd type="none" w="med" len="med"/>
+                      <a:tailEnd type="none" w="med" len="med"/>
+                    </a:lnB>
+                    <a:solidFill>
+                      <a:schemeClr val="tx1"/>
+                    </a:solidFill>
+                  </a:tcPr>
+                </a:tc>
+              </a:tr>
+              <a:tr h="310896">
+                <a:tc>
+                  <a:txBody>
+                    <a:bodyPr/>
+                    <a:lstStyle/>
+                    <a:p>
+                      <a:pPr algn="l" indent="0" marL="0">
+                        <a:buNone/>
+                      </a:pPr>
+                      <a:r>
+                        <a:rPr lang="en-US" sz="1400" dirty="0">
+                          <a:solidFill>
+                            <a:schemeClr val="bg1"/>
+                          </a:solidFill>
+                        </a:rPr>
+                        <a:t>Baterai Li-ion 18650 3000 mAh (isi 2)</a:t>
+                      </a:r>
+                      <a:endParaRPr lang="en-US" sz="1400" dirty="0"/>
+                    </a:p>
+                  </a:txBody>
+                  <a:tcPr marL="91440" marR="91440" marT="27432" marB="27432" anchor="ctr">
+                    <a:lnL w="9525" cap="flat" cmpd="sng" algn="ctr">
+                      <a:solidFill>
+                        <a:schemeClr val="accent3"/>
+                      </a:solidFill>
+                      <a:prstDash val="solid"/>
+                      <a:round/>
+                      <a:headEnd type="none" w="med" len="med"/>
+                      <a:tailEnd type="none" w="med" len="med"/>
+                    </a:lnL>
+                    <a:lnR w="9525" cap="flat" cmpd="sng" algn="ctr">
+                      <a:solidFill>
+                        <a:schemeClr val="accent3"/>
+                      </a:solidFill>
+                      <a:prstDash val="solid"/>
+                      <a:round/>
+                      <a:headEnd type="none" w="med" len="med"/>
+                      <a:tailEnd type="none" w="med" len="med"/>
+                    </a:lnR>
+                    <a:lnT w="9525" cap="flat" cmpd="sng" algn="ctr">
+                      <a:solidFill>
+                        <a:schemeClr val="accent3"/>
+                      </a:solidFill>
+                      <a:prstDash val="solid"/>
+                      <a:round/>
+                      <a:headEnd type="none" w="med" len="med"/>
+                      <a:tailEnd type="none" w="med" len="med"/>
+                    </a:lnT>
+                    <a:lnB w="9525" cap="flat" cmpd="sng" algn="ctr">
+                      <a:solidFill>
+                        <a:schemeClr val="accent3"/>
+                      </a:solidFill>
+                      <a:prstDash val="solid"/>
+                      <a:round/>
+                      <a:headEnd type="none" w="med" len="med"/>
+                      <a:tailEnd type="none" w="med" len="med"/>
+                    </a:lnB>
+                    <a:solidFill>
                       <a:schemeClr val="accent5"/>
                     </a:solidFill>
                   </a:tcPr>
@@ -10021,7 +9911,129 @@
                             <a:schemeClr val="bg1"/>
                           </a:solidFill>
                         </a:rPr>
-                        <a:t>Rp3.000</a:t>
+                        <a:t>Rp94.990</a:t>
+                      </a:r>
+                      <a:endParaRPr lang="en-US" sz="1400" dirty="0"/>
+                    </a:p>
+                  </a:txBody>
+                  <a:tcPr marL="91440" marR="91440" marT="27432" marB="27432" anchor="ctr">
+                    <a:lnL w="9525" cap="flat" cmpd="sng" algn="ctr">
+                      <a:solidFill>
+                        <a:schemeClr val="accent3"/>
+                      </a:solidFill>
+                      <a:prstDash val="solid"/>
+                      <a:round/>
+                      <a:headEnd type="none" w="med" len="med"/>
+                      <a:tailEnd type="none" w="med" len="med"/>
+                    </a:lnL>
+                    <a:lnR w="9525" cap="flat" cmpd="sng" algn="ctr">
+                      <a:solidFill>
+                        <a:schemeClr val="accent3"/>
+                      </a:solidFill>
+                      <a:prstDash val="solid"/>
+                      <a:round/>
+                      <a:headEnd type="none" w="med" len="med"/>
+                      <a:tailEnd type="none" w="med" len="med"/>
+                    </a:lnR>
+                    <a:lnT w="9525" cap="flat" cmpd="sng" algn="ctr">
+                      <a:solidFill>
+                        <a:schemeClr val="accent3"/>
+                      </a:solidFill>
+                      <a:prstDash val="solid"/>
+                      <a:round/>
+                      <a:headEnd type="none" w="med" len="med"/>
+                      <a:tailEnd type="none" w="med" len="med"/>
+                    </a:lnT>
+                    <a:lnB w="9525" cap="flat" cmpd="sng" algn="ctr">
+                      <a:solidFill>
+                        <a:schemeClr val="accent3"/>
+                      </a:solidFill>
+                      <a:prstDash val="solid"/>
+                      <a:round/>
+                      <a:headEnd type="none" w="med" len="med"/>
+                      <a:tailEnd type="none" w="med" len="med"/>
+                    </a:lnB>
+                    <a:solidFill>
+                      <a:schemeClr val="accent5"/>
+                    </a:solidFill>
+                  </a:tcPr>
+                </a:tc>
+                <a:tc>
+                  <a:txBody>
+                    <a:bodyPr/>
+                    <a:lstStyle/>
+                    <a:p>
+                      <a:pPr algn="r" indent="0" marL="0">
+                        <a:buNone/>
+                      </a:pPr>
+                      <a:r>
+                        <a:rPr lang="en-US" sz="1400" dirty="0">
+                          <a:solidFill>
+                            <a:schemeClr val="bg1"/>
+                          </a:solidFill>
+                        </a:rPr>
+                        <a:t>1 paket</a:t>
+                      </a:r>
+                      <a:endParaRPr lang="en-US" sz="1400" dirty="0"/>
+                    </a:p>
+                  </a:txBody>
+                  <a:tcPr marL="91440" marR="91440" marT="27432" marB="27432" anchor="ctr">
+                    <a:lnL w="9525" cap="flat" cmpd="sng" algn="ctr">
+                      <a:solidFill>
+                        <a:schemeClr val="accent3"/>
+                      </a:solidFill>
+                      <a:prstDash val="solid"/>
+                      <a:round/>
+                      <a:headEnd type="none" w="med" len="med"/>
+                      <a:tailEnd type="none" w="med" len="med"/>
+                    </a:lnL>
+                    <a:lnR w="9525" cap="flat" cmpd="sng" algn="ctr">
+                      <a:solidFill>
+                        <a:schemeClr val="accent3"/>
+                      </a:solidFill>
+                      <a:prstDash val="solid"/>
+                      <a:round/>
+                      <a:headEnd type="none" w="med" len="med"/>
+                      <a:tailEnd type="none" w="med" len="med"/>
+                    </a:lnR>
+                    <a:lnT w="9525" cap="flat" cmpd="sng" algn="ctr">
+                      <a:solidFill>
+                        <a:schemeClr val="accent3"/>
+                      </a:solidFill>
+                      <a:prstDash val="solid"/>
+                      <a:round/>
+                      <a:headEnd type="none" w="med" len="med"/>
+                      <a:tailEnd type="none" w="med" len="med"/>
+                    </a:lnT>
+                    <a:lnB w="9525" cap="flat" cmpd="sng" algn="ctr">
+                      <a:solidFill>
+                        <a:schemeClr val="accent3"/>
+                      </a:solidFill>
+                      <a:prstDash val="solid"/>
+                      <a:round/>
+                      <a:headEnd type="none" w="med" len="med"/>
+                      <a:tailEnd type="none" w="med" len="med"/>
+                    </a:lnB>
+                    <a:solidFill>
+                      <a:schemeClr val="accent5"/>
+                    </a:solidFill>
+                  </a:tcPr>
+                </a:tc>
+                <a:tc>
+                  <a:txBody>
+                    <a:bodyPr/>
+                    <a:lstStyle/>
+                    <a:p>
+                      <a:pPr algn="r" indent="0" marL="0">
+                        <a:buNone/>
+                      </a:pPr>
+                      <a:r>
+                        <a:rPr lang="en-US" sz="1400" dirty="0">
+                          <a:solidFill>
+                            <a:schemeClr val="bg1"/>
+                          </a:solidFill>
+                        </a:rPr>
+                        <a:t>Rp94.990</a:t>
                       </a:r>
                       <a:endParaRPr lang="en-US" sz="1400" dirty="0"/>
                     </a:p>
@@ -10251,7 +10263,7 @@
                             <a:schemeClr val="bg1"/>
                           </a:solidFill>
                         </a:rPr>
-                        <a:t>Rp456.000</a:t>
+                        <a:t>Rp566.390</a:t>
                       </a:r>
                       <a:endParaRPr lang="en-US" sz="1400" dirty="0"/>
                     </a:p>
@@ -10655,7 +10667,7 @@
                             <a:schemeClr val="bg1"/>
                           </a:solidFill>
                         </a:rPr>
-                        <a:t>Baterai Li-ion 18650</a:t>
+                        <a:t>Holder baterai 2× 18650 (seri)</a:t>
                       </a:r>
                       <a:endParaRPr lang="en-US" sz="1400" dirty="0"/>
                     </a:p>
@@ -10716,7 +10728,7 @@
                             <a:schemeClr val="bg1"/>
                           </a:solidFill>
                         </a:rPr>
-                        <a:t>Rp40.000</a:t>
+                        <a:t>Rp8.000</a:t>
                       </a:r>
                       <a:endParaRPr lang="en-US" sz="1400" dirty="0"/>
                     </a:p>
@@ -10777,7 +10789,7 @@
                             <a:schemeClr val="bg1"/>
                           </a:solidFill>
                         </a:rPr>
-                        <a:t>2</a:t>
+                        <a:t>1</a:t>
                       </a:r>
                       <a:endParaRPr lang="en-US" sz="1400" dirty="0"/>
                     </a:p>
@@ -10838,7 +10850,7 @@
                             <a:schemeClr val="bg1"/>
                           </a:solidFill>
                         </a:rPr>
-                        <a:t>Rp80.000</a:t>
+                        <a:t>Rp8.000</a:t>
                       </a:r>
                       <a:endParaRPr lang="en-US" sz="1400" dirty="0"/>
                     </a:p>
@@ -10901,7 +10913,7 @@
                             <a:schemeClr val="bg1"/>
                           </a:solidFill>
                         </a:rPr>
-                        <a:t>Holder baterai 2× 18650 (seri)</a:t>
+                        <a:t>Modul BMS 2S</a:t>
                       </a:r>
                       <a:endParaRPr lang="en-US" sz="1400" dirty="0"/>
                     </a:p>
@@ -10962,7 +10974,7 @@
                             <a:schemeClr val="bg1"/>
                           </a:solidFill>
                         </a:rPr>
-                        <a:t>Rp8.000</a:t>
+                        <a:t>Rp10.000</a:t>
                       </a:r>
                       <a:endParaRPr lang="en-US" sz="1400" dirty="0"/>
                     </a:p>
@@ -11084,7 +11096,7 @@
                             <a:schemeClr val="bg1"/>
                           </a:solidFill>
                         </a:rPr>
-                        <a:t>Rp8.000</a:t>
+                        <a:t>Rp10.000</a:t>
                       </a:r>
                       <a:endParaRPr lang="en-US" sz="1400" dirty="0"/>
                     </a:p>
@@ -11147,7 +11159,7 @@
                             <a:schemeClr val="bg1"/>
                           </a:solidFill>
                         </a:rPr>
-                        <a:t>Modul BMS 2S</a:t>
+                        <a:t>Modul charger 2S USB-C</a:t>
                       </a:r>
                       <a:endParaRPr lang="en-US" sz="1400" dirty="0"/>
                     </a:p>
@@ -11208,7 +11220,7 @@
                             <a:schemeClr val="bg1"/>
                           </a:solidFill>
                         </a:rPr>
-                        <a:t>Rp10.000</a:t>
+                        <a:t>Rp25.000</a:t>
                       </a:r>
                       <a:endParaRPr lang="en-US" sz="1400" dirty="0"/>
                     </a:p>
@@ -11330,7 +11342,7 @@
                             <a:schemeClr val="bg1"/>
                           </a:solidFill>
                         </a:rPr>
-                        <a:t>Rp10.000</a:t>
+                        <a:t>Rp25.000</a:t>
                       </a:r>
                       <a:endParaRPr lang="en-US" sz="1400" dirty="0"/>
                     </a:p>
@@ -11393,7 +11405,7 @@
                             <a:schemeClr val="bg1"/>
                           </a:solidFill>
                         </a:rPr>
-                        <a:t>Modul charger 2S USB-C</a:t>
+                        <a:t>Buck converter 5 V (MP1584)</a:t>
                       </a:r>
                       <a:endParaRPr lang="en-US" sz="1400" dirty="0"/>
                     </a:p>
@@ -11454,7 +11466,7 @@
                             <a:schemeClr val="bg1"/>
                           </a:solidFill>
                         </a:rPr>
-                        <a:t>Rp25.000</a:t>
+                        <a:t>Rp10.000</a:t>
                       </a:r>
                       <a:endParaRPr lang="en-US" sz="1400" dirty="0"/>
                     </a:p>
@@ -11576,7 +11588,7 @@
                             <a:schemeClr val="bg1"/>
                           </a:solidFill>
                         </a:rPr>
-                        <a:t>Rp25.000</a:t>
+                        <a:t>Rp10.000</a:t>
                       </a:r>
                       <a:endParaRPr lang="en-US" sz="1400" dirty="0"/>
                     </a:p>
@@ -11639,7 +11651,7 @@
                             <a:schemeClr val="bg1"/>
                           </a:solidFill>
                         </a:rPr>
-                        <a:t>Buck converter 5 V (MP1584)</a:t>
+                        <a:t>Saklar on/off</a:t>
                       </a:r>
                       <a:endParaRPr lang="en-US" sz="1400" dirty="0"/>
                     </a:p>
@@ -11700,7 +11712,7 @@
                             <a:schemeClr val="bg1"/>
                           </a:solidFill>
                         </a:rPr>
-                        <a:t>Rp10.000</a:t>
+                        <a:t>Rp3.000</a:t>
                       </a:r>
                       <a:endParaRPr lang="en-US" sz="1400" dirty="0"/>
                     </a:p>
@@ -11822,7 +11834,7 @@
                             <a:schemeClr val="bg1"/>
                           </a:solidFill>
                         </a:rPr>
-                        <a:t>Rp10.000</a:t>
+                        <a:t>Rp3.000</a:t>
                       </a:r>
                       <a:endParaRPr lang="en-US" sz="1400" dirty="0"/>
                     </a:p>
@@ -11885,7 +11897,7 @@
                             <a:schemeClr val="bg1"/>
                           </a:solidFill>
                         </a:rPr>
-                        <a:t>Saklar on/off</a:t>
+                        <a:t>Konektor JST XH 6 pin + header (encoder motor)</a:t>
                       </a:r>
                       <a:endParaRPr lang="en-US" sz="1400" dirty="0"/>
                     </a:p>
@@ -11929,252 +11941,6 @@
                     </a:lnB>
                     <a:solidFill>
                       <a:schemeClr val="accent5"/>
-                    </a:solidFill>
-                  </a:tcPr>
-                </a:tc>
-                <a:tc>
-                  <a:txBody>
-                    <a:bodyPr/>
-                    <a:lstStyle/>
-                    <a:p>
-                      <a:pPr algn="r" indent="0" marL="0">
-                        <a:buNone/>
-                      </a:pPr>
-                      <a:r>
-                        <a:rPr lang="en-US" sz="1400" dirty="0">
-                          <a:solidFill>
-                            <a:schemeClr val="bg1"/>
-                          </a:solidFill>
-                        </a:rPr>
-                        <a:t>Rp3.000</a:t>
-                      </a:r>
-                      <a:endParaRPr lang="en-US" sz="1400" dirty="0"/>
-                    </a:p>
-                  </a:txBody>
-                  <a:tcPr marL="91440" marR="91440" marT="27432" marB="27432" anchor="ctr">
-                    <a:lnL w="9525" cap="flat" cmpd="sng" algn="ctr">
-                      <a:solidFill>
-                        <a:schemeClr val="accent3"/>
-                      </a:solidFill>
-                      <a:prstDash val="solid"/>
-                      <a:round/>
-                      <a:headEnd type="none" w="med" len="med"/>
-                      <a:tailEnd type="none" w="med" len="med"/>
-                    </a:lnL>
-                    <a:lnR w="9525" cap="flat" cmpd="sng" algn="ctr">
-                      <a:solidFill>
-                        <a:schemeClr val="accent3"/>
-                      </a:solidFill>
-                      <a:prstDash val="solid"/>
-                      <a:round/>
-                      <a:headEnd type="none" w="med" len="med"/>
-                      <a:tailEnd type="none" w="med" len="med"/>
-                    </a:lnR>
-                    <a:lnT w="9525" cap="flat" cmpd="sng" algn="ctr">
-                      <a:solidFill>
-                        <a:schemeClr val="accent3"/>
-                      </a:solidFill>
-                      <a:prstDash val="solid"/>
-                      <a:round/>
-                      <a:headEnd type="none" w="med" len="med"/>
-                      <a:tailEnd type="none" w="med" len="med"/>
-                    </a:lnT>
-                    <a:lnB w="9525" cap="flat" cmpd="sng" algn="ctr">
-                      <a:solidFill>
-                        <a:schemeClr val="accent3"/>
-                      </a:solidFill>
-                      <a:prstDash val="solid"/>
-                      <a:round/>
-                      <a:headEnd type="none" w="med" len="med"/>
-                      <a:tailEnd type="none" w="med" len="med"/>
-                    </a:lnB>
-                    <a:solidFill>
-                      <a:schemeClr val="accent5"/>
-                    </a:solidFill>
-                  </a:tcPr>
-                </a:tc>
-                <a:tc>
-                  <a:txBody>
-                    <a:bodyPr/>
-                    <a:lstStyle/>
-                    <a:p>
-                      <a:pPr algn="r" indent="0" marL="0">
-                        <a:buNone/>
-                      </a:pPr>
-                      <a:r>
-                        <a:rPr lang="en-US" sz="1400" dirty="0">
-                          <a:solidFill>
-                            <a:schemeClr val="bg1"/>
-                          </a:solidFill>
-                        </a:rPr>
-                        <a:t>1</a:t>
-                      </a:r>
-                      <a:endParaRPr lang="en-US" sz="1400" dirty="0"/>
-                    </a:p>
-                  </a:txBody>
-                  <a:tcPr marL="91440" marR="91440" marT="27432" marB="27432" anchor="ctr">
-                    <a:lnL w="9525" cap="flat" cmpd="sng" algn="ctr">
-                      <a:solidFill>
-                        <a:schemeClr val="accent3"/>
-                      </a:solidFill>
-                      <a:prstDash val="solid"/>
-                      <a:round/>
-                      <a:headEnd type="none" w="med" len="med"/>
-                      <a:tailEnd type="none" w="med" len="med"/>
-                    </a:lnL>
-                    <a:lnR w="9525" cap="flat" cmpd="sng" algn="ctr">
-                      <a:solidFill>
-                        <a:schemeClr val="accent3"/>
-                      </a:solidFill>
-                      <a:prstDash val="solid"/>
-                      <a:round/>
-                      <a:headEnd type="none" w="med" len="med"/>
-                      <a:tailEnd type="none" w="med" len="med"/>
-                    </a:lnR>
-                    <a:lnT w="9525" cap="flat" cmpd="sng" algn="ctr">
-                      <a:solidFill>
-                        <a:schemeClr val="accent3"/>
-                      </a:solidFill>
-                      <a:prstDash val="solid"/>
-                      <a:round/>
-                      <a:headEnd type="none" w="med" len="med"/>
-                      <a:tailEnd type="none" w="med" len="med"/>
-                    </a:lnT>
-                    <a:lnB w="9525" cap="flat" cmpd="sng" algn="ctr">
-                      <a:solidFill>
-                        <a:schemeClr val="accent3"/>
-                      </a:solidFill>
-                      <a:prstDash val="solid"/>
-                      <a:round/>
-                      <a:headEnd type="none" w="med" len="med"/>
-                      <a:tailEnd type="none" w="med" len="med"/>
-                    </a:lnB>
-                    <a:solidFill>
-                      <a:schemeClr val="accent5"/>
-                    </a:solidFill>
-                  </a:tcPr>
-                </a:tc>
-                <a:tc>
-                  <a:txBody>
-                    <a:bodyPr/>
-                    <a:lstStyle/>
-                    <a:p>
-                      <a:pPr algn="r" indent="0" marL="0">
-                        <a:buNone/>
-                      </a:pPr>
-                      <a:r>
-                        <a:rPr lang="en-US" sz="1400" dirty="0">
-                          <a:solidFill>
-                            <a:schemeClr val="bg1"/>
-                          </a:solidFill>
-                        </a:rPr>
-                        <a:t>Rp3.000</a:t>
-                      </a:r>
-                      <a:endParaRPr lang="en-US" sz="1400" dirty="0"/>
-                    </a:p>
-                  </a:txBody>
-                  <a:tcPr marL="91440" marR="91440" marT="27432" marB="27432" anchor="ctr">
-                    <a:lnL w="9525" cap="flat" cmpd="sng" algn="ctr">
-                      <a:solidFill>
-                        <a:schemeClr val="accent3"/>
-                      </a:solidFill>
-                      <a:prstDash val="solid"/>
-                      <a:round/>
-                      <a:headEnd type="none" w="med" len="med"/>
-                      <a:tailEnd type="none" w="med" len="med"/>
-                    </a:lnL>
-                    <a:lnR w="9525" cap="flat" cmpd="sng" algn="ctr">
-                      <a:solidFill>
-                        <a:schemeClr val="accent3"/>
-                      </a:solidFill>
-                      <a:prstDash val="solid"/>
-                      <a:round/>
-                      <a:headEnd type="none" w="med" len="med"/>
-                      <a:tailEnd type="none" w="med" len="med"/>
-                    </a:lnR>
-                    <a:lnT w="9525" cap="flat" cmpd="sng" algn="ctr">
-                      <a:solidFill>
-                        <a:schemeClr val="accent3"/>
-                      </a:solidFill>
-                      <a:prstDash val="solid"/>
-                      <a:round/>
-                      <a:headEnd type="none" w="med" len="med"/>
-                      <a:tailEnd type="none" w="med" len="med"/>
-                    </a:lnT>
-                    <a:lnB w="9525" cap="flat" cmpd="sng" algn="ctr">
-                      <a:solidFill>
-                        <a:schemeClr val="accent3"/>
-                      </a:solidFill>
-                      <a:prstDash val="solid"/>
-                      <a:round/>
-                      <a:headEnd type="none" w="med" len="med"/>
-                      <a:tailEnd type="none" w="med" len="med"/>
-                    </a:lnB>
-                    <a:solidFill>
-                      <a:schemeClr val="accent5"/>
-                    </a:solidFill>
-                  </a:tcPr>
-                </a:tc>
-              </a:tr>
-              <a:tr h="310896">
-                <a:tc>
-                  <a:txBody>
-                    <a:bodyPr/>
-                    <a:lstStyle/>
-                    <a:p>
-                      <a:pPr algn="l" indent="0" marL="0">
-                        <a:buNone/>
-                      </a:pPr>
-                      <a:r>
-                        <a:rPr lang="en-US" sz="1400" dirty="0">
-                          <a:solidFill>
-                            <a:schemeClr val="bg1"/>
-                          </a:solidFill>
-                        </a:rPr>
-                        <a:t>Konektor JST PH2.0 6 pin + header (encoder motor)</a:t>
-                      </a:r>
-                      <a:endParaRPr lang="en-US" sz="1400" dirty="0"/>
-                    </a:p>
-                  </a:txBody>
-                  <a:tcPr marL="91440" marR="91440" marT="27432" marB="27432" anchor="ctr">
-                    <a:lnL w="9525" cap="flat" cmpd="sng" algn="ctr">
-                      <a:solidFill>
-                        <a:schemeClr val="accent3"/>
-                      </a:solidFill>
-                      <a:prstDash val="solid"/>
-                      <a:round/>
-                      <a:headEnd type="none" w="med" len="med"/>
-                      <a:tailEnd type="none" w="med" len="med"/>
-                    </a:lnL>
-                    <a:lnR w="9525" cap="flat" cmpd="sng" algn="ctr">
-                      <a:solidFill>
-                        <a:schemeClr val="accent3"/>
-                      </a:solidFill>
-                      <a:prstDash val="solid"/>
-                      <a:round/>
-                      <a:headEnd type="none" w="med" len="med"/>
-                      <a:tailEnd type="none" w="med" len="med"/>
-                    </a:lnR>
-                    <a:lnT w="9525" cap="flat" cmpd="sng" algn="ctr">
-                      <a:solidFill>
-                        <a:schemeClr val="accent3"/>
-                      </a:solidFill>
-                      <a:prstDash val="solid"/>
-                      <a:round/>
-                      <a:headEnd type="none" w="med" len="med"/>
-                      <a:tailEnd type="none" w="med" len="med"/>
-                    </a:lnT>
-                    <a:lnB w="9525" cap="flat" cmpd="sng" algn="ctr">
-                      <a:solidFill>
-                        <a:schemeClr val="accent3"/>
-                      </a:solidFill>
-                      <a:prstDash val="solid"/>
-                      <a:round/>
-                      <a:headEnd type="none" w="med" len="med"/>
-                      <a:tailEnd type="none" w="med" len="med"/>
-                    </a:lnB>
-                    <a:solidFill>
-                      <a:schemeClr val="tx1"/>
                     </a:solidFill>
                   </a:tcPr>
                 </a:tc>
@@ -12235,7 +12001,7 @@
                       <a:tailEnd type="none" w="med" len="med"/>
                     </a:lnB>
                     <a:solidFill>
-                      <a:schemeClr val="tx1"/>
+                      <a:schemeClr val="accent5"/>
                     </a:solidFill>
                   </a:tcPr>
                 </a:tc>
@@ -12296,7 +12062,7 @@
                       <a:tailEnd type="none" w="med" len="med"/>
                     </a:lnB>
                     <a:solidFill>
-                      <a:schemeClr val="tx1"/>
+                      <a:schemeClr val="accent5"/>
                     </a:solidFill>
                   </a:tcPr>
                 </a:tc>
@@ -12357,252 +12123,6 @@
                       <a:tailEnd type="none" w="med" len="med"/>
                     </a:lnB>
                     <a:solidFill>
-                      <a:schemeClr val="tx1"/>
-                    </a:solidFill>
-                  </a:tcPr>
-                </a:tc>
-              </a:tr>
-              <a:tr h="310896">
-                <a:tc>
-                  <a:txBody>
-                    <a:bodyPr/>
-                    <a:lstStyle/>
-                    <a:p>
-                      <a:pPr algn="l" indent="0" marL="0">
-                        <a:buNone/>
-                      </a:pPr>
-                      <a:r>
-                        <a:rPr lang="en-US" sz="1400" dirty="0">
-                          <a:solidFill>
-                            <a:schemeClr val="bg1"/>
-                          </a:solidFill>
-                        </a:rPr>
-                        <a:t>Komponen pendukung (header, socket, kapasitor, dioda)</a:t>
-                      </a:r>
-                      <a:endParaRPr lang="en-US" sz="1400" dirty="0"/>
-                    </a:p>
-                  </a:txBody>
-                  <a:tcPr marL="91440" marR="91440" marT="27432" marB="27432" anchor="ctr">
-                    <a:lnL w="9525" cap="flat" cmpd="sng" algn="ctr">
-                      <a:solidFill>
-                        <a:schemeClr val="accent3"/>
-                      </a:solidFill>
-                      <a:prstDash val="solid"/>
-                      <a:round/>
-                      <a:headEnd type="none" w="med" len="med"/>
-                      <a:tailEnd type="none" w="med" len="med"/>
-                    </a:lnL>
-                    <a:lnR w="9525" cap="flat" cmpd="sng" algn="ctr">
-                      <a:solidFill>
-                        <a:schemeClr val="accent3"/>
-                      </a:solidFill>
-                      <a:prstDash val="solid"/>
-                      <a:round/>
-                      <a:headEnd type="none" w="med" len="med"/>
-                      <a:tailEnd type="none" w="med" len="med"/>
-                    </a:lnR>
-                    <a:lnT w="9525" cap="flat" cmpd="sng" algn="ctr">
-                      <a:solidFill>
-                        <a:schemeClr val="accent3"/>
-                      </a:solidFill>
-                      <a:prstDash val="solid"/>
-                      <a:round/>
-                      <a:headEnd type="none" w="med" len="med"/>
-                      <a:tailEnd type="none" w="med" len="med"/>
-                    </a:lnT>
-                    <a:lnB w="9525" cap="flat" cmpd="sng" algn="ctr">
-                      <a:solidFill>
-                        <a:schemeClr val="accent3"/>
-                      </a:solidFill>
-                      <a:prstDash val="solid"/>
-                      <a:round/>
-                      <a:headEnd type="none" w="med" len="med"/>
-                      <a:tailEnd type="none" w="med" len="med"/>
-                    </a:lnB>
-                    <a:solidFill>
-                      <a:schemeClr val="accent5"/>
-                    </a:solidFill>
-                  </a:tcPr>
-                </a:tc>
-                <a:tc>
-                  <a:txBody>
-                    <a:bodyPr/>
-                    <a:lstStyle/>
-                    <a:p>
-                      <a:pPr algn="r" indent="0" marL="0">
-                        <a:buNone/>
-                      </a:pPr>
-                      <a:r>
-                        <a:rPr lang="en-US" sz="1400" dirty="0">
-                          <a:solidFill>
-                            <a:schemeClr val="bg1"/>
-                          </a:solidFill>
-                        </a:rPr>
-                        <a:t>Rp25.000</a:t>
-                      </a:r>
-                      <a:endParaRPr lang="en-US" sz="1400" dirty="0"/>
-                    </a:p>
-                  </a:txBody>
-                  <a:tcPr marL="91440" marR="91440" marT="27432" marB="27432" anchor="ctr">
-                    <a:lnL w="9525" cap="flat" cmpd="sng" algn="ctr">
-                      <a:solidFill>
-                        <a:schemeClr val="accent3"/>
-                      </a:solidFill>
-                      <a:prstDash val="solid"/>
-                      <a:round/>
-                      <a:headEnd type="none" w="med" len="med"/>
-                      <a:tailEnd type="none" w="med" len="med"/>
-                    </a:lnL>
-                    <a:lnR w="9525" cap="flat" cmpd="sng" algn="ctr">
-                      <a:solidFill>
-                        <a:schemeClr val="accent3"/>
-                      </a:solidFill>
-                      <a:prstDash val="solid"/>
-                      <a:round/>
-                      <a:headEnd type="none" w="med" len="med"/>
-                      <a:tailEnd type="none" w="med" len="med"/>
-                    </a:lnR>
-                    <a:lnT w="9525" cap="flat" cmpd="sng" algn="ctr">
-                      <a:solidFill>
-                        <a:schemeClr val="accent3"/>
-                      </a:solidFill>
-                      <a:prstDash val="solid"/>
-                      <a:round/>
-                      <a:headEnd type="none" w="med" len="med"/>
-                      <a:tailEnd type="none" w="med" len="med"/>
-                    </a:lnT>
-                    <a:lnB w="9525" cap="flat" cmpd="sng" algn="ctr">
-                      <a:solidFill>
-                        <a:schemeClr val="accent3"/>
-                      </a:solidFill>
-                      <a:prstDash val="solid"/>
-                      <a:round/>
-                      <a:headEnd type="none" w="med" len="med"/>
-                      <a:tailEnd type="none" w="med" len="med"/>
-                    </a:lnB>
-                    <a:solidFill>
-                      <a:schemeClr val="accent5"/>
-                    </a:solidFill>
-                  </a:tcPr>
-                </a:tc>
-                <a:tc>
-                  <a:txBody>
-                    <a:bodyPr/>
-                    <a:lstStyle/>
-                    <a:p>
-                      <a:pPr algn="r" indent="0" marL="0">
-                        <a:buNone/>
-                      </a:pPr>
-                      <a:r>
-                        <a:rPr lang="en-US" sz="1400" dirty="0">
-                          <a:solidFill>
-                            <a:schemeClr val="bg1"/>
-                          </a:solidFill>
-                        </a:rPr>
-                        <a:t>1 paket</a:t>
-                      </a:r>
-                      <a:endParaRPr lang="en-US" sz="1400" dirty="0"/>
-                    </a:p>
-                  </a:txBody>
-                  <a:tcPr marL="91440" marR="91440" marT="27432" marB="27432" anchor="ctr">
-                    <a:lnL w="9525" cap="flat" cmpd="sng" algn="ctr">
-                      <a:solidFill>
-                        <a:schemeClr val="accent3"/>
-                      </a:solidFill>
-                      <a:prstDash val="solid"/>
-                      <a:round/>
-                      <a:headEnd type="none" w="med" len="med"/>
-                      <a:tailEnd type="none" w="med" len="med"/>
-                    </a:lnL>
-                    <a:lnR w="9525" cap="flat" cmpd="sng" algn="ctr">
-                      <a:solidFill>
-                        <a:schemeClr val="accent3"/>
-                      </a:solidFill>
-                      <a:prstDash val="solid"/>
-                      <a:round/>
-                      <a:headEnd type="none" w="med" len="med"/>
-                      <a:tailEnd type="none" w="med" len="med"/>
-                    </a:lnR>
-                    <a:lnT w="9525" cap="flat" cmpd="sng" algn="ctr">
-                      <a:solidFill>
-                        <a:schemeClr val="accent3"/>
-                      </a:solidFill>
-                      <a:prstDash val="solid"/>
-                      <a:round/>
-                      <a:headEnd type="none" w="med" len="med"/>
-                      <a:tailEnd type="none" w="med" len="med"/>
-                    </a:lnT>
-                    <a:lnB w="9525" cap="flat" cmpd="sng" algn="ctr">
-                      <a:solidFill>
-                        <a:schemeClr val="accent3"/>
-                      </a:solidFill>
-                      <a:prstDash val="solid"/>
-                      <a:round/>
-                      <a:headEnd type="none" w="med" len="med"/>
-                      <a:tailEnd type="none" w="med" len="med"/>
-                    </a:lnB>
-                    <a:solidFill>
-                      <a:schemeClr val="accent5"/>
-                    </a:solidFill>
-                  </a:tcPr>
-                </a:tc>
-                <a:tc>
-                  <a:txBody>
-                    <a:bodyPr/>
-                    <a:lstStyle/>
-                    <a:p>
-                      <a:pPr algn="r" indent="0" marL="0">
-                        <a:buNone/>
-                      </a:pPr>
-                      <a:r>
-                        <a:rPr lang="en-US" sz="1400" dirty="0">
-                          <a:solidFill>
-                            <a:schemeClr val="bg1"/>
-                          </a:solidFill>
-                        </a:rPr>
-                        <a:t>Rp25.000</a:t>
-                      </a:r>
-                      <a:endParaRPr lang="en-US" sz="1400" dirty="0"/>
-                    </a:p>
-                  </a:txBody>
-                  <a:tcPr marL="91440" marR="91440" marT="27432" marB="27432" anchor="ctr">
-                    <a:lnL w="9525" cap="flat" cmpd="sng" algn="ctr">
-                      <a:solidFill>
-                        <a:schemeClr val="accent3"/>
-                      </a:solidFill>
-                      <a:prstDash val="solid"/>
-                      <a:round/>
-                      <a:headEnd type="none" w="med" len="med"/>
-                      <a:tailEnd type="none" w="med" len="med"/>
-                    </a:lnL>
-                    <a:lnR w="9525" cap="flat" cmpd="sng" algn="ctr">
-                      <a:solidFill>
-                        <a:schemeClr val="accent3"/>
-                      </a:solidFill>
-                      <a:prstDash val="solid"/>
-                      <a:round/>
-                      <a:headEnd type="none" w="med" len="med"/>
-                      <a:tailEnd type="none" w="med" len="med"/>
-                    </a:lnR>
-                    <a:lnT w="9525" cap="flat" cmpd="sng" algn="ctr">
-                      <a:solidFill>
-                        <a:schemeClr val="accent3"/>
-                      </a:solidFill>
-                      <a:prstDash val="solid"/>
-                      <a:round/>
-                      <a:headEnd type="none" w="med" len="med"/>
-                      <a:tailEnd type="none" w="med" len="med"/>
-                    </a:lnT>
-                    <a:lnB w="9525" cap="flat" cmpd="sng" algn="ctr">
-                      <a:solidFill>
-                        <a:schemeClr val="accent3"/>
-                      </a:solidFill>
-                      <a:prstDash val="solid"/>
-                      <a:round/>
-                      <a:headEnd type="none" w="med" len="med"/>
-                      <a:tailEnd type="none" w="med" len="med"/>
-                    </a:lnB>
-                    <a:solidFill>
                       <a:schemeClr val="accent5"/>
                     </a:solidFill>
                   </a:tcPr>
@@ -12623,7 +12143,7 @@
                             <a:schemeClr val="bg1"/>
                           </a:solidFill>
                         </a:rPr>
-                        <a:t>Konektor JST XH 8 pin + kabel (perkiraan)</a:t>
+                        <a:t>Konektor JST XH 8 pin + kabel</a:t>
                       </a:r>
                       <a:endParaRPr lang="en-US" sz="1400" dirty="0"/>
                     </a:p>
@@ -13110,6 +12630,252 @@
                         <a:buNone/>
                       </a:pPr>
                       <a:r>
+                        <a:rPr lang="en-US" sz="1400" dirty="0">
+                          <a:solidFill>
+                            <a:schemeClr val="bg1"/>
+                          </a:solidFill>
+                        </a:rPr>
+                        <a:t>Komponen pendukung (header, socket, C, dioda, resistor)</a:t>
+                      </a:r>
+                      <a:endParaRPr lang="en-US" sz="1400" dirty="0"/>
+                    </a:p>
+                  </a:txBody>
+                  <a:tcPr marL="91440" marR="91440" marT="27432" marB="27432" anchor="ctr">
+                    <a:lnL w="9525" cap="flat" cmpd="sng" algn="ctr">
+                      <a:solidFill>
+                        <a:schemeClr val="accent3"/>
+                      </a:solidFill>
+                      <a:prstDash val="solid"/>
+                      <a:round/>
+                      <a:headEnd type="none" w="med" len="med"/>
+                      <a:tailEnd type="none" w="med" len="med"/>
+                    </a:lnL>
+                    <a:lnR w="9525" cap="flat" cmpd="sng" algn="ctr">
+                      <a:solidFill>
+                        <a:schemeClr val="accent3"/>
+                      </a:solidFill>
+                      <a:prstDash val="solid"/>
+                      <a:round/>
+                      <a:headEnd type="none" w="med" len="med"/>
+                      <a:tailEnd type="none" w="med" len="med"/>
+                    </a:lnR>
+                    <a:lnT w="9525" cap="flat" cmpd="sng" algn="ctr">
+                      <a:solidFill>
+                        <a:schemeClr val="accent3"/>
+                      </a:solidFill>
+                      <a:prstDash val="solid"/>
+                      <a:round/>
+                      <a:headEnd type="none" w="med" len="med"/>
+                      <a:tailEnd type="none" w="med" len="med"/>
+                    </a:lnT>
+                    <a:lnB w="9525" cap="flat" cmpd="sng" algn="ctr">
+                      <a:solidFill>
+                        <a:schemeClr val="accent3"/>
+                      </a:solidFill>
+                      <a:prstDash val="solid"/>
+                      <a:round/>
+                      <a:headEnd type="none" w="med" len="med"/>
+                      <a:tailEnd type="none" w="med" len="med"/>
+                    </a:lnB>
+                    <a:solidFill>
+                      <a:schemeClr val="tx1"/>
+                    </a:solidFill>
+                  </a:tcPr>
+                </a:tc>
+                <a:tc>
+                  <a:txBody>
+                    <a:bodyPr/>
+                    <a:lstStyle/>
+                    <a:p>
+                      <a:pPr algn="r" indent="0" marL="0">
+                        <a:buNone/>
+                      </a:pPr>
+                      <a:r>
+                        <a:rPr lang="en-US" sz="1400" dirty="0">
+                          <a:solidFill>
+                            <a:schemeClr val="bg1"/>
+                          </a:solidFill>
+                        </a:rPr>
+                        <a:t>Rp25.000</a:t>
+                      </a:r>
+                      <a:endParaRPr lang="en-US" sz="1400" dirty="0"/>
+                    </a:p>
+                  </a:txBody>
+                  <a:tcPr marL="91440" marR="91440" marT="27432" marB="27432" anchor="ctr">
+                    <a:lnL w="9525" cap="flat" cmpd="sng" algn="ctr">
+                      <a:solidFill>
+                        <a:schemeClr val="accent3"/>
+                      </a:solidFill>
+                      <a:prstDash val="solid"/>
+                      <a:round/>
+                      <a:headEnd type="none" w="med" len="med"/>
+                      <a:tailEnd type="none" w="med" len="med"/>
+                    </a:lnL>
+                    <a:lnR w="9525" cap="flat" cmpd="sng" algn="ctr">
+                      <a:solidFill>
+                        <a:schemeClr val="accent3"/>
+                      </a:solidFill>
+                      <a:prstDash val="solid"/>
+                      <a:round/>
+                      <a:headEnd type="none" w="med" len="med"/>
+                      <a:tailEnd type="none" w="med" len="med"/>
+                    </a:lnR>
+                    <a:lnT w="9525" cap="flat" cmpd="sng" algn="ctr">
+                      <a:solidFill>
+                        <a:schemeClr val="accent3"/>
+                      </a:solidFill>
+                      <a:prstDash val="solid"/>
+                      <a:round/>
+                      <a:headEnd type="none" w="med" len="med"/>
+                      <a:tailEnd type="none" w="med" len="med"/>
+                    </a:lnT>
+                    <a:lnB w="9525" cap="flat" cmpd="sng" algn="ctr">
+                      <a:solidFill>
+                        <a:schemeClr val="accent3"/>
+                      </a:solidFill>
+                      <a:prstDash val="solid"/>
+                      <a:round/>
+                      <a:headEnd type="none" w="med" len="med"/>
+                      <a:tailEnd type="none" w="med" len="med"/>
+                    </a:lnB>
+                    <a:solidFill>
+                      <a:schemeClr val="tx1"/>
+                    </a:solidFill>
+                  </a:tcPr>
+                </a:tc>
+                <a:tc>
+                  <a:txBody>
+                    <a:bodyPr/>
+                    <a:lstStyle/>
+                    <a:p>
+                      <a:pPr algn="r" indent="0" marL="0">
+                        <a:buNone/>
+                      </a:pPr>
+                      <a:r>
+                        <a:rPr lang="en-US" sz="1400" dirty="0">
+                          <a:solidFill>
+                            <a:schemeClr val="bg1"/>
+                          </a:solidFill>
+                        </a:rPr>
+                        <a:t>1 paket</a:t>
+                      </a:r>
+                      <a:endParaRPr lang="en-US" sz="1400" dirty="0"/>
+                    </a:p>
+                  </a:txBody>
+                  <a:tcPr marL="91440" marR="91440" marT="27432" marB="27432" anchor="ctr">
+                    <a:lnL w="9525" cap="flat" cmpd="sng" algn="ctr">
+                      <a:solidFill>
+                        <a:schemeClr val="accent3"/>
+                      </a:solidFill>
+                      <a:prstDash val="solid"/>
+                      <a:round/>
+                      <a:headEnd type="none" w="med" len="med"/>
+                      <a:tailEnd type="none" w="med" len="med"/>
+                    </a:lnL>
+                    <a:lnR w="9525" cap="flat" cmpd="sng" algn="ctr">
+                      <a:solidFill>
+                        <a:schemeClr val="accent3"/>
+                      </a:solidFill>
+                      <a:prstDash val="solid"/>
+                      <a:round/>
+                      <a:headEnd type="none" w="med" len="med"/>
+                      <a:tailEnd type="none" w="med" len="med"/>
+                    </a:lnR>
+                    <a:lnT w="9525" cap="flat" cmpd="sng" algn="ctr">
+                      <a:solidFill>
+                        <a:schemeClr val="accent3"/>
+                      </a:solidFill>
+                      <a:prstDash val="solid"/>
+                      <a:round/>
+                      <a:headEnd type="none" w="med" len="med"/>
+                      <a:tailEnd type="none" w="med" len="med"/>
+                    </a:lnT>
+                    <a:lnB w="9525" cap="flat" cmpd="sng" algn="ctr">
+                      <a:solidFill>
+                        <a:schemeClr val="accent3"/>
+                      </a:solidFill>
+                      <a:prstDash val="solid"/>
+                      <a:round/>
+                      <a:headEnd type="none" w="med" len="med"/>
+                      <a:tailEnd type="none" w="med" len="med"/>
+                    </a:lnB>
+                    <a:solidFill>
+                      <a:schemeClr val="tx1"/>
+                    </a:solidFill>
+                  </a:tcPr>
+                </a:tc>
+                <a:tc>
+                  <a:txBody>
+                    <a:bodyPr/>
+                    <a:lstStyle/>
+                    <a:p>
+                      <a:pPr algn="r" indent="0" marL="0">
+                        <a:buNone/>
+                      </a:pPr>
+                      <a:r>
+                        <a:rPr lang="en-US" sz="1400" dirty="0">
+                          <a:solidFill>
+                            <a:schemeClr val="bg1"/>
+                          </a:solidFill>
+                        </a:rPr>
+                        <a:t>Rp25.000</a:t>
+                      </a:r>
+                      <a:endParaRPr lang="en-US" sz="1400" dirty="0"/>
+                    </a:p>
+                  </a:txBody>
+                  <a:tcPr marL="91440" marR="91440" marT="27432" marB="27432" anchor="ctr">
+                    <a:lnL w="9525" cap="flat" cmpd="sng" algn="ctr">
+                      <a:solidFill>
+                        <a:schemeClr val="accent3"/>
+                      </a:solidFill>
+                      <a:prstDash val="solid"/>
+                      <a:round/>
+                      <a:headEnd type="none" w="med" len="med"/>
+                      <a:tailEnd type="none" w="med" len="med"/>
+                    </a:lnL>
+                    <a:lnR w="9525" cap="flat" cmpd="sng" algn="ctr">
+                      <a:solidFill>
+                        <a:schemeClr val="accent3"/>
+                      </a:solidFill>
+                      <a:prstDash val="solid"/>
+                      <a:round/>
+                      <a:headEnd type="none" w="med" len="med"/>
+                      <a:tailEnd type="none" w="med" len="med"/>
+                    </a:lnR>
+                    <a:lnT w="9525" cap="flat" cmpd="sng" algn="ctr">
+                      <a:solidFill>
+                        <a:schemeClr val="accent3"/>
+                      </a:solidFill>
+                      <a:prstDash val="solid"/>
+                      <a:round/>
+                      <a:headEnd type="none" w="med" len="med"/>
+                      <a:tailEnd type="none" w="med" len="med"/>
+                    </a:lnT>
+                    <a:lnB w="9525" cap="flat" cmpd="sng" algn="ctr">
+                      <a:solidFill>
+                        <a:schemeClr val="accent3"/>
+                      </a:solidFill>
+                      <a:prstDash val="solid"/>
+                      <a:round/>
+                      <a:headEnd type="none" w="med" len="med"/>
+                      <a:tailEnd type="none" w="med" len="med"/>
+                    </a:lnB>
+                    <a:solidFill>
+                      <a:schemeClr val="tx1"/>
+                    </a:solidFill>
+                  </a:tcPr>
+                </a:tc>
+              </a:tr>
+              <a:tr h="310896">
+                <a:tc>
+                  <a:txBody>
+                    <a:bodyPr/>
+                    <a:lstStyle/>
+                    <a:p>
+                      <a:pPr algn="l" indent="0" marL="0">
+                        <a:buNone/>
+                      </a:pPr>
+                      <a:r>
                         <a:rPr lang="en-US" sz="1400" b="1" dirty="0">
                           <a:solidFill>
                             <a:schemeClr val="bg1"/>
@@ -13282,7 +13048,7 @@
                             <a:schemeClr val="bg1"/>
                           </a:solidFill>
                         </a:rPr>
-                        <a:t>Rp832.000</a:t>
+                        <a:t>Rp862.390</a:t>
                       </a:r>
                       <a:endParaRPr lang="en-US" sz="1400" dirty="0"/>
                     </a:p>
@@ -13932,7 +13698,7 @@
                             <a:schemeClr val="bg1"/>
                           </a:solidFill>
                         </a:rPr>
-                        <a:t>Bracket motor N20</a:t>
+                        <a:t>Ball caster</a:t>
                       </a:r>
                       <a:endParaRPr lang="en-US" sz="1400" dirty="0"/>
                     </a:p>
@@ -14054,7 +13820,7 @@
                             <a:schemeClr val="bg1"/>
                           </a:solidFill>
                         </a:rPr>
-                        <a:t>1 pasang</a:t>
+                        <a:t>1 pcs</a:t>
                       </a:r>
                       <a:endParaRPr lang="en-US" sz="1400" dirty="0"/>
                     </a:p>
@@ -14178,7 +13944,7 @@
                             <a:schemeClr val="bg1"/>
                           </a:solidFill>
                         </a:rPr>
-                        <a:t>Skid nilon (baut, spacer, mur nilon)</a:t>
+                        <a:t>Baut, mur, spacer</a:t>
                       </a:r>
                       <a:endParaRPr lang="en-US" sz="1400" dirty="0"/>
                     </a:p>
@@ -14239,7 +14005,7 @@
                             <a:schemeClr val="bg1"/>
                           </a:solidFill>
                         </a:rPr>
-                        <a:t>Rp5.000</a:t>
+                        <a:t>Rp15.000</a:t>
                       </a:r>
                       <a:endParaRPr lang="en-US" sz="1400" dirty="0"/>
                     </a:p>
@@ -14361,7 +14127,7 @@
                             <a:schemeClr val="bg1"/>
                           </a:solidFill>
                         </a:rPr>
-                        <a:t>Rp5.000</a:t>
+                        <a:t>Rp15.000</a:t>
                       </a:r>
                       <a:endParaRPr lang="en-US" sz="1400" dirty="0"/>
                     </a:p>
@@ -14424,7 +14190,7 @@
                             <a:schemeClr val="bg1"/>
                           </a:solidFill>
                         </a:rPr>
-                        <a:t>Baut, mur, spacer</a:t>
+                        <a:t>Timah solder + flux (lain-lain)</a:t>
                       </a:r>
                       <a:endParaRPr lang="en-US" sz="1400" dirty="0"/>
                     </a:p>
@@ -14485,7 +14251,7 @@
                             <a:schemeClr val="bg1"/>
                           </a:solidFill>
                         </a:rPr>
-                        <a:t>Rp15.000</a:t>
+                        <a:t>Rp25.000</a:t>
                       </a:r>
                       <a:endParaRPr lang="en-US" sz="1400" dirty="0"/>
                     </a:p>
@@ -14607,7 +14373,7 @@
                             <a:schemeClr val="bg1"/>
                           </a:solidFill>
                         </a:rPr>
-                        <a:t>Rp15.000</a:t>
+                        <a:t>Rp25.000</a:t>
                       </a:r>
                       <a:endParaRPr lang="en-US" sz="1400" dirty="0"/>
                     </a:p>
@@ -14670,7 +14436,7 @@
                             <a:schemeClr val="bg1"/>
                           </a:solidFill>
                         </a:rPr>
-                        <a:t>Total mekanik</a:t>
+                        <a:t>Total mekanik + lain-lain</a:t>
                       </a:r>
                       <a:endParaRPr lang="en-US" sz="1400" dirty="0"/>
                     </a:p>
@@ -14837,7 +14603,7 @@
                             <a:schemeClr val="bg1"/>
                           </a:solidFill>
                         </a:rPr>
-                        <a:t>Rp55.000</a:t>
+                        <a:t>Rp75.000</a:t>
                       </a:r>
                       <a:endParaRPr lang="en-US" sz="1400" dirty="0"/>
                     </a:p>
@@ -14956,7 +14722,7 @@
                   <a:schemeClr val="accent2"/>
                 </a:solidFill>
               </a:rPr>
-              <a:t>Rp832.000</a:t>
+              <a:t>Rp862.390</a:t>
             </a:r>
             <a:endParaRPr lang="en-US" sz="1400" dirty="0"/>
           </a:p>
@@ -15015,7 +14781,7 @@
                   <a:schemeClr val="bg1"/>
                 </a:solidFill>
               </a:rPr>
-              <a:t>Mekanik</a:t>
+              <a:t>Mekanik + lain-lain</a:t>
             </a:r>
             <a:endParaRPr lang="en-US" sz="1400" dirty="0"/>
           </a:p>
@@ -15029,7 +14795,7 @@
                   <a:schemeClr val="accent2"/>
                 </a:solidFill>
               </a:rPr>
-              <a:t>Rp55.000</a:t>
+              <a:t>Rp75.000</a:t>
             </a:r>
             <a:endParaRPr lang="en-US" sz="1400" dirty="0"/>
           </a:p>
@@ -15102,7 +14868,7 @@
                   <a:schemeClr val="bg1"/>
                 </a:solidFill>
               </a:rPr>
-              <a:t>Rp887.000</a:t>
+              <a:t>Rp937.390</a:t>
             </a:r>
             <a:endParaRPr lang="en-US" sz="1400" dirty="0"/>
           </a:p>
@@ -16262,7 +16028,7 @@
                   <a:schemeClr val="accent2"/>
                 </a:solidFill>
               </a:rPr>
-              <a:t>Rp887.000</a:t>
+              <a:t>Rp937.390</a:t>
             </a:r>
             <a:endParaRPr lang="en-US" sz="3600" dirty="0"/>
           </a:p>
@@ -16276,7 +16042,7 @@
                   <a:schemeClr val="bg1"/>
                 </a:solidFill>
               </a:rPr>
-              <a:t>± 44% harga kit pembanding</a:t>
+              <a:t>± 47% harga kit pembanding</a:t>
             </a:r>
             <a:endParaRPr lang="en-US" sz="3600" dirty="0"/>
           </a:p>
@@ -17084,7 +16850,7 @@
                             <a:schemeClr val="bg1"/>
                           </a:solidFill>
                         </a:rPr>
-                        <a:t>Rp887.000</a:t>
+                        <a:t>Rp937.390</a:t>
                       </a:r>
                       <a:endParaRPr lang="en-US" sz="1400" dirty="0"/>
                     </a:p>
@@ -17145,7 +16911,7 @@
                             <a:schemeClr val="accent2"/>
                           </a:solidFill>
                         </a:rPr>
-                        <a:t>56% lebih murah</a:t>
+                        <a:t>53% lebih murah</a:t>
                       </a:r>
                       <a:endParaRPr lang="en-US" sz="1400" dirty="0"/>
                     </a:p>

</xml_diff>